<commit_message>
Add Papalexi target-held-out validation
</commit_message>
<xml_diff>
--- a/deliverables/FusionVI-X_Final_Project_Presentation.pptx
+++ b/deliverables/FusionVI-X_Final_Project_Presentation.pptx
@@ -2,22 +2,22 @@
 <file path=ppt/presentation.xml><?xml version="1.0" encoding="utf-8"?>
 <p:presentation xmlns:p="http://schemas.openxmlformats.org/presentationml/2006/main">
   <p:sldMasterIdLst>
-    <p:sldMasterId xmlns:r="http://schemas.openxmlformats.org/officeDocument/2006/relationships" id="2147483648" r:id="R9ee676b4107844fb"/>
+    <p:sldMasterId xmlns:r="http://schemas.openxmlformats.org/officeDocument/2006/relationships" id="2147483648" r:id="R01cc322bb1b04516"/>
   </p:sldMasterIdLst>
   <p:notesMasterIdLst>
-    <p:notesMasterId xmlns:r="http://schemas.openxmlformats.org/officeDocument/2006/relationships" r:id="Rd7e944e21a9549a4"/>
+    <p:notesMasterId xmlns:r="http://schemas.openxmlformats.org/officeDocument/2006/relationships" r:id="R446a9f3e89eb4ee6"/>
   </p:notesMasterIdLst>
   <p:sldIdLst>
-    <p:sldId xmlns:r="http://schemas.openxmlformats.org/officeDocument/2006/relationships" id="256" r:id="Rfb2c5a59251f47dc"/>
-    <p:sldId xmlns:r="http://schemas.openxmlformats.org/officeDocument/2006/relationships" id="257" r:id="Rade8242d0358446f"/>
-    <p:sldId xmlns:r="http://schemas.openxmlformats.org/officeDocument/2006/relationships" id="258" r:id="R115ef70efcfc4e4b"/>
-    <p:sldId xmlns:r="http://schemas.openxmlformats.org/officeDocument/2006/relationships" id="259" r:id="R9ed9400c03bd4df4"/>
-    <p:sldId xmlns:r="http://schemas.openxmlformats.org/officeDocument/2006/relationships" id="260" r:id="R4aa5b32aea744265"/>
-    <p:sldId xmlns:r="http://schemas.openxmlformats.org/officeDocument/2006/relationships" id="261" r:id="R67e6c416ffaa4045"/>
-    <p:sldId xmlns:r="http://schemas.openxmlformats.org/officeDocument/2006/relationships" id="262" r:id="Rd6f7d54dbc974750"/>
-    <p:sldId xmlns:r="http://schemas.openxmlformats.org/officeDocument/2006/relationships" id="263" r:id="R088a2ea2454f46fe"/>
-    <p:sldId xmlns:r="http://schemas.openxmlformats.org/officeDocument/2006/relationships" id="264" r:id="R34585a06c6974d7d"/>
-    <p:sldId xmlns:r="http://schemas.openxmlformats.org/officeDocument/2006/relationships" id="265" r:id="R51d6e686791845e7"/>
+    <p:sldId xmlns:r="http://schemas.openxmlformats.org/officeDocument/2006/relationships" id="256" r:id="Rba36275a665346ee"/>
+    <p:sldId xmlns:r="http://schemas.openxmlformats.org/officeDocument/2006/relationships" id="257" r:id="Ra12f90cf82af4f97"/>
+    <p:sldId xmlns:r="http://schemas.openxmlformats.org/officeDocument/2006/relationships" id="258" r:id="Rf02f80df7a2e46d8"/>
+    <p:sldId xmlns:r="http://schemas.openxmlformats.org/officeDocument/2006/relationships" id="259" r:id="R5262931b3eff4526"/>
+    <p:sldId xmlns:r="http://schemas.openxmlformats.org/officeDocument/2006/relationships" id="260" r:id="Rc35715fa022b47a8"/>
+    <p:sldId xmlns:r="http://schemas.openxmlformats.org/officeDocument/2006/relationships" id="261" r:id="Rf230001ba6b640a6"/>
+    <p:sldId xmlns:r="http://schemas.openxmlformats.org/officeDocument/2006/relationships" id="262" r:id="R411373851eac45d7"/>
+    <p:sldId xmlns:r="http://schemas.openxmlformats.org/officeDocument/2006/relationships" id="263" r:id="R88685954afca4a54"/>
+    <p:sldId xmlns:r="http://schemas.openxmlformats.org/officeDocument/2006/relationships" id="264" r:id="Rc47c74b147f646c7"/>
+    <p:sldId xmlns:r="http://schemas.openxmlformats.org/officeDocument/2006/relationships" id="265" r:id="Rcf684dfd27dd4d20"/>
   </p:sldIdLst>
   <p:sldSz cx="12192000" cy="6858000"/>
   <p:notesSz cx="6858000" cy="9144000"/>
@@ -451,7 +451,7 @@
           <a:lstStyle xmlns:a="http://schemas.openxmlformats.org/drawingml/2006/main"/>
           <a:p xmlns:a="http://schemas.openxmlformats.org/drawingml/2006/main">
             <a:r>
-              <a:t>Opening question: Can a model recover an activation surface phenotype when marker RNA points in a different direction? FusionVI-X hides the target marker, learns from nine donors and evaluates the untouched tenth donor. Presentation timing: about 35 seconds.</a:t>
+              <a:t>Opening question: Can a model recover a surface biomarker when marker RNA points in a different direction? We test unseen donors in primary PBMCs and unseen CRISPR targets in a separate PD-L1 screen. Timing: 30 seconds.</a:t>
             </a:r>
           </a:p>
         </p:txBody>
@@ -521,7 +521,7 @@
           <a:lstStyle xmlns:a="http://schemas.openxmlformats.org/drawingml/2006/main"/>
           <a:p xmlns:a="http://schemas.openxmlformats.org/drawingml/2006/main">
             <a:r>
-              <a:t>The conclusion is now positive and specific. The scalar gate alone was insufficient, but the donor-nested targeted cross-modal head improved all global markers and strongly rescued discordant HLA-DR. The biological implication is that neighbouring surface proteins preserve activation context when RNA is misleading. Timing: 45 seconds, leaving about three minutes for questions.</a:t>
+              <a:t>The same principle now holds in two datasets: unseen donors and unseen perturbations. Targeted cross-modal context improves surface biomarker recovery, while CMTM6 defines a biologically important failure. This is the conclusion. Timing: 40 seconds, leaving about three minutes for questions.</a:t>
             </a:r>
           </a:p>
         </p:txBody>
@@ -801,7 +801,7 @@
           <a:lstStyle xmlns:a="http://schemas.openxmlformats.org/drawingml/2006/main"/>
           <a:p xmlns:a="http://schemas.openxmlformats.org/drawingml/2006/main">
             <a:r>
-              <a:t>This evaluation addresses circularity and model-selection leakage. The three activation proteins are hidden from all inputs. The readout family is chosen only among training donors, then evaluated once on the outer held-out donor. The harder subset contains cells where transcript and protein ranks differ by at least 50 percentile points. Timing: 55 seconds.</a:t>
+              <a:t>This evaluation prevents target leakage. The surface marker is hidden from all inputs. Readout selection happens only within training donors or training CRISPR targets. Experiment 1 reports one value per donor. Experiment 2 reports perturbation effects relative to held-out non-targeting cells in each replicate. Timing: 45 seconds.</a:t>
             </a:r>
           </a:p>
         </p:txBody>
@@ -871,7 +871,7 @@
           <a:lstStyle xmlns:a="http://schemas.openxmlformats.org/drawingml/2006/main"/>
           <a:p xmlns:a="http://schemas.openxmlformats.org/drawingml/2006/main">
             <a:r>
-              <a:t>The direct T-cell and monocyte contrasts are perfect for both models. NK and B responses are also close to perfect. Even RNA PCA performs at ceiling. This endpoint confirms that the models learned biology, but it cannot discriminate FusionVI from totalVI. Results generated by this project. Timing: 45 seconds.</a:t>
+              <a:t>Experiment 2 uses the Papalexi ECCITE-seq screen. PD-L1 is hidden from model input. Five folds each hold out all cells from five CRISPR targets, while non-targeting controls are partitioned within replicate. This tests mechanism-level transfer in an immune-checkpoint setting. Timing: 45 seconds.</a:t>
             </a:r>
           </a:p>
         </p:txBody>
@@ -1081,7 +1081,7 @@
           <a:lstStyle xmlns:a="http://schemas.openxmlformats.org/drawingml/2006/main"/>
           <a:p xmlns:a="http://schemas.openxmlformats.org/drawingml/2006/main">
             <a:r>
-              <a:t>The gate did not collapse. It used more protein under anti-CD3/CD28 and in CD69-discordant cells. But the unsupervised ELBO did not translate that behavior into marker recovery. The positive cross-modal head shows what was missing: direct training pressure on the pharmacodynamic endpoint, selected without looking at the held-out donor. Timing: 45 seconds.</a:t>
+              <a:t>External validation is positive. FusionVI-X ranks 75 unseen target-by-replicate PD-L1 effects with Spearman 0.879 and gets 84 percent of directions correct. CD274 RNA alone reaches 0.587 and 64 percent. The model recovers JAK-STAT and CUL3-BRD4 biology but fails on CMTM6, a known post-transcriptional stabilizer. Timing: 55 seconds.</a:t>
             </a:r>
           </a:p>
         </p:txBody>
@@ -1149,7 +1149,7 @@
   </p:cSld>
   <p:clrMap bg1="lt1" tx1="dk1" bg2="lt2" tx2="dk2" accent1="accent1" accent2="accent2" accent3="accent3" accent4="accent4" accent5="accent5" accent6="accent6" hlink="hlink" folHlink="folHlink"/>
   <p:sldLayoutIdLst>
-    <p:sldLayoutId xmlns:r="http://schemas.openxmlformats.org/officeDocument/2006/relationships" id="2147483649" r:id="Rcd0f1a0533084a8d"/>
+    <p:sldLayoutId xmlns:r="http://schemas.openxmlformats.org/officeDocument/2006/relationships" id="2147483649" r:id="Rb64d322ce5f04abc"/>
   </p:sldLayoutIdLst>
   <p:txStyles>
     <p:titleStyle>
@@ -1700,7 +1700,7 @@
           <p:cNvPr id="14" name="">
             <a:extLst xmlns:a="http://schemas.openxmlformats.org/drawingml/2006/main">
               <a:ext uri="{FF2B5EF4-FFF2-40B4-BE49-F238E27FC236}">
-                <a16:creationId xmlns:a16="http://schemas.microsoft.com/office/drawing/2014/main" id="{7C765AAA-A0DB-4FEC-9E62-95528EBAE1D2}"/>
+                <a16:creationId xmlns:a16="http://schemas.microsoft.com/office/drawing/2014/main" id="{A5C77C96-68BE-4059-9EEF-41DC8C3F14B3}"/>
               </a:ext>
             </a:extLst>
           </p:cNvPr>
@@ -1730,7 +1730,7 @@
           <p:cNvPr id="2" name="">
             <a:extLst xmlns:a="http://schemas.openxmlformats.org/drawingml/2006/main">
               <a:ext uri="{FF2B5EF4-FFF2-40B4-BE49-F238E27FC236}">
-                <a16:creationId xmlns:a16="http://schemas.microsoft.com/office/drawing/2014/main" id="{15B8E58F-FDA2-43B4-BE3E-D78BE9B735A7}"/>
+                <a16:creationId xmlns:a16="http://schemas.microsoft.com/office/drawing/2014/main" id="{2A67BC02-7F00-4F87-893D-13149D300F5E}"/>
               </a:ext>
             </a:extLst>
           </p:cNvPr>
@@ -1760,7 +1760,7 @@
           <p:cNvPr id="3" name="">
             <a:extLst xmlns:a="http://schemas.openxmlformats.org/drawingml/2006/main">
               <a:ext uri="{FF2B5EF4-FFF2-40B4-BE49-F238E27FC236}">
-                <a16:creationId xmlns:a16="http://schemas.microsoft.com/office/drawing/2014/main" id="{1D6A71BE-AAAF-4B8B-9243-07D18B8A2AF1}"/>
+                <a16:creationId xmlns:a16="http://schemas.microsoft.com/office/drawing/2014/main" id="{5B7D7A46-2168-42AB-B7DE-A3AAB69F26C7}"/>
               </a:ext>
             </a:extLst>
           </p:cNvPr>
@@ -1821,7 +1821,7 @@
           <p:cNvPr id="4" name="">
             <a:extLst xmlns:a="http://schemas.openxmlformats.org/drawingml/2006/main">
               <a:ext uri="{FF2B5EF4-FFF2-40B4-BE49-F238E27FC236}">
-                <a16:creationId xmlns:a16="http://schemas.microsoft.com/office/drawing/2014/main" id="{B4EB0615-DF47-4E92-8841-6DC2AD763488}"/>
+                <a16:creationId xmlns:a16="http://schemas.microsoft.com/office/drawing/2014/main" id="{73CBC493-11FE-4D04-9286-392D950C711A}"/>
               </a:ext>
             </a:extLst>
           </p:cNvPr>
@@ -1909,7 +1909,7 @@
           <p:cNvPr id="5" name="">
             <a:extLst xmlns:a="http://schemas.openxmlformats.org/drawingml/2006/main">
               <a:ext uri="{FF2B5EF4-FFF2-40B4-BE49-F238E27FC236}">
-                <a16:creationId xmlns:a16="http://schemas.microsoft.com/office/drawing/2014/main" id="{8978AF13-6765-4BEE-B1F7-ACC0630BED96}"/>
+                <a16:creationId xmlns:a16="http://schemas.microsoft.com/office/drawing/2014/main" id="{41A48231-6812-4AB5-9C7C-A4B081094742}"/>
               </a:ext>
             </a:extLst>
           </p:cNvPr>
@@ -1960,7 +1960,7 @@
                 <a:ea typeface="Arial"/>
                 <a:cs typeface="Arial"/>
               </a:rPr>
-              <a:t>Targeted cross-modal recovery of pharmacodynamic surface markers in unseen donors</a:t>
+              <a:t>Cross-modal recovery of surface biomarkers in unseen donors and unseen perturbations</a:t>
             </a:r>
           </a:p>
         </p:txBody>
@@ -1970,7 +1970,7 @@
           <p:cNvPr id="6" name="">
             <a:extLst xmlns:a="http://schemas.openxmlformats.org/drawingml/2006/main">
               <a:ext uri="{FF2B5EF4-FFF2-40B4-BE49-F238E27FC236}">
-                <a16:creationId xmlns:a16="http://schemas.microsoft.com/office/drawing/2014/main" id="{F83B8047-86A1-4682-A16E-47A04FE0C112}"/>
+                <a16:creationId xmlns:a16="http://schemas.microsoft.com/office/drawing/2014/main" id="{72774835-8876-41F1-8F3A-FBEC0303D032}"/>
               </a:ext>
             </a:extLst>
           </p:cNvPr>
@@ -2002,7 +2002,7 @@
           <p:cNvPr id="7" name="">
             <a:extLst xmlns:a="http://schemas.openxmlformats.org/drawingml/2006/main">
               <a:ext uri="{FF2B5EF4-FFF2-40B4-BE49-F238E27FC236}">
-                <a16:creationId xmlns:a16="http://schemas.microsoft.com/office/drawing/2014/main" id="{572148EC-C839-41DE-B0FE-B97A45ACAA9E}"/>
+                <a16:creationId xmlns:a16="http://schemas.microsoft.com/office/drawing/2014/main" id="{5A6AC957-B97F-4999-B64E-3971AD9353EC}"/>
               </a:ext>
             </a:extLst>
           </p:cNvPr>
@@ -2053,7 +2053,7 @@
                 <a:ea typeface="Arial"/>
                 <a:cs typeface="Arial"/>
               </a:rPr>
-              <a:t>10 donors</a:t>
+              <a:t>2 datasets</a:t>
             </a:r>
           </a:p>
         </p:txBody>
@@ -2063,7 +2063,7 @@
           <p:cNvPr id="8" name="">
             <a:extLst xmlns:a="http://schemas.openxmlformats.org/drawingml/2006/main">
               <a:ext uri="{FF2B5EF4-FFF2-40B4-BE49-F238E27FC236}">
-                <a16:creationId xmlns:a16="http://schemas.microsoft.com/office/drawing/2014/main" id="{7A5F6301-8554-40BA-96F2-E8A8FDCB2463}"/>
+                <a16:creationId xmlns:a16="http://schemas.microsoft.com/office/drawing/2014/main" id="{90610D21-9297-4B5F-9E4A-3C3D09F0B907}"/>
               </a:ext>
             </a:extLst>
           </p:cNvPr>
@@ -2095,7 +2095,7 @@
           <p:cNvPr id="9" name="">
             <a:extLst xmlns:a="http://schemas.openxmlformats.org/drawingml/2006/main">
               <a:ext uri="{FF2B5EF4-FFF2-40B4-BE49-F238E27FC236}">
-                <a16:creationId xmlns:a16="http://schemas.microsoft.com/office/drawing/2014/main" id="{13E04A30-CCC7-445D-A732-C46952E4CAE3}"/>
+                <a16:creationId xmlns:a16="http://schemas.microsoft.com/office/drawing/2014/main" id="{8D14BFC8-D3CB-4DFC-98D3-642D8938E3E4}"/>
               </a:ext>
             </a:extLst>
           </p:cNvPr>
@@ -2146,7 +2146,7 @@
                 <a:ea typeface="Arial"/>
                 <a:cs typeface="Arial"/>
               </a:rPr>
-              <a:t>16,382 cells</a:t>
+              <a:t>37,111 cells</a:t>
             </a:r>
           </a:p>
         </p:txBody>
@@ -2156,7 +2156,7 @@
           <p:cNvPr id="10" name="">
             <a:extLst xmlns:a="http://schemas.openxmlformats.org/drawingml/2006/main">
               <a:ext uri="{FF2B5EF4-FFF2-40B4-BE49-F238E27FC236}">
-                <a16:creationId xmlns:a16="http://schemas.microsoft.com/office/drawing/2014/main" id="{2D9E68E8-020E-4565-9313-030ECC20F447}"/>
+                <a16:creationId xmlns:a16="http://schemas.microsoft.com/office/drawing/2014/main" id="{43F9A551-5375-4C13-B911-3D9A2219D710}"/>
               </a:ext>
             </a:extLst>
           </p:cNvPr>
@@ -2168,7 +2168,7 @@
         <p:spPr>
           <a:xfrm xmlns:a="http://schemas.openxmlformats.org/drawingml/2006/main">
             <a:off x="4038600" y="4210050"/>
-            <a:ext cx="2095500" cy="361950"/>
+            <a:ext cx="2381250" cy="361950"/>
           </a:xfrm>
           <a:prstGeom xmlns:a="http://schemas.openxmlformats.org/drawingml/2006/main" prst="roundRect">
             <a:avLst>
@@ -2188,7 +2188,7 @@
           <p:cNvPr id="11" name="">
             <a:extLst xmlns:a="http://schemas.openxmlformats.org/drawingml/2006/main">
               <a:ext uri="{FF2B5EF4-FFF2-40B4-BE49-F238E27FC236}">
-                <a16:creationId xmlns:a16="http://schemas.microsoft.com/office/drawing/2014/main" id="{67DE0200-F244-44F2-9007-4B45CD2A9EEA}"/>
+                <a16:creationId xmlns:a16="http://schemas.microsoft.com/office/drawing/2014/main" id="{E24569D6-9B05-4099-85EF-F2D0035BF031}"/>
               </a:ext>
             </a:extLst>
           </p:cNvPr>
@@ -2200,7 +2200,7 @@
         <p:spPr>
           <a:xfrm xmlns:a="http://schemas.openxmlformats.org/drawingml/2006/main">
             <a:off x="4114800" y="4257675"/>
-            <a:ext cx="1943100" cy="266700"/>
+            <a:ext cx="2228850" cy="266700"/>
           </a:xfrm>
           <a:prstGeom xmlns:a="http://schemas.openxmlformats.org/drawingml/2006/main" prst="rect">
             <a:avLst/>
@@ -2239,7 +2239,7 @@
                 <a:ea typeface="Arial"/>
                 <a:cs typeface="Arial"/>
               </a:rPr>
-              <a:t>RNA + 39 proteins</a:t>
+              <a:t>10 donors + 25 targets</a:t>
             </a:r>
           </a:p>
         </p:txBody>
@@ -2249,7 +2249,7 @@
           <p:cNvPr id="12" name="">
             <a:extLst xmlns:a="http://schemas.openxmlformats.org/drawingml/2006/main">
               <a:ext uri="{FF2B5EF4-FFF2-40B4-BE49-F238E27FC236}">
-                <a16:creationId xmlns:a16="http://schemas.microsoft.com/office/drawing/2014/main" id="{2944CA8C-986D-47A7-9E1A-66F17C1E5A0A}"/>
+                <a16:creationId xmlns:a16="http://schemas.microsoft.com/office/drawing/2014/main" id="{5ECC86DD-17C7-45F1-A055-31FEF64B1222}"/>
               </a:ext>
             </a:extLst>
           </p:cNvPr>
@@ -2310,7 +2310,7 @@
           <p:cNvPr id="13" name="">
             <a:extLst xmlns:a="http://schemas.openxmlformats.org/drawingml/2006/main">
               <a:ext uri="{FF2B5EF4-FFF2-40B4-BE49-F238E27FC236}">
-                <a16:creationId xmlns:a16="http://schemas.microsoft.com/office/drawing/2014/main" id="{4FF50E9D-73FC-4D54-8475-42AEC15B37DA}"/>
+                <a16:creationId xmlns:a16="http://schemas.microsoft.com/office/drawing/2014/main" id="{B7AAC521-5DF3-4734-BC87-D1BF56818AE4}"/>
               </a:ext>
             </a:extLst>
           </p:cNvPr>
@@ -2334,7 +2334,7 @@
         </p:spPr>
         <p:txBody>
           <a:bodyPr xmlns:a="http://schemas.openxmlformats.org/drawingml/2006/main" anchor="ctr">
-            <a:normAutofit fontScale="92021"/>
+            <a:normAutofit fontScale="100000"/>
           </a:bodyPr>
           <a:lstStyle xmlns:a="http://schemas.openxmlformats.org/drawingml/2006/main"/>
           <a:p xmlns:a="http://schemas.openxmlformats.org/drawingml/2006/main">
@@ -2361,7 +2361,7 @@
                 <a:ea typeface="Arial"/>
                 <a:cs typeface="Arial"/>
               </a:rPr>
-              <a:t>Nested donor validation</a:t>
+              <a:t>Two external tests</a:t>
             </a:r>
           </a:p>
         </p:txBody>
@@ -2369,7 +2369,7 @@
     </p:spTree>
     <p:extLst>
       <p:ext uri="{BB962C8B-B14F-4D97-AF65-F5344CB8AC3E}">
-        <p14:creationId xmlns:p14="http://schemas.microsoft.com/office/powerpoint/2010/main" val="1387431785"/>
+        <p14:creationId xmlns:p14="http://schemas.microsoft.com/office/powerpoint/2010/main" val="449473511"/>
       </p:ext>
     </p:extLst>
   </p:cSld>
@@ -2400,7 +2400,7 @@
           <p:cNvPr id="13" name="">
             <a:extLst xmlns:a="http://schemas.openxmlformats.org/drawingml/2006/main">
               <a:ext uri="{FF2B5EF4-FFF2-40B4-BE49-F238E27FC236}">
-                <a16:creationId xmlns:a16="http://schemas.microsoft.com/office/drawing/2014/main" id="{B1FF1587-1943-41A1-84D5-1A7F4752D792}"/>
+                <a16:creationId xmlns:a16="http://schemas.microsoft.com/office/drawing/2014/main" id="{DF1D203C-D3CC-4531-A761-F969C19ACA01}"/>
               </a:ext>
             </a:extLst>
           </p:cNvPr>
@@ -2461,7 +2461,7 @@
           <p:cNvPr id="2" name="">
             <a:extLst xmlns:a="http://schemas.openxmlformats.org/drawingml/2006/main">
               <a:ext uri="{FF2B5EF4-FFF2-40B4-BE49-F238E27FC236}">
-                <a16:creationId xmlns:a16="http://schemas.microsoft.com/office/drawing/2014/main" id="{B52A03F3-CC7C-4E89-99DB-396D63D55D1F}"/>
+                <a16:creationId xmlns:a16="http://schemas.microsoft.com/office/drawing/2014/main" id="{F3B633AC-7BF5-422C-BE5F-853550CB6D42}"/>
               </a:ext>
             </a:extLst>
           </p:cNvPr>
@@ -2512,7 +2512,7 @@
                 <a:ea typeface="Arial"/>
                 <a:cs typeface="Arial"/>
               </a:rPr>
-              <a:t>Cross-modal context rescues surface biomarkers</a:t>
+              <a:t>Cross-modal context generalizes across two tests</a:t>
             </a:r>
           </a:p>
         </p:txBody>
@@ -2522,7 +2522,7 @@
           <p:cNvPr id="3" name="">
             <a:extLst xmlns:a="http://schemas.openxmlformats.org/drawingml/2006/main">
               <a:ext uri="{FF2B5EF4-FFF2-40B4-BE49-F238E27FC236}">
-                <a16:creationId xmlns:a16="http://schemas.microsoft.com/office/drawing/2014/main" id="{619F9E41-8B37-4DA9-9830-24C001341A62}"/>
+                <a16:creationId xmlns:a16="http://schemas.microsoft.com/office/drawing/2014/main" id="{88C03A71-F41F-47A1-A2FF-9A0CB3C89937}"/>
               </a:ext>
             </a:extLst>
           </p:cNvPr>
@@ -2552,7 +2552,7 @@
           <p:cNvPr id="4" name="">
             <a:extLst xmlns:a="http://schemas.openxmlformats.org/drawingml/2006/main">
               <a:ext uri="{FF2B5EF4-FFF2-40B4-BE49-F238E27FC236}">
-                <a16:creationId xmlns:a16="http://schemas.microsoft.com/office/drawing/2014/main" id="{FFC099E7-5743-4C12-AFBA-FE91C5840526}"/>
+                <a16:creationId xmlns:a16="http://schemas.microsoft.com/office/drawing/2014/main" id="{3134F649-CBAA-4DCF-9CDE-961CAF80CC17}"/>
               </a:ext>
             </a:extLst>
           </p:cNvPr>
@@ -2613,7 +2613,7 @@
           <p:cNvPr id="5" name="">
             <a:extLst xmlns:a="http://schemas.openxmlformats.org/drawingml/2006/main">
               <a:ext uri="{FF2B5EF4-FFF2-40B4-BE49-F238E27FC236}">
-                <a16:creationId xmlns:a16="http://schemas.microsoft.com/office/drawing/2014/main" id="{D55295EE-D248-4CEA-8750-6AC2CA4A3EAD}"/>
+                <a16:creationId xmlns:a16="http://schemas.microsoft.com/office/drawing/2014/main" id="{9EE782C9-4F14-4E55-A98D-54F92A10C439}"/>
               </a:ext>
             </a:extLst>
           </p:cNvPr>
@@ -2664,7 +2664,7 @@
                 <a:ea typeface="Arial"/>
                 <a:cs typeface="Arial"/>
               </a:rPr>
-              <a:t>FusionVI-X improved CD25, CD69 and HLA-DR in unseen donors; the strongest rescue occurred when HLA-DR RNA and protein disagreed.</a:t>
+              <a:t>FusionVI-X improved CD25, CD69 and HLA-DR in unseen donors, then recovered PD-L1 effects from unseen CRISPR targets.</a:t>
             </a:r>
           </a:p>
         </p:txBody>
@@ -2674,7 +2674,7 @@
           <p:cNvPr id="6" name="">
             <a:extLst xmlns:a="http://schemas.openxmlformats.org/drawingml/2006/main">
               <a:ext uri="{FF2B5EF4-FFF2-40B4-BE49-F238E27FC236}">
-                <a16:creationId xmlns:a16="http://schemas.microsoft.com/office/drawing/2014/main" id="{9489954A-0427-4E8E-906C-024697A63528}"/>
+                <a16:creationId xmlns:a16="http://schemas.microsoft.com/office/drawing/2014/main" id="{856BAE84-AC05-4BAF-BF05-5ABE50BDA3EC}"/>
               </a:ext>
             </a:extLst>
           </p:cNvPr>
@@ -2735,7 +2735,7 @@
           <p:cNvPr id="7" name="">
             <a:extLst xmlns:a="http://schemas.openxmlformats.org/drawingml/2006/main">
               <a:ext uri="{FF2B5EF4-FFF2-40B4-BE49-F238E27FC236}">
-                <a16:creationId xmlns:a16="http://schemas.microsoft.com/office/drawing/2014/main" id="{9422C9E4-4ED2-47F9-8B86-34C1C1EB3BB7}"/>
+                <a16:creationId xmlns:a16="http://schemas.microsoft.com/office/drawing/2014/main" id="{CD03C7E0-0F1E-466D-9941-95D45F8499AC}"/>
               </a:ext>
             </a:extLst>
           </p:cNvPr>
@@ -2786,7 +2786,7 @@
                 <a:ea typeface="Arial"/>
                 <a:cs typeface="Arial"/>
               </a:rPr>
-              <a:t>Neighbouring surface proteins retain activation-state information that marker RNA can miss.</a:t>
+              <a:t>Neighbouring surface proteins retain response information that marker RNA can miss.</a:t>
             </a:r>
           </a:p>
         </p:txBody>
@@ -2796,7 +2796,7 @@
           <p:cNvPr id="8" name="">
             <a:extLst xmlns:a="http://schemas.openxmlformats.org/drawingml/2006/main">
               <a:ext uri="{FF2B5EF4-FFF2-40B4-BE49-F238E27FC236}">
-                <a16:creationId xmlns:a16="http://schemas.microsoft.com/office/drawing/2014/main" id="{A39A8CA5-6C51-45FB-9FFA-2319CB6F7113}"/>
+                <a16:creationId xmlns:a16="http://schemas.microsoft.com/office/drawing/2014/main" id="{E9ABC328-6FEF-45C1-B41E-A6F91B31B853}"/>
               </a:ext>
             </a:extLst>
           </p:cNvPr>
@@ -2857,7 +2857,7 @@
           <p:cNvPr id="9" name="">
             <a:extLst xmlns:a="http://schemas.openxmlformats.org/drawingml/2006/main">
               <a:ext uri="{FF2B5EF4-FFF2-40B4-BE49-F238E27FC236}">
-                <a16:creationId xmlns:a16="http://schemas.microsoft.com/office/drawing/2014/main" id="{6F70822E-F521-4AB8-9573-77F98ADDB637}"/>
+                <a16:creationId xmlns:a16="http://schemas.microsoft.com/office/drawing/2014/main" id="{8AA461D1-D33D-4CD2-9386-DB6EC21BF9FB}"/>
               </a:ext>
             </a:extLst>
           </p:cNvPr>
@@ -2869,7 +2869,7 @@
         <p:spPr>
           <a:xfrm xmlns:a="http://schemas.openxmlformats.org/drawingml/2006/main">
             <a:off x="6191250" y="2495550"/>
-            <a:ext cx="4762500" cy="1619250"/>
+            <a:ext cx="4762500" cy="1428750"/>
           </a:xfrm>
           <a:prstGeom xmlns:a="http://schemas.openxmlformats.org/drawingml/2006/main" prst="rect">
             <a:avLst/>
@@ -2881,7 +2881,7 @@
         </p:spPr>
         <p:txBody>
           <a:bodyPr xmlns:a="http://schemas.openxmlformats.org/drawingml/2006/main" anchor="t">
-            <a:normAutofit fontScale="93626"/>
+            <a:normAutofit fontScale="96983"/>
           </a:bodyPr>
           <a:lstStyle xmlns:a="http://schemas.openxmlformats.org/drawingml/2006/main"/>
           <a:p xmlns:a="http://schemas.openxmlformats.org/drawingml/2006/main">
@@ -2908,7 +2908,7 @@
                 <a:ea typeface="Arial"/>
                 <a:cs typeface="Arial"/>
               </a:rPr>
-              <a:t>An unsupervised gate can recognize context. A donor-nested targeted readout is what converts that context into better biomarker recovery.</a:t>
+              <a:t>Targeted supervision converts cross-modal context into better biomarker recovery. The scalar gate alone contributes less.</a:t>
             </a:r>
           </a:p>
         </p:txBody>
@@ -2918,18 +2918,18 @@
           <p:cNvPr id="10" name="">
             <a:extLst xmlns:a="http://schemas.openxmlformats.org/drawingml/2006/main">
               <a:ext uri="{FF2B5EF4-FFF2-40B4-BE49-F238E27FC236}">
-                <a16:creationId xmlns:a16="http://schemas.microsoft.com/office/drawing/2014/main" id="{9B207C53-0C21-4AC1-B152-B097C8DEC355}"/>
-              </a:ext>
-            </a:extLst>
-          </p:cNvPr>
-          <p:cNvSpPr>
-            <a:spLocks xmlns:a="http://schemas.openxmlformats.org/drawingml/2006/main" noGrp="1"/>
-          </p:cNvSpPr>
-          <p:nvPr/>
-        </p:nvSpPr>
-        <p:spPr>
-          <a:xfrm xmlns:a="http://schemas.openxmlformats.org/drawingml/2006/main">
-            <a:off x="6191250" y="4762500"/>
+                <a16:creationId xmlns:a16="http://schemas.microsoft.com/office/drawing/2014/main" id="{DE6FD311-6C7B-4631-A4E2-67ECA4C06454}"/>
+              </a:ext>
+            </a:extLst>
+          </p:cNvPr>
+          <p:cNvSpPr>
+            <a:spLocks xmlns:a="http://schemas.openxmlformats.org/drawingml/2006/main" noGrp="1"/>
+          </p:cNvSpPr>
+          <p:nvPr/>
+        </p:nvSpPr>
+        <p:spPr>
+          <a:xfrm xmlns:a="http://schemas.openxmlformats.org/drawingml/2006/main">
+            <a:off x="6191250" y="4533900"/>
             <a:ext cx="1905000" cy="228600"/>
           </a:xfrm>
           <a:prstGeom xmlns:a="http://schemas.openxmlformats.org/drawingml/2006/main" prst="rect">
@@ -2969,7 +2969,7 @@
                 <a:ea typeface="Arial"/>
                 <a:cs typeface="Arial"/>
               </a:rPr>
-              <a:t>Next experiment</a:t>
+              <a:t>Boundary</a:t>
             </a:r>
           </a:p>
         </p:txBody>
@@ -2979,19 +2979,19 @@
           <p:cNvPr id="11" name="">
             <a:extLst xmlns:a="http://schemas.openxmlformats.org/drawingml/2006/main">
               <a:ext uri="{FF2B5EF4-FFF2-40B4-BE49-F238E27FC236}">
-                <a16:creationId xmlns:a16="http://schemas.microsoft.com/office/drawing/2014/main" id="{3C7CC063-2606-4A42-895F-2B6E1CFA3356}"/>
-              </a:ext>
-            </a:extLst>
-          </p:cNvPr>
-          <p:cNvSpPr>
-            <a:spLocks xmlns:a="http://schemas.openxmlformats.org/drawingml/2006/main" noGrp="1"/>
-          </p:cNvSpPr>
-          <p:nvPr/>
-        </p:nvSpPr>
-        <p:spPr>
-          <a:xfrm xmlns:a="http://schemas.openxmlformats.org/drawingml/2006/main">
-            <a:off x="6191250" y="5124450"/>
-            <a:ext cx="4762500" cy="666750"/>
+                <a16:creationId xmlns:a16="http://schemas.microsoft.com/office/drawing/2014/main" id="{A6FE71E5-EB01-4888-BEC5-42B078D5D3C7}"/>
+              </a:ext>
+            </a:extLst>
+          </p:cNvPr>
+          <p:cNvSpPr>
+            <a:spLocks xmlns:a="http://schemas.openxmlformats.org/drawingml/2006/main" noGrp="1"/>
+          </p:cNvSpPr>
+          <p:nvPr/>
+        </p:nvSpPr>
+        <p:spPr>
+          <a:xfrm xmlns:a="http://schemas.openxmlformats.org/drawingml/2006/main">
+            <a:off x="6191250" y="4895850"/>
+            <a:ext cx="4762500" cy="838200"/>
           </a:xfrm>
           <a:prstGeom xmlns:a="http://schemas.openxmlformats.org/drawingml/2006/main" prst="rect">
             <a:avLst/>
@@ -3030,7 +3030,7 @@
                 <a:ea typeface="Arial"/>
                 <a:cs typeface="Arial"/>
               </a:rPr>
-              <a:t>Test unseen perturbations, doses and timepoints with an external pharmacodynamic endpoint.</a:t>
+              <a:t>CMTM6 shows that post-transcriptional stability mechanisms can remain invisible without direct protein evidence.</a:t>
             </a:r>
           </a:p>
         </p:txBody>
@@ -3040,7 +3040,7 @@
           <p:cNvPr id="12" name="">
             <a:extLst xmlns:a="http://schemas.openxmlformats.org/drawingml/2006/main">
               <a:ext uri="{FF2B5EF4-FFF2-40B4-BE49-F238E27FC236}">
-                <a16:creationId xmlns:a16="http://schemas.microsoft.com/office/drawing/2014/main" id="{95806874-FD8D-4689-9C5F-926399253DEE}"/>
+                <a16:creationId xmlns:a16="http://schemas.microsoft.com/office/drawing/2014/main" id="{8F5590BE-3C17-4572-B8C3-929E6D31CF37}"/>
               </a:ext>
             </a:extLst>
           </p:cNvPr>
@@ -3091,7 +3091,7 @@
                 <a:ea typeface="Arial"/>
                 <a:cs typeface="Arial"/>
               </a:rPr>
-              <a:t>All outer folds, inner selections, ablations and statistics are reproducible.</a:t>
+              <a:t>Two outer validation schemes, all ablations and all statistics are reproducible.</a:t>
             </a:r>
           </a:p>
         </p:txBody>
@@ -3099,7 +3099,7 @@
     </p:spTree>
     <p:extLst>
       <p:ext uri="{BB962C8B-B14F-4D97-AF65-F5344CB8AC3E}">
-        <p14:creationId xmlns:p14="http://schemas.microsoft.com/office/powerpoint/2010/main" val="214934700"/>
+        <p14:creationId xmlns:p14="http://schemas.microsoft.com/office/powerpoint/2010/main" val="69657979"/>
       </p:ext>
     </p:extLst>
   </p:cSld>
@@ -3130,7 +3130,7 @@
           <p:cNvPr id="20" name="">
             <a:extLst xmlns:a="http://schemas.openxmlformats.org/drawingml/2006/main">
               <a:ext uri="{FF2B5EF4-FFF2-40B4-BE49-F238E27FC236}">
-                <a16:creationId xmlns:a16="http://schemas.microsoft.com/office/drawing/2014/main" id="{A4E60D39-DED0-4AD9-B161-A4B9491A5C99}"/>
+                <a16:creationId xmlns:a16="http://schemas.microsoft.com/office/drawing/2014/main" id="{F4AD7EB4-3026-46E3-A2E8-9920F3E209E8}"/>
               </a:ext>
             </a:extLst>
           </p:cNvPr>
@@ -3191,7 +3191,7 @@
           <p:cNvPr id="2" name="">
             <a:extLst xmlns:a="http://schemas.openxmlformats.org/drawingml/2006/main">
               <a:ext uri="{FF2B5EF4-FFF2-40B4-BE49-F238E27FC236}">
-                <a16:creationId xmlns:a16="http://schemas.microsoft.com/office/drawing/2014/main" id="{0C121906-4D5A-4A70-8A76-D4E25AE57642}"/>
+                <a16:creationId xmlns:a16="http://schemas.microsoft.com/office/drawing/2014/main" id="{D705FBF8-D102-4561-86B1-FE98BFC793A2}"/>
               </a:ext>
             </a:extLst>
           </p:cNvPr>
@@ -3252,7 +3252,7 @@
           <p:cNvPr id="3" name="">
             <a:extLst xmlns:a="http://schemas.openxmlformats.org/drawingml/2006/main">
               <a:ext uri="{FF2B5EF4-FFF2-40B4-BE49-F238E27FC236}">
-                <a16:creationId xmlns:a16="http://schemas.microsoft.com/office/drawing/2014/main" id="{6B63710B-FBF2-4516-95DC-27658599ACA8}"/>
+                <a16:creationId xmlns:a16="http://schemas.microsoft.com/office/drawing/2014/main" id="{C1A28F89-968F-4746-9E89-F74C7D416D92}"/>
               </a:ext>
             </a:extLst>
           </p:cNvPr>
@@ -3282,7 +3282,7 @@
           <p:cNvPr id="4" name="">
             <a:extLst xmlns:a="http://schemas.openxmlformats.org/drawingml/2006/main">
               <a:ext uri="{FF2B5EF4-FFF2-40B4-BE49-F238E27FC236}">
-                <a16:creationId xmlns:a16="http://schemas.microsoft.com/office/drawing/2014/main" id="{EACD4143-D9E3-4223-8ECE-ABB18F760CE5}"/>
+                <a16:creationId xmlns:a16="http://schemas.microsoft.com/office/drawing/2014/main" id="{76384100-4405-4BFA-A5F1-8A2C740A0E33}"/>
               </a:ext>
             </a:extLst>
           </p:cNvPr>
@@ -3343,7 +3343,7 @@
           <p:cNvPr id="5" name="">
             <a:extLst xmlns:a="http://schemas.openxmlformats.org/drawingml/2006/main">
               <a:ext uri="{FF2B5EF4-FFF2-40B4-BE49-F238E27FC236}">
-                <a16:creationId xmlns:a16="http://schemas.microsoft.com/office/drawing/2014/main" id="{1639AEAC-A3A1-43CD-9928-B39CD12C5058}"/>
+                <a16:creationId xmlns:a16="http://schemas.microsoft.com/office/drawing/2014/main" id="{D8286049-651E-4476-AE88-BE1F0D7D31DA}"/>
               </a:ext>
             </a:extLst>
           </p:cNvPr>
@@ -3404,7 +3404,7 @@
           <p:cNvPr id="6" name="">
             <a:extLst xmlns:a="http://schemas.openxmlformats.org/drawingml/2006/main">
               <a:ext uri="{FF2B5EF4-FFF2-40B4-BE49-F238E27FC236}">
-                <a16:creationId xmlns:a16="http://schemas.microsoft.com/office/drawing/2014/main" id="{3BD160CC-B86D-4223-AE30-6DE655282ED4}"/>
+                <a16:creationId xmlns:a16="http://schemas.microsoft.com/office/drawing/2014/main" id="{D30EAA7E-074E-409E-AA0B-4C873051B63F}"/>
               </a:ext>
             </a:extLst>
           </p:cNvPr>
@@ -3436,7 +3436,7 @@
           <p:cNvPr id="7" name="">
             <a:extLst xmlns:a="http://schemas.openxmlformats.org/drawingml/2006/main">
               <a:ext uri="{FF2B5EF4-FFF2-40B4-BE49-F238E27FC236}">
-                <a16:creationId xmlns:a16="http://schemas.microsoft.com/office/drawing/2014/main" id="{4B6E7D33-3215-4219-B13C-4335AACE292B}"/>
+                <a16:creationId xmlns:a16="http://schemas.microsoft.com/office/drawing/2014/main" id="{5E8D02E0-8A28-47BF-9F27-5D995CEBF81F}"/>
               </a:ext>
             </a:extLst>
           </p:cNvPr>
@@ -3497,7 +3497,7 @@
           <p:cNvPr id="8" name="">
             <a:extLst xmlns:a="http://schemas.openxmlformats.org/drawingml/2006/main">
               <a:ext uri="{FF2B5EF4-FFF2-40B4-BE49-F238E27FC236}">
-                <a16:creationId xmlns:a16="http://schemas.microsoft.com/office/drawing/2014/main" id="{43E80FF5-6E99-48D0-B2C5-E4CEED240967}"/>
+                <a16:creationId xmlns:a16="http://schemas.microsoft.com/office/drawing/2014/main" id="{D14460D5-3479-4B7B-ACDF-42A585884803}"/>
               </a:ext>
             </a:extLst>
           </p:cNvPr>
@@ -3585,7 +3585,7 @@
           <p:cNvPr id="9" name="">
             <a:extLst xmlns:a="http://schemas.openxmlformats.org/drawingml/2006/main">
               <a:ext uri="{FF2B5EF4-FFF2-40B4-BE49-F238E27FC236}">
-                <a16:creationId xmlns:a16="http://schemas.microsoft.com/office/drawing/2014/main" id="{B6BA660C-796B-494E-BBFD-B0D4F80C5F5F}"/>
+                <a16:creationId xmlns:a16="http://schemas.microsoft.com/office/drawing/2014/main" id="{8A955046-5384-472D-A0F2-14D342B26734}"/>
               </a:ext>
             </a:extLst>
           </p:cNvPr>
@@ -3646,7 +3646,7 @@
           <p:cNvPr id="10" name="">
             <a:extLst xmlns:a="http://schemas.openxmlformats.org/drawingml/2006/main">
               <a:ext uri="{FF2B5EF4-FFF2-40B4-BE49-F238E27FC236}">
-                <a16:creationId xmlns:a16="http://schemas.microsoft.com/office/drawing/2014/main" id="{185F59BC-6DDD-450B-BF1D-1659C937600C}"/>
+                <a16:creationId xmlns:a16="http://schemas.microsoft.com/office/drawing/2014/main" id="{A8BEF589-CF98-4F19-AE99-176C4FC951E8}"/>
               </a:ext>
             </a:extLst>
           </p:cNvPr>
@@ -3678,7 +3678,7 @@
           <p:cNvPr id="11" name="">
             <a:extLst xmlns:a="http://schemas.openxmlformats.org/drawingml/2006/main">
               <a:ext uri="{FF2B5EF4-FFF2-40B4-BE49-F238E27FC236}">
-                <a16:creationId xmlns:a16="http://schemas.microsoft.com/office/drawing/2014/main" id="{B1C8D32C-7DA1-43FB-A57E-649821072A00}"/>
+                <a16:creationId xmlns:a16="http://schemas.microsoft.com/office/drawing/2014/main" id="{FE46DA32-7CF3-4F68-A496-EA9572E254BB}"/>
               </a:ext>
             </a:extLst>
           </p:cNvPr>
@@ -3739,7 +3739,7 @@
           <p:cNvPr id="12" name="">
             <a:extLst xmlns:a="http://schemas.openxmlformats.org/drawingml/2006/main">
               <a:ext uri="{FF2B5EF4-FFF2-40B4-BE49-F238E27FC236}">
-                <a16:creationId xmlns:a16="http://schemas.microsoft.com/office/drawing/2014/main" id="{CF6B907F-EAE9-46DD-B03D-81D9538DD60A}"/>
+                <a16:creationId xmlns:a16="http://schemas.microsoft.com/office/drawing/2014/main" id="{83ED8903-DAC6-450A-B467-E4EF0E723528}"/>
               </a:ext>
             </a:extLst>
           </p:cNvPr>
@@ -3827,7 +3827,7 @@
           <p:cNvPr id="13" name="">
             <a:extLst xmlns:a="http://schemas.openxmlformats.org/drawingml/2006/main">
               <a:ext uri="{FF2B5EF4-FFF2-40B4-BE49-F238E27FC236}">
-                <a16:creationId xmlns:a16="http://schemas.microsoft.com/office/drawing/2014/main" id="{671A8502-C0AE-466F-892B-14AE902FBABA}"/>
+                <a16:creationId xmlns:a16="http://schemas.microsoft.com/office/drawing/2014/main" id="{DBB1958B-B6BD-4F1E-9DB8-36D18CA5B720}"/>
               </a:ext>
             </a:extLst>
           </p:cNvPr>
@@ -3888,7 +3888,7 @@
           <p:cNvPr id="14" name="">
             <a:extLst xmlns:a="http://schemas.openxmlformats.org/drawingml/2006/main">
               <a:ext uri="{FF2B5EF4-FFF2-40B4-BE49-F238E27FC236}">
-                <a16:creationId xmlns:a16="http://schemas.microsoft.com/office/drawing/2014/main" id="{2BE65749-6243-4719-99E5-FE5B9F0F4150}"/>
+                <a16:creationId xmlns:a16="http://schemas.microsoft.com/office/drawing/2014/main" id="{CBFDFB87-2FC4-4B65-ABAA-CC765F4BF9FE}"/>
               </a:ext>
             </a:extLst>
           </p:cNvPr>
@@ -3918,7 +3918,7 @@
           <p:cNvPr id="15" name="">
             <a:extLst xmlns:a="http://schemas.openxmlformats.org/drawingml/2006/main">
               <a:ext uri="{FF2B5EF4-FFF2-40B4-BE49-F238E27FC236}">
-                <a16:creationId xmlns:a16="http://schemas.microsoft.com/office/drawing/2014/main" id="{2EED4A0F-A2F0-487B-ACB7-1587BD5A6F6F}"/>
+                <a16:creationId xmlns:a16="http://schemas.microsoft.com/office/drawing/2014/main" id="{AB75F44B-2395-4CEF-8AB1-5AF46B312B43}"/>
               </a:ext>
             </a:extLst>
           </p:cNvPr>
@@ -3979,7 +3979,7 @@
           <p:cNvPr id="16" name="">
             <a:extLst xmlns:a="http://schemas.openxmlformats.org/drawingml/2006/main">
               <a:ext uri="{FF2B5EF4-FFF2-40B4-BE49-F238E27FC236}">
-                <a16:creationId xmlns:a16="http://schemas.microsoft.com/office/drawing/2014/main" id="{B7AD6E22-7ECA-4BF3-B7F0-50FB0839378D}"/>
+                <a16:creationId xmlns:a16="http://schemas.microsoft.com/office/drawing/2014/main" id="{719954CB-54E2-4045-906C-F683F0620A86}"/>
               </a:ext>
             </a:extLst>
           </p:cNvPr>
@@ -4040,7 +4040,7 @@
           <p:cNvPr id="17" name="">
             <a:extLst xmlns:a="http://schemas.openxmlformats.org/drawingml/2006/main">
               <a:ext uri="{FF2B5EF4-FFF2-40B4-BE49-F238E27FC236}">
-                <a16:creationId xmlns:a16="http://schemas.microsoft.com/office/drawing/2014/main" id="{24A27428-97E6-4103-A4B8-A0B80707AA0E}"/>
+                <a16:creationId xmlns:a16="http://schemas.microsoft.com/office/drawing/2014/main" id="{C636423B-5DBE-4D1B-B453-76985E6D37B6}"/>
               </a:ext>
             </a:extLst>
           </p:cNvPr>
@@ -4064,7 +4064,7 @@
         </p:spPr>
         <p:txBody>
           <a:bodyPr xmlns:a="http://schemas.openxmlformats.org/drawingml/2006/main" anchor="t">
-            <a:normAutofit fontScale="88388"/>
+            <a:normAutofit fontScale="86687"/>
           </a:bodyPr>
           <a:lstStyle xmlns:a="http://schemas.openxmlformats.org/drawingml/2006/main"/>
           <a:p xmlns:a="http://schemas.openxmlformats.org/drawingml/2006/main">
@@ -4073,7 +4073,7 @@
                 <a:spcPct val="104000"/>
               </a:lnSpc>
               <a:buNone/>
-              <a:defRPr sz="2250" b="1">
+              <a:defRPr sz="2100" b="1">
                 <a:solidFill>
                   <a:srgbClr val="17223B"/>
                 </a:solidFill>
@@ -4083,7 +4083,7 @@
               </a:defRPr>
             </a:pPr>
             <a:r>
-              <a:rPr sz="2250" b="1">
+              <a:rPr sz="2100" b="1">
                 <a:solidFill>
                   <a:srgbClr val="17223B"/>
                 </a:solidFill>
@@ -4091,7 +4091,7 @@
                 <a:ea typeface="Arial"/>
                 <a:cs typeface="Arial"/>
               </a:rPr>
-              <a:t>Can multimodal AI preserve this biologically meaningful disagreement and recover activation markers in a new donor?</a:t>
+              <a:t>Can multimodal AI preserve this biologically meaningful disagreement and recover surface biomarkers in a new donor or after a new perturbation?</a:t>
             </a:r>
           </a:p>
         </p:txBody>
@@ -4101,7 +4101,7 @@
           <p:cNvPr id="18" name="">
             <a:extLst xmlns:a="http://schemas.openxmlformats.org/drawingml/2006/main">
               <a:ext uri="{FF2B5EF4-FFF2-40B4-BE49-F238E27FC236}">
-                <a16:creationId xmlns:a16="http://schemas.microsoft.com/office/drawing/2014/main" id="{BED581D3-ABCA-4F83-A039-0F93AF5582EA}"/>
+                <a16:creationId xmlns:a16="http://schemas.microsoft.com/office/drawing/2014/main" id="{1F31B6B7-465E-4E4A-8FF4-77216CB46545}"/>
               </a:ext>
             </a:extLst>
           </p:cNvPr>
@@ -4162,7 +4162,7 @@
           <p:cNvPr id="19" name="">
             <a:extLst xmlns:a="http://schemas.openxmlformats.org/drawingml/2006/main">
               <a:ext uri="{FF2B5EF4-FFF2-40B4-BE49-F238E27FC236}">
-                <a16:creationId xmlns:a16="http://schemas.microsoft.com/office/drawing/2014/main" id="{20FFA817-BCF4-4C8F-9E52-D346CD6A4E85}"/>
+                <a16:creationId xmlns:a16="http://schemas.microsoft.com/office/drawing/2014/main" id="{A038DB0E-8F2E-4F3A-B612-4A5A68D83032}"/>
               </a:ext>
             </a:extLst>
           </p:cNvPr>
@@ -4221,7 +4221,7 @@
     </p:spTree>
     <p:extLst>
       <p:ext uri="{BB962C8B-B14F-4D97-AF65-F5344CB8AC3E}">
-        <p14:creationId xmlns:p14="http://schemas.microsoft.com/office/powerpoint/2010/main" val="1133631005"/>
+        <p14:creationId xmlns:p14="http://schemas.microsoft.com/office/powerpoint/2010/main" val="289164590"/>
       </p:ext>
     </p:extLst>
   </p:cSld>
@@ -4252,7 +4252,7 @@
           <p:cNvPr id="27" name="">
             <a:extLst xmlns:a="http://schemas.openxmlformats.org/drawingml/2006/main">
               <a:ext uri="{FF2B5EF4-FFF2-40B4-BE49-F238E27FC236}">
-                <a16:creationId xmlns:a16="http://schemas.microsoft.com/office/drawing/2014/main" id="{2CC0C81E-DB79-46C5-855B-FFD4A899A85B}"/>
+                <a16:creationId xmlns:a16="http://schemas.microsoft.com/office/drawing/2014/main" id="{9BB9BF50-FEE3-4973-8264-72C1ED468909}"/>
               </a:ext>
             </a:extLst>
           </p:cNvPr>
@@ -4313,7 +4313,7 @@
           <p:cNvPr id="2" name="">
             <a:extLst xmlns:a="http://schemas.openxmlformats.org/drawingml/2006/main">
               <a:ext uri="{FF2B5EF4-FFF2-40B4-BE49-F238E27FC236}">
-                <a16:creationId xmlns:a16="http://schemas.microsoft.com/office/drawing/2014/main" id="{1C695242-5494-4C78-8AF7-518DA92855E2}"/>
+                <a16:creationId xmlns:a16="http://schemas.microsoft.com/office/drawing/2014/main" id="{1B2793EE-BC80-4799-A434-B0A22B972601}"/>
               </a:ext>
             </a:extLst>
           </p:cNvPr>
@@ -4374,7 +4374,7 @@
           <p:cNvPr id="3" name="">
             <a:extLst xmlns:a="http://schemas.openxmlformats.org/drawingml/2006/main">
               <a:ext uri="{FF2B5EF4-FFF2-40B4-BE49-F238E27FC236}">
-                <a16:creationId xmlns:a16="http://schemas.microsoft.com/office/drawing/2014/main" id="{C2CE5160-69BB-45CC-9203-2C1644B7EA83}"/>
+                <a16:creationId xmlns:a16="http://schemas.microsoft.com/office/drawing/2014/main" id="{F87BA071-6702-4EB9-BF9F-54D3CA3EDCF1}"/>
               </a:ext>
             </a:extLst>
           </p:cNvPr>
@@ -4404,7 +4404,7 @@
           <p:cNvPr id="4" name="">
             <a:extLst xmlns:a="http://schemas.openxmlformats.org/drawingml/2006/main">
               <a:ext uri="{FF2B5EF4-FFF2-40B4-BE49-F238E27FC236}">
-                <a16:creationId xmlns:a16="http://schemas.microsoft.com/office/drawing/2014/main" id="{848E56DE-E7A1-4485-8250-2039008A3EAF}"/>
+                <a16:creationId xmlns:a16="http://schemas.microsoft.com/office/drawing/2014/main" id="{067D4AA1-6F0C-45BE-86CD-3EFCB7BF0F38}"/>
               </a:ext>
             </a:extLst>
           </p:cNvPr>
@@ -4465,7 +4465,7 @@
           <p:cNvPr id="5" name="">
             <a:extLst xmlns:a="http://schemas.openxmlformats.org/drawingml/2006/main">
               <a:ext uri="{FF2B5EF4-FFF2-40B4-BE49-F238E27FC236}">
-                <a16:creationId xmlns:a16="http://schemas.microsoft.com/office/drawing/2014/main" id="{6CC90B0C-097C-4288-8AA2-F3CAF964E9AC}"/>
+                <a16:creationId xmlns:a16="http://schemas.microsoft.com/office/drawing/2014/main" id="{C8BDCF62-013E-495A-B3A5-9D539DE4F57C}"/>
               </a:ext>
             </a:extLst>
           </p:cNvPr>
@@ -4526,7 +4526,7 @@
           <p:cNvPr id="6" name="">
             <a:extLst xmlns:a="http://schemas.openxmlformats.org/drawingml/2006/main">
               <a:ext uri="{FF2B5EF4-FFF2-40B4-BE49-F238E27FC236}">
-                <a16:creationId xmlns:a16="http://schemas.microsoft.com/office/drawing/2014/main" id="{728C9BC9-2A94-4C8F-821D-E94033EB91A6}"/>
+                <a16:creationId xmlns:a16="http://schemas.microsoft.com/office/drawing/2014/main" id="{EB711C8B-AD81-4CF2-8C17-48C89E5DF087}"/>
               </a:ext>
             </a:extLst>
           </p:cNvPr>
@@ -4587,7 +4587,7 @@
           <p:cNvPr id="7" name="">
             <a:extLst xmlns:a="http://schemas.openxmlformats.org/drawingml/2006/main">
               <a:ext uri="{FF2B5EF4-FFF2-40B4-BE49-F238E27FC236}">
-                <a16:creationId xmlns:a16="http://schemas.microsoft.com/office/drawing/2014/main" id="{A599581A-6E22-43C7-AC29-1A7201F39358}"/>
+                <a16:creationId xmlns:a16="http://schemas.microsoft.com/office/drawing/2014/main" id="{97B28F40-2010-472C-B2F7-A8309C41739F}"/>
               </a:ext>
             </a:extLst>
           </p:cNvPr>
@@ -4619,7 +4619,7 @@
           <p:cNvPr id="8" name="">
             <a:extLst xmlns:a="http://schemas.openxmlformats.org/drawingml/2006/main">
               <a:ext uri="{FF2B5EF4-FFF2-40B4-BE49-F238E27FC236}">
-                <a16:creationId xmlns:a16="http://schemas.microsoft.com/office/drawing/2014/main" id="{E52EBB90-397A-476B-9C02-5BB3C253AAEB}"/>
+                <a16:creationId xmlns:a16="http://schemas.microsoft.com/office/drawing/2014/main" id="{D47A32A3-AF99-498C-A9BA-648FA725A67C}"/>
               </a:ext>
             </a:extLst>
           </p:cNvPr>
@@ -4680,7 +4680,7 @@
           <p:cNvPr id="9" name="">
             <a:extLst xmlns:a="http://schemas.openxmlformats.org/drawingml/2006/main">
               <a:ext uri="{FF2B5EF4-FFF2-40B4-BE49-F238E27FC236}">
-                <a16:creationId xmlns:a16="http://schemas.microsoft.com/office/drawing/2014/main" id="{3B0F8853-6E1B-4CBC-9512-F994552E9174}"/>
+                <a16:creationId xmlns:a16="http://schemas.microsoft.com/office/drawing/2014/main" id="{FBAD9B9F-4B20-402B-A591-05E9A7E665BE}"/>
               </a:ext>
             </a:extLst>
           </p:cNvPr>
@@ -4741,7 +4741,7 @@
           <p:cNvPr id="10" name="">
             <a:extLst xmlns:a="http://schemas.openxmlformats.org/drawingml/2006/main">
               <a:ext uri="{FF2B5EF4-FFF2-40B4-BE49-F238E27FC236}">
-                <a16:creationId xmlns:a16="http://schemas.microsoft.com/office/drawing/2014/main" id="{3130C8A5-A015-4218-96B7-3AEAA823DE1C}"/>
+                <a16:creationId xmlns:a16="http://schemas.microsoft.com/office/drawing/2014/main" id="{6450FC28-7D5D-4636-9DD2-CEDEA61DCD4C}"/>
               </a:ext>
             </a:extLst>
           </p:cNvPr>
@@ -4773,7 +4773,7 @@
           <p:cNvPr id="11" name="">
             <a:extLst xmlns:a="http://schemas.openxmlformats.org/drawingml/2006/main">
               <a:ext uri="{FF2B5EF4-FFF2-40B4-BE49-F238E27FC236}">
-                <a16:creationId xmlns:a16="http://schemas.microsoft.com/office/drawing/2014/main" id="{109234F9-2D19-4736-B663-2540C0BC7D18}"/>
+                <a16:creationId xmlns:a16="http://schemas.microsoft.com/office/drawing/2014/main" id="{C0373589-4F48-48E8-A628-F8BF24216828}"/>
               </a:ext>
             </a:extLst>
           </p:cNvPr>
@@ -4834,7 +4834,7 @@
           <p:cNvPr id="12" name="">
             <a:extLst xmlns:a="http://schemas.openxmlformats.org/drawingml/2006/main">
               <a:ext uri="{FF2B5EF4-FFF2-40B4-BE49-F238E27FC236}">
-                <a16:creationId xmlns:a16="http://schemas.microsoft.com/office/drawing/2014/main" id="{2312B29F-5895-420C-AF2A-4F847762B622}"/>
+                <a16:creationId xmlns:a16="http://schemas.microsoft.com/office/drawing/2014/main" id="{0F47B8C3-6041-4D67-8617-3A6643F00C74}"/>
               </a:ext>
             </a:extLst>
           </p:cNvPr>
@@ -4895,7 +4895,7 @@
           <p:cNvPr id="13" name="">
             <a:extLst xmlns:a="http://schemas.openxmlformats.org/drawingml/2006/main">
               <a:ext uri="{FF2B5EF4-FFF2-40B4-BE49-F238E27FC236}">
-                <a16:creationId xmlns:a16="http://schemas.microsoft.com/office/drawing/2014/main" id="{C0EEE489-B069-43B9-B36E-B89BD98B34F4}"/>
+                <a16:creationId xmlns:a16="http://schemas.microsoft.com/office/drawing/2014/main" id="{0229719E-1253-4D9A-A378-95D19A4765DF}"/>
               </a:ext>
             </a:extLst>
           </p:cNvPr>
@@ -4927,7 +4927,7 @@
           <p:cNvPr id="14" name="">
             <a:extLst xmlns:a="http://schemas.openxmlformats.org/drawingml/2006/main">
               <a:ext uri="{FF2B5EF4-FFF2-40B4-BE49-F238E27FC236}">
-                <a16:creationId xmlns:a16="http://schemas.microsoft.com/office/drawing/2014/main" id="{F7A2F4CC-A8BC-4B21-AF9F-A28959EB9875}"/>
+                <a16:creationId xmlns:a16="http://schemas.microsoft.com/office/drawing/2014/main" id="{1A1AD407-7513-40F1-8019-ADEA7363BB8B}"/>
               </a:ext>
             </a:extLst>
           </p:cNvPr>
@@ -4988,7 +4988,7 @@
           <p:cNvPr id="15" name="">
             <a:extLst xmlns:a="http://schemas.openxmlformats.org/drawingml/2006/main">
               <a:ext uri="{FF2B5EF4-FFF2-40B4-BE49-F238E27FC236}">
-                <a16:creationId xmlns:a16="http://schemas.microsoft.com/office/drawing/2014/main" id="{823ACBA1-D982-4341-B112-D02FD71CC98F}"/>
+                <a16:creationId xmlns:a16="http://schemas.microsoft.com/office/drawing/2014/main" id="{C072B7B9-7D37-4CC6-9695-82BBD41E99DA}"/>
               </a:ext>
             </a:extLst>
           </p:cNvPr>
@@ -5049,7 +5049,7 @@
           <p:cNvPr id="16" name="">
             <a:extLst xmlns:a="http://schemas.openxmlformats.org/drawingml/2006/main">
               <a:ext uri="{FF2B5EF4-FFF2-40B4-BE49-F238E27FC236}">
-                <a16:creationId xmlns:a16="http://schemas.microsoft.com/office/drawing/2014/main" id="{222C1533-CF9B-4C67-B2DF-E947C16A3B9C}"/>
+                <a16:creationId xmlns:a16="http://schemas.microsoft.com/office/drawing/2014/main" id="{E4988F7C-D947-48F9-923B-BD72A27E7ABE}"/>
               </a:ext>
             </a:extLst>
           </p:cNvPr>
@@ -5110,7 +5110,7 @@
           <p:cNvPr id="17" name="">
             <a:extLst xmlns:a="http://schemas.openxmlformats.org/drawingml/2006/main">
               <a:ext uri="{FF2B5EF4-FFF2-40B4-BE49-F238E27FC236}">
-                <a16:creationId xmlns:a16="http://schemas.microsoft.com/office/drawing/2014/main" id="{2D63AA37-C719-411B-A226-81E330A49D3F}"/>
+                <a16:creationId xmlns:a16="http://schemas.microsoft.com/office/drawing/2014/main" id="{FFAACC36-3EE2-431C-AD4C-47903BDB29B2}"/>
               </a:ext>
             </a:extLst>
           </p:cNvPr>
@@ -5142,7 +5142,7 @@
           <p:cNvPr id="18" name="">
             <a:extLst xmlns:a="http://schemas.openxmlformats.org/drawingml/2006/main">
               <a:ext uri="{FF2B5EF4-FFF2-40B4-BE49-F238E27FC236}">
-                <a16:creationId xmlns:a16="http://schemas.microsoft.com/office/drawing/2014/main" id="{6E432E3B-E5BC-4E6B-97EC-A3BB59479E98}"/>
+                <a16:creationId xmlns:a16="http://schemas.microsoft.com/office/drawing/2014/main" id="{53686119-981E-4B99-A9F9-332580633A2F}"/>
               </a:ext>
             </a:extLst>
           </p:cNvPr>
@@ -5203,7 +5203,7 @@
           <p:cNvPr id="19" name="">
             <a:extLst xmlns:a="http://schemas.openxmlformats.org/drawingml/2006/main">
               <a:ext uri="{FF2B5EF4-FFF2-40B4-BE49-F238E27FC236}">
-                <a16:creationId xmlns:a16="http://schemas.microsoft.com/office/drawing/2014/main" id="{676F6B17-7CAF-44EB-8992-E166FC7FE5EE}"/>
+                <a16:creationId xmlns:a16="http://schemas.microsoft.com/office/drawing/2014/main" id="{36A4C05B-286A-4806-9BF8-A432AAF98C8E}"/>
               </a:ext>
             </a:extLst>
           </p:cNvPr>
@@ -5318,7 +5318,7 @@
           <p:cNvPr id="20" name="">
             <a:extLst xmlns:a="http://schemas.openxmlformats.org/drawingml/2006/main">
               <a:ext uri="{FF2B5EF4-FFF2-40B4-BE49-F238E27FC236}">
-                <a16:creationId xmlns:a16="http://schemas.microsoft.com/office/drawing/2014/main" id="{702E9260-EAB4-4C7E-AC98-72318BB537F8}"/>
+                <a16:creationId xmlns:a16="http://schemas.microsoft.com/office/drawing/2014/main" id="{090620CD-8508-486E-A680-27EDB1671AB9}"/>
               </a:ext>
             </a:extLst>
           </p:cNvPr>
@@ -5348,7 +5348,7 @@
           <p:cNvPr id="21" name="">
             <a:extLst xmlns:a="http://schemas.openxmlformats.org/drawingml/2006/main">
               <a:ext uri="{FF2B5EF4-FFF2-40B4-BE49-F238E27FC236}">
-                <a16:creationId xmlns:a16="http://schemas.microsoft.com/office/drawing/2014/main" id="{528DFFCF-B281-40AA-A016-F9B7F1316B9F}"/>
+                <a16:creationId xmlns:a16="http://schemas.microsoft.com/office/drawing/2014/main" id="{52ABE288-D082-49FF-B8A5-DA50052F4E8E}"/>
               </a:ext>
             </a:extLst>
           </p:cNvPr>
@@ -5409,7 +5409,7 @@
           <p:cNvPr id="22" name="">
             <a:extLst xmlns:a="http://schemas.openxmlformats.org/drawingml/2006/main">
               <a:ext uri="{FF2B5EF4-FFF2-40B4-BE49-F238E27FC236}">
-                <a16:creationId xmlns:a16="http://schemas.microsoft.com/office/drawing/2014/main" id="{34AF8BA4-E7CC-422C-A7D6-8ADF413AAA2E}"/>
+                <a16:creationId xmlns:a16="http://schemas.microsoft.com/office/drawing/2014/main" id="{3F2B2058-45FB-4E47-B8E3-C5398AC4901C}"/>
               </a:ext>
             </a:extLst>
           </p:cNvPr>
@@ -5470,7 +5470,7 @@
           <p:cNvPr id="23" name="">
             <a:extLst xmlns:a="http://schemas.openxmlformats.org/drawingml/2006/main">
               <a:ext uri="{FF2B5EF4-FFF2-40B4-BE49-F238E27FC236}">
-                <a16:creationId xmlns:a16="http://schemas.microsoft.com/office/drawing/2014/main" id="{5E5670C5-FDF0-463F-89E7-FB7A90B21733}"/>
+                <a16:creationId xmlns:a16="http://schemas.microsoft.com/office/drawing/2014/main" id="{5010B9C0-CE62-4EC5-BA2C-4E22257BB529}"/>
               </a:ext>
             </a:extLst>
           </p:cNvPr>
@@ -5531,7 +5531,7 @@
           <p:cNvPr id="24" name="">
             <a:extLst xmlns:a="http://schemas.openxmlformats.org/drawingml/2006/main">
               <a:ext uri="{FF2B5EF4-FFF2-40B4-BE49-F238E27FC236}">
-                <a16:creationId xmlns:a16="http://schemas.microsoft.com/office/drawing/2014/main" id="{654FA520-2BBF-4628-954E-256D9A680777}"/>
+                <a16:creationId xmlns:a16="http://schemas.microsoft.com/office/drawing/2014/main" id="{AC4CB11D-2EEE-4EE4-B92F-8B56F796CDED}"/>
               </a:ext>
             </a:extLst>
           </p:cNvPr>
@@ -5592,7 +5592,7 @@
           <p:cNvPr id="25" name="">
             <a:extLst xmlns:a="http://schemas.openxmlformats.org/drawingml/2006/main">
               <a:ext uri="{FF2B5EF4-FFF2-40B4-BE49-F238E27FC236}">
-                <a16:creationId xmlns:a16="http://schemas.microsoft.com/office/drawing/2014/main" id="{26FCFCEB-25B1-436F-B98D-01A2C5D46003}"/>
+                <a16:creationId xmlns:a16="http://schemas.microsoft.com/office/drawing/2014/main" id="{DDF3D0DA-7463-4D23-AEC7-5D6FA79EAC77}"/>
               </a:ext>
             </a:extLst>
           </p:cNvPr>
@@ -5653,7 +5653,7 @@
           <p:cNvPr id="26" name="">
             <a:extLst xmlns:a="http://schemas.openxmlformats.org/drawingml/2006/main">
               <a:ext uri="{FF2B5EF4-FFF2-40B4-BE49-F238E27FC236}">
-                <a16:creationId xmlns:a16="http://schemas.microsoft.com/office/drawing/2014/main" id="{94AB36B6-439A-4468-8B70-9D340447C882}"/>
+                <a16:creationId xmlns:a16="http://schemas.microsoft.com/office/drawing/2014/main" id="{066BB958-A245-431E-845C-AD186482E2C6}"/>
               </a:ext>
             </a:extLst>
           </p:cNvPr>
@@ -5712,7 +5712,7 @@
     </p:spTree>
     <p:extLst>
       <p:ext uri="{BB962C8B-B14F-4D97-AF65-F5344CB8AC3E}">
-        <p14:creationId xmlns:p14="http://schemas.microsoft.com/office/powerpoint/2010/main" val="1841576184"/>
+        <p14:creationId xmlns:p14="http://schemas.microsoft.com/office/powerpoint/2010/main" val="770079051"/>
       </p:ext>
     </p:extLst>
   </p:cSld>
@@ -5743,7 +5743,7 @@
           <p:cNvPr id="40" name="">
             <a:extLst xmlns:a="http://schemas.openxmlformats.org/drawingml/2006/main">
               <a:ext uri="{FF2B5EF4-FFF2-40B4-BE49-F238E27FC236}">
-                <a16:creationId xmlns:a16="http://schemas.microsoft.com/office/drawing/2014/main" id="{48FD35C2-19FE-4F2D-8F77-9BCBB1DBE825}"/>
+                <a16:creationId xmlns:a16="http://schemas.microsoft.com/office/drawing/2014/main" id="{C037EEE8-3808-4869-AE28-E90B317E1295}"/>
               </a:ext>
             </a:extLst>
           </p:cNvPr>
@@ -5804,7 +5804,7 @@
           <p:cNvPr id="2" name="">
             <a:extLst xmlns:a="http://schemas.openxmlformats.org/drawingml/2006/main">
               <a:ext uri="{FF2B5EF4-FFF2-40B4-BE49-F238E27FC236}">
-                <a16:creationId xmlns:a16="http://schemas.microsoft.com/office/drawing/2014/main" id="{5FCF306F-BD14-4782-89C5-9472D9D98896}"/>
+                <a16:creationId xmlns:a16="http://schemas.microsoft.com/office/drawing/2014/main" id="{6822DA65-F71A-4F2E-A845-221D990E2019}"/>
               </a:ext>
             </a:extLst>
           </p:cNvPr>
@@ -5865,7 +5865,7 @@
           <p:cNvPr id="3" name="">
             <a:extLst xmlns:a="http://schemas.openxmlformats.org/drawingml/2006/main">
               <a:ext uri="{FF2B5EF4-FFF2-40B4-BE49-F238E27FC236}">
-                <a16:creationId xmlns:a16="http://schemas.microsoft.com/office/drawing/2014/main" id="{B0889432-B36E-40E5-AACB-202CBCCB0EB1}"/>
+                <a16:creationId xmlns:a16="http://schemas.microsoft.com/office/drawing/2014/main" id="{B161D831-9E61-4B0F-BE4C-03AD5E7118B3}"/>
               </a:ext>
             </a:extLst>
           </p:cNvPr>
@@ -5895,7 +5895,7 @@
           <p:cNvPr id="4" name="">
             <a:extLst xmlns:a="http://schemas.openxmlformats.org/drawingml/2006/main">
               <a:ext uri="{FF2B5EF4-FFF2-40B4-BE49-F238E27FC236}">
-                <a16:creationId xmlns:a16="http://schemas.microsoft.com/office/drawing/2014/main" id="{E8C74475-5795-4BAF-BD26-A169D156432F}"/>
+                <a16:creationId xmlns:a16="http://schemas.microsoft.com/office/drawing/2014/main" id="{D549E0C4-6473-4C1C-B04A-6674B81C4A29}"/>
               </a:ext>
             </a:extLst>
           </p:cNvPr>
@@ -5956,7 +5956,7 @@
           <p:cNvPr id="5" name="">
             <a:extLst xmlns:a="http://schemas.openxmlformats.org/drawingml/2006/main">
               <a:ext uri="{FF2B5EF4-FFF2-40B4-BE49-F238E27FC236}">
-                <a16:creationId xmlns:a16="http://schemas.microsoft.com/office/drawing/2014/main" id="{B50AC870-8EE3-402E-9599-705D604B5318}"/>
+                <a16:creationId xmlns:a16="http://schemas.microsoft.com/office/drawing/2014/main" id="{C76F9BFC-3D37-4886-B325-FB3F825F0548}"/>
               </a:ext>
             </a:extLst>
           </p:cNvPr>
@@ -6017,7 +6017,7 @@
           <p:cNvPr id="6" name="">
             <a:extLst xmlns:a="http://schemas.openxmlformats.org/drawingml/2006/main">
               <a:ext uri="{FF2B5EF4-FFF2-40B4-BE49-F238E27FC236}">
-                <a16:creationId xmlns:a16="http://schemas.microsoft.com/office/drawing/2014/main" id="{8576C63D-F24A-47A1-988D-7720DD12FAB9}"/>
+                <a16:creationId xmlns:a16="http://schemas.microsoft.com/office/drawing/2014/main" id="{D73CB3F5-F0C2-4AA5-9FA0-8453BC05BE91}"/>
               </a:ext>
             </a:extLst>
           </p:cNvPr>
@@ -6049,7 +6049,7 @@
           <p:cNvPr id="7" name="">
             <a:extLst xmlns:a="http://schemas.openxmlformats.org/drawingml/2006/main">
               <a:ext uri="{FF2B5EF4-FFF2-40B4-BE49-F238E27FC236}">
-                <a16:creationId xmlns:a16="http://schemas.microsoft.com/office/drawing/2014/main" id="{C2764021-B480-4839-BEBE-9CDD1FA736DA}"/>
+                <a16:creationId xmlns:a16="http://schemas.microsoft.com/office/drawing/2014/main" id="{EC00262B-EC32-45ED-9FDD-CE5CC8A14772}"/>
               </a:ext>
             </a:extLst>
           </p:cNvPr>
@@ -6110,7 +6110,7 @@
           <p:cNvPr id="8" name="">
             <a:extLst xmlns:a="http://schemas.openxmlformats.org/drawingml/2006/main">
               <a:ext uri="{FF2B5EF4-FFF2-40B4-BE49-F238E27FC236}">
-                <a16:creationId xmlns:a16="http://schemas.microsoft.com/office/drawing/2014/main" id="{738B4951-3E70-451E-99F3-428E086B2075}"/>
+                <a16:creationId xmlns:a16="http://schemas.microsoft.com/office/drawing/2014/main" id="{96B9C2F7-164C-468D-A486-24BC838BC393}"/>
               </a:ext>
             </a:extLst>
           </p:cNvPr>
@@ -6171,7 +6171,7 @@
           <p:cNvPr id="9" name="">
             <a:extLst xmlns:a="http://schemas.openxmlformats.org/drawingml/2006/main">
               <a:ext uri="{FF2B5EF4-FFF2-40B4-BE49-F238E27FC236}">
-                <a16:creationId xmlns:a16="http://schemas.microsoft.com/office/drawing/2014/main" id="{F8D614E6-13CF-4D91-8102-1BD44CBACDFB}"/>
+                <a16:creationId xmlns:a16="http://schemas.microsoft.com/office/drawing/2014/main" id="{0243DC74-42C5-4DA2-A2D7-DDD0E4DB8698}"/>
               </a:ext>
             </a:extLst>
           </p:cNvPr>
@@ -6203,7 +6203,7 @@
           <p:cNvPr id="10" name="">
             <a:extLst xmlns:a="http://schemas.openxmlformats.org/drawingml/2006/main">
               <a:ext uri="{FF2B5EF4-FFF2-40B4-BE49-F238E27FC236}">
-                <a16:creationId xmlns:a16="http://schemas.microsoft.com/office/drawing/2014/main" id="{120CF150-FA5E-4527-A4C5-76861295BC39}"/>
+                <a16:creationId xmlns:a16="http://schemas.microsoft.com/office/drawing/2014/main" id="{8FEA0A7A-16FA-4BE6-BF7D-AC8A245273CB}"/>
               </a:ext>
             </a:extLst>
           </p:cNvPr>
@@ -6264,7 +6264,7 @@
           <p:cNvPr id="11" name="">
             <a:extLst xmlns:a="http://schemas.openxmlformats.org/drawingml/2006/main">
               <a:ext uri="{FF2B5EF4-FFF2-40B4-BE49-F238E27FC236}">
-                <a16:creationId xmlns:a16="http://schemas.microsoft.com/office/drawing/2014/main" id="{DAA7B077-3F5B-49AD-B3FC-3D90C9066A9E}"/>
+                <a16:creationId xmlns:a16="http://schemas.microsoft.com/office/drawing/2014/main" id="{66CC6515-38D2-44FA-B7A5-27511CEDBC89}"/>
               </a:ext>
             </a:extLst>
           </p:cNvPr>
@@ -6325,7 +6325,7 @@
           <p:cNvPr id="12" name="">
             <a:extLst xmlns:a="http://schemas.openxmlformats.org/drawingml/2006/main">
               <a:ext uri="{FF2B5EF4-FFF2-40B4-BE49-F238E27FC236}">
-                <a16:creationId xmlns:a16="http://schemas.microsoft.com/office/drawing/2014/main" id="{BA85AB36-F9FF-46DA-99C8-E1DBB47E41A3}"/>
+                <a16:creationId xmlns:a16="http://schemas.microsoft.com/office/drawing/2014/main" id="{C35500B1-AF91-4DA0-A610-C74C086AB7BB}"/>
               </a:ext>
             </a:extLst>
           </p:cNvPr>
@@ -6357,7 +6357,7 @@
           <p:cNvPr id="13" name="">
             <a:extLst xmlns:a="http://schemas.openxmlformats.org/drawingml/2006/main">
               <a:ext uri="{FF2B5EF4-FFF2-40B4-BE49-F238E27FC236}">
-                <a16:creationId xmlns:a16="http://schemas.microsoft.com/office/drawing/2014/main" id="{0A751A12-41E0-4EA3-A38B-67298BCA7530}"/>
+                <a16:creationId xmlns:a16="http://schemas.microsoft.com/office/drawing/2014/main" id="{2038C89A-6F56-41C5-8717-2EAC772DDB63}"/>
               </a:ext>
             </a:extLst>
           </p:cNvPr>
@@ -6418,7 +6418,7 @@
           <p:cNvPr id="14" name="">
             <a:extLst xmlns:a="http://schemas.openxmlformats.org/drawingml/2006/main">
               <a:ext uri="{FF2B5EF4-FFF2-40B4-BE49-F238E27FC236}">
-                <a16:creationId xmlns:a16="http://schemas.microsoft.com/office/drawing/2014/main" id="{5CC8411B-1DA9-4FFD-8DEB-86B240C0B680}"/>
+                <a16:creationId xmlns:a16="http://schemas.microsoft.com/office/drawing/2014/main" id="{0CBD7603-DBF8-4F43-8C90-BA384C142A57}"/>
               </a:ext>
             </a:extLst>
           </p:cNvPr>
@@ -6479,7 +6479,7 @@
           <p:cNvPr id="15" name="">
             <a:extLst xmlns:a="http://schemas.openxmlformats.org/drawingml/2006/main">
               <a:ext uri="{FF2B5EF4-FFF2-40B4-BE49-F238E27FC236}">
-                <a16:creationId xmlns:a16="http://schemas.microsoft.com/office/drawing/2014/main" id="{8BBE76AB-B720-48CC-9200-6C93D310B7F6}"/>
+                <a16:creationId xmlns:a16="http://schemas.microsoft.com/office/drawing/2014/main" id="{A34B8946-B6B7-483E-B777-02D6F11D006E}"/>
               </a:ext>
             </a:extLst>
           </p:cNvPr>
@@ -6511,7 +6511,7 @@
           <p:cNvPr id="16" name="">
             <a:extLst xmlns:a="http://schemas.openxmlformats.org/drawingml/2006/main">
               <a:ext uri="{FF2B5EF4-FFF2-40B4-BE49-F238E27FC236}">
-                <a16:creationId xmlns:a16="http://schemas.microsoft.com/office/drawing/2014/main" id="{070F8737-047D-4640-AEAD-9395EA85EA9B}"/>
+                <a16:creationId xmlns:a16="http://schemas.microsoft.com/office/drawing/2014/main" id="{5D9A6DD4-C878-4B45-9869-6F8A93CCF058}"/>
               </a:ext>
             </a:extLst>
           </p:cNvPr>
@@ -6599,7 +6599,7 @@
           <p:cNvPr id="17" name="">
             <a:extLst xmlns:a="http://schemas.openxmlformats.org/drawingml/2006/main">
               <a:ext uri="{FF2B5EF4-FFF2-40B4-BE49-F238E27FC236}">
-                <a16:creationId xmlns:a16="http://schemas.microsoft.com/office/drawing/2014/main" id="{2CDEE4C3-44A7-4520-AAC3-09890520DFED}"/>
+                <a16:creationId xmlns:a16="http://schemas.microsoft.com/office/drawing/2014/main" id="{C647BD97-126C-4AF9-9BB5-0543F72D458C}"/>
               </a:ext>
             </a:extLst>
           </p:cNvPr>
@@ -6660,7 +6660,7 @@
           <p:cNvPr id="18" name="">
             <a:extLst xmlns:a="http://schemas.openxmlformats.org/drawingml/2006/main">
               <a:ext uri="{FF2B5EF4-FFF2-40B4-BE49-F238E27FC236}">
-                <a16:creationId xmlns:a16="http://schemas.microsoft.com/office/drawing/2014/main" id="{EA4479F8-332C-4C47-A735-538523AA6B27}"/>
+                <a16:creationId xmlns:a16="http://schemas.microsoft.com/office/drawing/2014/main" id="{C2AD3223-F1DA-4BDD-829E-A2178D71FEF7}"/>
               </a:ext>
             </a:extLst>
           </p:cNvPr>
@@ -6692,7 +6692,7 @@
           <p:cNvPr id="19" name="">
             <a:extLst xmlns:a="http://schemas.openxmlformats.org/drawingml/2006/main">
               <a:ext uri="{FF2B5EF4-FFF2-40B4-BE49-F238E27FC236}">
-                <a16:creationId xmlns:a16="http://schemas.microsoft.com/office/drawing/2014/main" id="{9419308F-70E1-4D1D-95C4-BAE81E04621E}"/>
+                <a16:creationId xmlns:a16="http://schemas.microsoft.com/office/drawing/2014/main" id="{B04EAB9B-57F8-4EA8-9FB5-50DDB1EAA3D1}"/>
               </a:ext>
             </a:extLst>
           </p:cNvPr>
@@ -6753,7 +6753,7 @@
           <p:cNvPr id="20" name="">
             <a:extLst xmlns:a="http://schemas.openxmlformats.org/drawingml/2006/main">
               <a:ext uri="{FF2B5EF4-FFF2-40B4-BE49-F238E27FC236}">
-                <a16:creationId xmlns:a16="http://schemas.microsoft.com/office/drawing/2014/main" id="{45CBD3A4-4099-4B51-A058-5E94510B2175}"/>
+                <a16:creationId xmlns:a16="http://schemas.microsoft.com/office/drawing/2014/main" id="{A640E52C-078A-4535-BAFA-2098CA1A7C9A}"/>
               </a:ext>
             </a:extLst>
           </p:cNvPr>
@@ -6785,7 +6785,7 @@
           <p:cNvPr id="21" name="">
             <a:extLst xmlns:a="http://schemas.openxmlformats.org/drawingml/2006/main">
               <a:ext uri="{FF2B5EF4-FFF2-40B4-BE49-F238E27FC236}">
-                <a16:creationId xmlns:a16="http://schemas.microsoft.com/office/drawing/2014/main" id="{00B9C938-9B7C-425E-A4EB-04505B113645}"/>
+                <a16:creationId xmlns:a16="http://schemas.microsoft.com/office/drawing/2014/main" id="{7683C85E-4B9B-4E40-A4A9-03318B1761FB}"/>
               </a:ext>
             </a:extLst>
           </p:cNvPr>
@@ -6846,7 +6846,7 @@
           <p:cNvPr id="22" name="">
             <a:extLst xmlns:a="http://schemas.openxmlformats.org/drawingml/2006/main">
               <a:ext uri="{FF2B5EF4-FFF2-40B4-BE49-F238E27FC236}">
-                <a16:creationId xmlns:a16="http://schemas.microsoft.com/office/drawing/2014/main" id="{9D38E2EE-6BDF-4C6B-8A4D-27F4B8778C29}"/>
+                <a16:creationId xmlns:a16="http://schemas.microsoft.com/office/drawing/2014/main" id="{5B07C8DA-2839-496A-8F53-C608912E88A0}"/>
               </a:ext>
             </a:extLst>
           </p:cNvPr>
@@ -6907,7 +6907,7 @@
           <p:cNvPr id="23" name="">
             <a:extLst xmlns:a="http://schemas.openxmlformats.org/drawingml/2006/main">
               <a:ext uri="{FF2B5EF4-FFF2-40B4-BE49-F238E27FC236}">
-                <a16:creationId xmlns:a16="http://schemas.microsoft.com/office/drawing/2014/main" id="{52225722-0FD2-4430-BC55-715CFFBCA5A4}"/>
+                <a16:creationId xmlns:a16="http://schemas.microsoft.com/office/drawing/2014/main" id="{6A5CDEB4-5AF2-4675-9036-2E870BAA1735}"/>
               </a:ext>
             </a:extLst>
           </p:cNvPr>
@@ -6968,7 +6968,7 @@
           <p:cNvPr id="24" name="">
             <a:extLst xmlns:a="http://schemas.openxmlformats.org/drawingml/2006/main">
               <a:ext uri="{FF2B5EF4-FFF2-40B4-BE49-F238E27FC236}">
-                <a16:creationId xmlns:a16="http://schemas.microsoft.com/office/drawing/2014/main" id="{70D7CD5F-20F3-42AA-A868-236EBF1F73F4}"/>
+                <a16:creationId xmlns:a16="http://schemas.microsoft.com/office/drawing/2014/main" id="{BFB80B35-7939-4145-90AE-359772FDA796}"/>
               </a:ext>
             </a:extLst>
           </p:cNvPr>
@@ -7000,7 +7000,7 @@
           <p:cNvPr id="25" name="">
             <a:extLst xmlns:a="http://schemas.openxmlformats.org/drawingml/2006/main">
               <a:ext uri="{FF2B5EF4-FFF2-40B4-BE49-F238E27FC236}">
-                <a16:creationId xmlns:a16="http://schemas.microsoft.com/office/drawing/2014/main" id="{858FA0CE-1B44-478E-87A8-5755B50321A7}"/>
+                <a16:creationId xmlns:a16="http://schemas.microsoft.com/office/drawing/2014/main" id="{1778B282-6AC8-47FF-989C-363435E8A68A}"/>
               </a:ext>
             </a:extLst>
           </p:cNvPr>
@@ -7061,7 +7061,7 @@
           <p:cNvPr id="26" name="">
             <a:extLst xmlns:a="http://schemas.openxmlformats.org/drawingml/2006/main">
               <a:ext uri="{FF2B5EF4-FFF2-40B4-BE49-F238E27FC236}">
-                <a16:creationId xmlns:a16="http://schemas.microsoft.com/office/drawing/2014/main" id="{868AF502-8F97-42CF-9461-F8B36602768B}"/>
+                <a16:creationId xmlns:a16="http://schemas.microsoft.com/office/drawing/2014/main" id="{3E6A2574-CBE6-4EE7-856A-996EA0CA7770}"/>
               </a:ext>
             </a:extLst>
           </p:cNvPr>
@@ -7093,7 +7093,7 @@
           <p:cNvPr id="27" name="">
             <a:extLst xmlns:a="http://schemas.openxmlformats.org/drawingml/2006/main">
               <a:ext uri="{FF2B5EF4-FFF2-40B4-BE49-F238E27FC236}">
-                <a16:creationId xmlns:a16="http://schemas.microsoft.com/office/drawing/2014/main" id="{FC06F6F3-E875-4E86-9CAE-C2454EBFFCF2}"/>
+                <a16:creationId xmlns:a16="http://schemas.microsoft.com/office/drawing/2014/main" id="{2954DD96-BFFF-4311-85F5-5A29F0263E47}"/>
               </a:ext>
             </a:extLst>
           </p:cNvPr>
@@ -7154,7 +7154,7 @@
           <p:cNvPr id="28" name="">
             <a:extLst xmlns:a="http://schemas.openxmlformats.org/drawingml/2006/main">
               <a:ext uri="{FF2B5EF4-FFF2-40B4-BE49-F238E27FC236}">
-                <a16:creationId xmlns:a16="http://schemas.microsoft.com/office/drawing/2014/main" id="{5F3459C9-C864-45A6-A9ED-F88C453F5DE3}"/>
+                <a16:creationId xmlns:a16="http://schemas.microsoft.com/office/drawing/2014/main" id="{D0EB9ED5-EF9D-421F-B0F0-19FCEFA8076B}"/>
               </a:ext>
             </a:extLst>
           </p:cNvPr>
@@ -7215,7 +7215,7 @@
           <p:cNvPr id="29" name="">
             <a:extLst xmlns:a="http://schemas.openxmlformats.org/drawingml/2006/main">
               <a:ext uri="{FF2B5EF4-FFF2-40B4-BE49-F238E27FC236}">
-                <a16:creationId xmlns:a16="http://schemas.microsoft.com/office/drawing/2014/main" id="{1C487A14-0ADE-437D-922C-FD69F790DF71}"/>
+                <a16:creationId xmlns:a16="http://schemas.microsoft.com/office/drawing/2014/main" id="{7B706AB8-9C02-42D8-8E06-0B571596CA9C}"/>
               </a:ext>
             </a:extLst>
           </p:cNvPr>
@@ -7276,7 +7276,7 @@
           <p:cNvPr id="30" name="">
             <a:extLst xmlns:a="http://schemas.openxmlformats.org/drawingml/2006/main">
               <a:ext uri="{FF2B5EF4-FFF2-40B4-BE49-F238E27FC236}">
-                <a16:creationId xmlns:a16="http://schemas.microsoft.com/office/drawing/2014/main" id="{E10D1214-D001-448E-A6D7-9E06174EB4D8}"/>
+                <a16:creationId xmlns:a16="http://schemas.microsoft.com/office/drawing/2014/main" id="{E84D5C03-4857-442E-98E8-38E5A6E8A6FB}"/>
               </a:ext>
             </a:extLst>
           </p:cNvPr>
@@ -7308,7 +7308,7 @@
           <p:cNvPr id="31" name="">
             <a:extLst xmlns:a="http://schemas.openxmlformats.org/drawingml/2006/main">
               <a:ext uri="{FF2B5EF4-FFF2-40B4-BE49-F238E27FC236}">
-                <a16:creationId xmlns:a16="http://schemas.microsoft.com/office/drawing/2014/main" id="{A107D2EE-6E42-4C99-B549-3C614986BAD5}"/>
+                <a16:creationId xmlns:a16="http://schemas.microsoft.com/office/drawing/2014/main" id="{A41567FE-78A0-4097-BAD2-763ACF5AEE73}"/>
               </a:ext>
             </a:extLst>
           </p:cNvPr>
@@ -7396,7 +7396,7 @@
           <p:cNvPr id="32" name="">
             <a:extLst xmlns:a="http://schemas.openxmlformats.org/drawingml/2006/main">
               <a:ext uri="{FF2B5EF4-FFF2-40B4-BE49-F238E27FC236}">
-                <a16:creationId xmlns:a16="http://schemas.microsoft.com/office/drawing/2014/main" id="{CCB073BD-8E7E-43EC-B3E0-9F650B9F9667}"/>
+                <a16:creationId xmlns:a16="http://schemas.microsoft.com/office/drawing/2014/main" id="{3DAC3AB0-8061-4088-986A-4D03B1B06A90}"/>
               </a:ext>
             </a:extLst>
           </p:cNvPr>
@@ -7457,7 +7457,7 @@
           <p:cNvPr id="33" name="">
             <a:extLst xmlns:a="http://schemas.openxmlformats.org/drawingml/2006/main">
               <a:ext uri="{FF2B5EF4-FFF2-40B4-BE49-F238E27FC236}">
-                <a16:creationId xmlns:a16="http://schemas.microsoft.com/office/drawing/2014/main" id="{A18B648B-2661-4605-9154-3EF23A2FC753}"/>
+                <a16:creationId xmlns:a16="http://schemas.microsoft.com/office/drawing/2014/main" id="{A6C38CAB-CC82-44A4-93BD-C1A2D0F1FDF5}"/>
               </a:ext>
             </a:extLst>
           </p:cNvPr>
@@ -7489,7 +7489,7 @@
           <p:cNvPr id="34" name="">
             <a:extLst xmlns:a="http://schemas.openxmlformats.org/drawingml/2006/main">
               <a:ext uri="{FF2B5EF4-FFF2-40B4-BE49-F238E27FC236}">
-                <a16:creationId xmlns:a16="http://schemas.microsoft.com/office/drawing/2014/main" id="{30317F52-631F-4809-883B-90DE97027F70}"/>
+                <a16:creationId xmlns:a16="http://schemas.microsoft.com/office/drawing/2014/main" id="{061DD26D-47C4-46E9-AD51-5D722AAB7A1B}"/>
               </a:ext>
             </a:extLst>
           </p:cNvPr>
@@ -7550,7 +7550,7 @@
           <p:cNvPr id="35" name="">
             <a:extLst xmlns:a="http://schemas.openxmlformats.org/drawingml/2006/main">
               <a:ext uri="{FF2B5EF4-FFF2-40B4-BE49-F238E27FC236}">
-                <a16:creationId xmlns:a16="http://schemas.microsoft.com/office/drawing/2014/main" id="{BB5FF63E-E4C3-4586-8C6C-90987A9278A5}"/>
+                <a16:creationId xmlns:a16="http://schemas.microsoft.com/office/drawing/2014/main" id="{FD33D464-FC42-49B8-8899-C1D7718AB4ED}"/>
               </a:ext>
             </a:extLst>
           </p:cNvPr>
@@ -7611,7 +7611,7 @@
           <p:cNvPr id="36" name="">
             <a:extLst xmlns:a="http://schemas.openxmlformats.org/drawingml/2006/main">
               <a:ext uri="{FF2B5EF4-FFF2-40B4-BE49-F238E27FC236}">
-                <a16:creationId xmlns:a16="http://schemas.microsoft.com/office/drawing/2014/main" id="{C450F3B0-945E-4361-8094-235F28B8ED6E}"/>
+                <a16:creationId xmlns:a16="http://schemas.microsoft.com/office/drawing/2014/main" id="{93FC4ECD-F866-4217-A3E6-8B7E478B74CB}"/>
               </a:ext>
             </a:extLst>
           </p:cNvPr>
@@ -7643,7 +7643,7 @@
           <p:cNvPr id="37" name="">
             <a:extLst xmlns:a="http://schemas.openxmlformats.org/drawingml/2006/main">
               <a:ext uri="{FF2B5EF4-FFF2-40B4-BE49-F238E27FC236}">
-                <a16:creationId xmlns:a16="http://schemas.microsoft.com/office/drawing/2014/main" id="{68F7B7EF-95B8-4A81-AFB9-F1FE3712DB6F}"/>
+                <a16:creationId xmlns:a16="http://schemas.microsoft.com/office/drawing/2014/main" id="{CB94E518-DFFD-40E5-9CAC-95B92449CD4D}"/>
               </a:ext>
             </a:extLst>
           </p:cNvPr>
@@ -7731,7 +7731,7 @@
           <p:cNvPr id="38" name="">
             <a:extLst xmlns:a="http://schemas.openxmlformats.org/drawingml/2006/main">
               <a:ext uri="{FF2B5EF4-FFF2-40B4-BE49-F238E27FC236}">
-                <a16:creationId xmlns:a16="http://schemas.microsoft.com/office/drawing/2014/main" id="{8FD8583D-657F-45A8-91B4-50B93EEB57D4}"/>
+                <a16:creationId xmlns:a16="http://schemas.microsoft.com/office/drawing/2014/main" id="{20D963BF-0E81-4BE3-BC2D-078EF8DACDF3}"/>
               </a:ext>
             </a:extLst>
           </p:cNvPr>
@@ -7763,7 +7763,7 @@
           <p:cNvPr id="39" name="">
             <a:extLst xmlns:a="http://schemas.openxmlformats.org/drawingml/2006/main">
               <a:ext uri="{FF2B5EF4-FFF2-40B4-BE49-F238E27FC236}">
-                <a16:creationId xmlns:a16="http://schemas.microsoft.com/office/drawing/2014/main" id="{AACC2F2E-F0BE-43B7-B536-E008BDF47FC2}"/>
+                <a16:creationId xmlns:a16="http://schemas.microsoft.com/office/drawing/2014/main" id="{28746196-A20D-4A53-A751-1C6D45710E15}"/>
               </a:ext>
             </a:extLst>
           </p:cNvPr>
@@ -7814,7 +7814,7 @@
                 <a:ea typeface="Arial"/>
                 <a:cs typeface="Arial"/>
               </a:rPr>
-              <a:t>FusionVI-X readout: latent z  +  remaining 36 ADTs  +  marker RNA proxy  →  hidden surface marker</a:t>
+              <a:t>FusionVI-X readout: latent z  +  remaining proteins  +  marker RNA proxy  →  hidden surface marker</a:t>
             </a:r>
           </a:p>
         </p:txBody>
@@ -7822,7 +7822,7 @@
     </p:spTree>
     <p:extLst>
       <p:ext uri="{BB962C8B-B14F-4D97-AF65-F5344CB8AC3E}">
-        <p14:creationId xmlns:p14="http://schemas.microsoft.com/office/powerpoint/2010/main" val="1322528192"/>
+        <p14:creationId xmlns:p14="http://schemas.microsoft.com/office/powerpoint/2010/main" val="1319516388"/>
       </p:ext>
     </p:extLst>
   </p:cSld>
@@ -7853,7 +7853,7 @@
           <p:cNvPr id="25" name="">
             <a:extLst xmlns:a="http://schemas.openxmlformats.org/drawingml/2006/main">
               <a:ext uri="{FF2B5EF4-FFF2-40B4-BE49-F238E27FC236}">
-                <a16:creationId xmlns:a16="http://schemas.microsoft.com/office/drawing/2014/main" id="{1461D347-FDC3-44BA-A547-A4C9FD7510FD}"/>
+                <a16:creationId xmlns:a16="http://schemas.microsoft.com/office/drawing/2014/main" id="{4A5F9E26-F251-4E6C-BEAF-007C0943791A}"/>
               </a:ext>
             </a:extLst>
           </p:cNvPr>
@@ -7914,7 +7914,7 @@
           <p:cNvPr id="2" name="">
             <a:extLst xmlns:a="http://schemas.openxmlformats.org/drawingml/2006/main">
               <a:ext uri="{FF2B5EF4-FFF2-40B4-BE49-F238E27FC236}">
-                <a16:creationId xmlns:a16="http://schemas.microsoft.com/office/drawing/2014/main" id="{A3B545DE-9DEE-4B31-8906-C63E73083194}"/>
+                <a16:creationId xmlns:a16="http://schemas.microsoft.com/office/drawing/2014/main" id="{2C80DA13-14BA-4AF2-A59E-0FE6CE6AA6EF}"/>
               </a:ext>
             </a:extLst>
           </p:cNvPr>
@@ -7975,7 +7975,7 @@
           <p:cNvPr id="3" name="">
             <a:extLst xmlns:a="http://schemas.openxmlformats.org/drawingml/2006/main">
               <a:ext uri="{FF2B5EF4-FFF2-40B4-BE49-F238E27FC236}">
-                <a16:creationId xmlns:a16="http://schemas.microsoft.com/office/drawing/2014/main" id="{AA17AC17-CFEF-4256-B715-A1400095E862}"/>
+                <a16:creationId xmlns:a16="http://schemas.microsoft.com/office/drawing/2014/main" id="{BCAD54A9-9F6D-4D65-9C10-E006D0F2760F}"/>
               </a:ext>
             </a:extLst>
           </p:cNvPr>
@@ -8005,7 +8005,7 @@
           <p:cNvPr id="4" name="">
             <a:extLst xmlns:a="http://schemas.openxmlformats.org/drawingml/2006/main">
               <a:ext uri="{FF2B5EF4-FFF2-40B4-BE49-F238E27FC236}">
-                <a16:creationId xmlns:a16="http://schemas.microsoft.com/office/drawing/2014/main" id="{FEE0D635-3837-4617-B052-B86126B0EF5C}"/>
+                <a16:creationId xmlns:a16="http://schemas.microsoft.com/office/drawing/2014/main" id="{CF6DC2D8-7E02-47B3-92F1-A3DB18F35F91}"/>
               </a:ext>
             </a:extLst>
           </p:cNvPr>
@@ -8066,7 +8066,7 @@
           <p:cNvPr id="5" name="">
             <a:extLst xmlns:a="http://schemas.openxmlformats.org/drawingml/2006/main">
               <a:ext uri="{FF2B5EF4-FFF2-40B4-BE49-F238E27FC236}">
-                <a16:creationId xmlns:a16="http://schemas.microsoft.com/office/drawing/2014/main" id="{22C4A8A8-F040-4630-AAE5-C019A740AA7B}"/>
+                <a16:creationId xmlns:a16="http://schemas.microsoft.com/office/drawing/2014/main" id="{B8F7659B-0EDB-4ABB-A641-F113461B4F40}"/>
               </a:ext>
             </a:extLst>
           </p:cNvPr>
@@ -8127,7 +8127,7 @@
           <p:cNvPr id="6" name="">
             <a:extLst xmlns:a="http://schemas.openxmlformats.org/drawingml/2006/main">
               <a:ext uri="{FF2B5EF4-FFF2-40B4-BE49-F238E27FC236}">
-                <a16:creationId xmlns:a16="http://schemas.microsoft.com/office/drawing/2014/main" id="{3628AF3A-FF1D-4D8A-9AAF-0CE4797F3AD6}"/>
+                <a16:creationId xmlns:a16="http://schemas.microsoft.com/office/drawing/2014/main" id="{8EB8B9F7-DFDF-44FD-8D89-47FA15816CA0}"/>
               </a:ext>
             </a:extLst>
           </p:cNvPr>
@@ -8188,7 +8188,7 @@
           <p:cNvPr id="7" name="">
             <a:extLst xmlns:a="http://schemas.openxmlformats.org/drawingml/2006/main">
               <a:ext uri="{FF2B5EF4-FFF2-40B4-BE49-F238E27FC236}">
-                <a16:creationId xmlns:a16="http://schemas.microsoft.com/office/drawing/2014/main" id="{D7ECBA81-ED39-4C65-8DB2-A80DF602FDE9}"/>
+                <a16:creationId xmlns:a16="http://schemas.microsoft.com/office/drawing/2014/main" id="{7D339A4E-F61C-46A7-AB88-1F6D1895DFBA}"/>
               </a:ext>
             </a:extLst>
           </p:cNvPr>
@@ -8239,7 +8239,7 @@
                 <a:ea typeface="Arial"/>
                 <a:cs typeface="Arial"/>
               </a:rPr>
-              <a:t>CD25, CD69 and HLA-DR are zeroed at encoder input, then reconstructed by the decoder.</a:t>
+              <a:t>CD25, CD69, HLA-DR or PD-L1 is zeroed at encoder input, then reconstructed without copying the target.</a:t>
             </a:r>
           </a:p>
         </p:txBody>
@@ -8249,7 +8249,7 @@
           <p:cNvPr id="8" name="">
             <a:extLst xmlns:a="http://schemas.openxmlformats.org/drawingml/2006/main">
               <a:ext uri="{FF2B5EF4-FFF2-40B4-BE49-F238E27FC236}">
-                <a16:creationId xmlns:a16="http://schemas.microsoft.com/office/drawing/2014/main" id="{6011E3E2-E633-41CC-8D7B-DDEFC22E2BB3}"/>
+                <a16:creationId xmlns:a16="http://schemas.microsoft.com/office/drawing/2014/main" id="{A8CB1ABA-DF1B-41B3-AE11-E813228F028B}"/>
               </a:ext>
             </a:extLst>
           </p:cNvPr>
@@ -8310,7 +8310,7 @@
           <p:cNvPr id="9" name="">
             <a:extLst xmlns:a="http://schemas.openxmlformats.org/drawingml/2006/main">
               <a:ext uri="{FF2B5EF4-FFF2-40B4-BE49-F238E27FC236}">
-                <a16:creationId xmlns:a16="http://schemas.microsoft.com/office/drawing/2014/main" id="{5844FCFC-2CDE-44CE-8219-C9CA7FAA7B3B}"/>
+                <a16:creationId xmlns:a16="http://schemas.microsoft.com/office/drawing/2014/main" id="{DC412774-56AB-4A69-B24B-20CFA5FB927A}"/>
               </a:ext>
             </a:extLst>
           </p:cNvPr>
@@ -8361,7 +8361,7 @@
                 <a:ea typeface="Arial"/>
                 <a:cs typeface="Arial"/>
               </a:rPr>
-              <a:t>Select the readout inside training donors</a:t>
+              <a:t>Select the readout inside training groups</a:t>
             </a:r>
           </a:p>
         </p:txBody>
@@ -8371,7 +8371,7 @@
           <p:cNvPr id="10" name="">
             <a:extLst xmlns:a="http://schemas.openxmlformats.org/drawingml/2006/main">
               <a:ext uri="{FF2B5EF4-FFF2-40B4-BE49-F238E27FC236}">
-                <a16:creationId xmlns:a16="http://schemas.microsoft.com/office/drawing/2014/main" id="{5CA14B9A-9C89-4143-8BCC-6829743E461C}"/>
+                <a16:creationId xmlns:a16="http://schemas.microsoft.com/office/drawing/2014/main" id="{6F25B0CB-56FB-4EF0-909D-3A63F3051A86}"/>
               </a:ext>
             </a:extLst>
           </p:cNvPr>
@@ -8395,7 +8395,7 @@
         </p:spPr>
         <p:txBody>
           <a:bodyPr xmlns:a="http://schemas.openxmlformats.org/drawingml/2006/main" anchor="t">
-            <a:normAutofit fontScale="96155"/>
+            <a:normAutofit fontScale="100000"/>
           </a:bodyPr>
           <a:lstStyle xmlns:a="http://schemas.openxmlformats.org/drawingml/2006/main"/>
           <a:p xmlns:a="http://schemas.openxmlformats.org/drawingml/2006/main">
@@ -8422,7 +8422,7 @@
                 <a:ea typeface="Arial"/>
                 <a:cs typeface="Arial"/>
               </a:rPr>
-              <a:t>Three grouped inner folds choose Ridge, gradient boosting or Extra Trees; the outer donor is never used.</a:t>
+              <a:t>Inner grouped validation chooses the head; the outer donor or CRISPR target is never used.</a:t>
             </a:r>
           </a:p>
         </p:txBody>
@@ -8432,7 +8432,7 @@
           <p:cNvPr id="11" name="">
             <a:extLst xmlns:a="http://schemas.openxmlformats.org/drawingml/2006/main">
               <a:ext uri="{FF2B5EF4-FFF2-40B4-BE49-F238E27FC236}">
-                <a16:creationId xmlns:a16="http://schemas.microsoft.com/office/drawing/2014/main" id="{EFB234E7-CF17-44D5-9193-5D37417D466E}"/>
+                <a16:creationId xmlns:a16="http://schemas.microsoft.com/office/drawing/2014/main" id="{463937FC-9B07-45D7-BCED-7BB87CE5544A}"/>
               </a:ext>
             </a:extLst>
           </p:cNvPr>
@@ -8462,7 +8462,7 @@
           <p:cNvPr id="12" name="">
             <a:extLst xmlns:a="http://schemas.openxmlformats.org/drawingml/2006/main">
               <a:ext uri="{FF2B5EF4-FFF2-40B4-BE49-F238E27FC236}">
-                <a16:creationId xmlns:a16="http://schemas.microsoft.com/office/drawing/2014/main" id="{3A836D6D-2353-482C-9ECE-774F05195077}"/>
+                <a16:creationId xmlns:a16="http://schemas.microsoft.com/office/drawing/2014/main" id="{A5A4A088-4BCB-4F75-8886-97228982A282}"/>
               </a:ext>
             </a:extLst>
           </p:cNvPr>
@@ -8523,7 +8523,7 @@
           <p:cNvPr id="13" name="">
             <a:extLst xmlns:a="http://schemas.openxmlformats.org/drawingml/2006/main">
               <a:ext uri="{FF2B5EF4-FFF2-40B4-BE49-F238E27FC236}">
-                <a16:creationId xmlns:a16="http://schemas.microsoft.com/office/drawing/2014/main" id="{C2035A10-D688-4CD2-B8AC-22E6108FF756}"/>
+                <a16:creationId xmlns:a16="http://schemas.microsoft.com/office/drawing/2014/main" id="{49B4360B-6A77-48B4-AC6B-A9FA2D829011}"/>
               </a:ext>
             </a:extLst>
           </p:cNvPr>
@@ -8555,7 +8555,7 @@
           <p:cNvPr id="14" name="">
             <a:extLst xmlns:a="http://schemas.openxmlformats.org/drawingml/2006/main">
               <a:ext uri="{FF2B5EF4-FFF2-40B4-BE49-F238E27FC236}">
-                <a16:creationId xmlns:a16="http://schemas.microsoft.com/office/drawing/2014/main" id="{A140B11C-6449-452F-8CE4-2548030936B8}"/>
+                <a16:creationId xmlns:a16="http://schemas.microsoft.com/office/drawing/2014/main" id="{E6142622-5DEC-4683-BDBB-B14FF846D4BF}"/>
               </a:ext>
             </a:extLst>
           </p:cNvPr>
@@ -8616,7 +8616,7 @@
           <p:cNvPr id="15" name="">
             <a:extLst xmlns:a="http://schemas.openxmlformats.org/drawingml/2006/main">
               <a:ext uri="{FF2B5EF4-FFF2-40B4-BE49-F238E27FC236}">
-                <a16:creationId xmlns:a16="http://schemas.microsoft.com/office/drawing/2014/main" id="{E8FD9975-11E8-4C7D-9B17-45015DD35173}"/>
+                <a16:creationId xmlns:a16="http://schemas.microsoft.com/office/drawing/2014/main" id="{262124C6-C34D-4A64-B980-743CFCCCA70F}"/>
               </a:ext>
             </a:extLst>
           </p:cNvPr>
@@ -8648,7 +8648,7 @@
           <p:cNvPr id="16" name="">
             <a:extLst xmlns:a="http://schemas.openxmlformats.org/drawingml/2006/main">
               <a:ext uri="{FF2B5EF4-FFF2-40B4-BE49-F238E27FC236}">
-                <a16:creationId xmlns:a16="http://schemas.microsoft.com/office/drawing/2014/main" id="{2F6B0A6B-BA3A-45ED-9C3E-514EDBED0BB6}"/>
+                <a16:creationId xmlns:a16="http://schemas.microsoft.com/office/drawing/2014/main" id="{3E4E38EE-7C16-4DCD-BC31-1967E24E7C02}"/>
               </a:ext>
             </a:extLst>
           </p:cNvPr>
@@ -8709,7 +8709,7 @@
           <p:cNvPr id="17" name="">
             <a:extLst xmlns:a="http://schemas.openxmlformats.org/drawingml/2006/main">
               <a:ext uri="{FF2B5EF4-FFF2-40B4-BE49-F238E27FC236}">
-                <a16:creationId xmlns:a16="http://schemas.microsoft.com/office/drawing/2014/main" id="{E558E129-AF87-48EB-A9F4-EC9931BEC9A5}"/>
+                <a16:creationId xmlns:a16="http://schemas.microsoft.com/office/drawing/2014/main" id="{A72051D6-3E38-441C-9E90-BA7D53F7ADC7}"/>
               </a:ext>
             </a:extLst>
           </p:cNvPr>
@@ -8729,7 +8729,7 @@
             </a:avLst>
           </a:prstGeom>
           <a:solidFill xmlns:a="http://schemas.openxmlformats.org/drawingml/2006/main">
-            <a:srgbClr val="DDF3F2"/>
+            <a:srgbClr val="EEE7FF"/>
           </a:solidFill>
           <a:ln xmlns:a="http://schemas.openxmlformats.org/drawingml/2006/main" w="0">
             <a:noFill/>
@@ -8741,7 +8741,7 @@
           <p:cNvPr id="18" name="">
             <a:extLst xmlns:a="http://schemas.openxmlformats.org/drawingml/2006/main">
               <a:ext uri="{FF2B5EF4-FFF2-40B4-BE49-F238E27FC236}">
-                <a16:creationId xmlns:a16="http://schemas.microsoft.com/office/drawing/2014/main" id="{2B0A608B-BC4C-44BC-9D40-BA06C6608E62}"/>
+                <a16:creationId xmlns:a16="http://schemas.microsoft.com/office/drawing/2014/main" id="{A1400C4C-9B43-4F71-B965-4B6275894DBA}"/>
               </a:ext>
             </a:extLst>
           </p:cNvPr>
@@ -8776,7 +8776,7 @@
               <a:buNone/>
               <a:defRPr sz="1200" b="1">
                 <a:solidFill>
-                  <a:srgbClr val="0D8A9A"/>
+                  <a:srgbClr val="6C3ED9"/>
                 </a:solidFill>
                 <a:latin typeface="Arial"/>
                 <a:ea typeface="Arial"/>
@@ -8786,13 +8786,13 @@
             <a:r>
               <a:rPr sz="1200" b="1">
                 <a:solidFill>
-                  <a:srgbClr val="0D8A9A"/>
-                </a:solidFill>
-                <a:latin typeface="Arial"/>
-                <a:ea typeface="Arial"/>
-                <a:cs typeface="Arial"/>
-              </a:rPr>
-              <a:t>NK + B indirect response</a:t>
+                  <a:srgbClr val="6C3ED9"/>
+                </a:solidFill>
+                <a:latin typeface="Arial"/>
+                <a:ea typeface="Arial"/>
+                <a:cs typeface="Arial"/>
+              </a:rPr>
+              <a:t>Unseen CRISPR targets</a:t>
             </a:r>
           </a:p>
         </p:txBody>
@@ -8802,7 +8802,7 @@
           <p:cNvPr id="19" name="">
             <a:extLst xmlns:a="http://schemas.openxmlformats.org/drawingml/2006/main">
               <a:ext uri="{FF2B5EF4-FFF2-40B4-BE49-F238E27FC236}">
-                <a16:creationId xmlns:a16="http://schemas.microsoft.com/office/drawing/2014/main" id="{D24512E6-8561-436B-91DF-E4F632D36673}"/>
+                <a16:creationId xmlns:a16="http://schemas.microsoft.com/office/drawing/2014/main" id="{AD7B495B-B0CC-4C1B-BEA6-97F4EE51FB1F}"/>
               </a:ext>
             </a:extLst>
           </p:cNvPr>
@@ -8814,7 +8814,7 @@
         <p:spPr>
           <a:xfrm xmlns:a="http://schemas.openxmlformats.org/drawingml/2006/main">
             <a:off x="8534400" y="3771900"/>
-            <a:ext cx="2095500" cy="361950"/>
+            <a:ext cx="2286000" cy="361950"/>
           </a:xfrm>
           <a:prstGeom xmlns:a="http://schemas.openxmlformats.org/drawingml/2006/main" prst="roundRect">
             <a:avLst>
@@ -8834,7 +8834,7 @@
           <p:cNvPr id="20" name="">
             <a:extLst xmlns:a="http://schemas.openxmlformats.org/drawingml/2006/main">
               <a:ext uri="{FF2B5EF4-FFF2-40B4-BE49-F238E27FC236}">
-                <a16:creationId xmlns:a16="http://schemas.microsoft.com/office/drawing/2014/main" id="{76D321C5-A56D-45FA-9B85-572093F62012}"/>
+                <a16:creationId xmlns:a16="http://schemas.microsoft.com/office/drawing/2014/main" id="{AE017E41-FF95-4F54-9CDA-785BA01B87F1}"/>
               </a:ext>
             </a:extLst>
           </p:cNvPr>
@@ -8846,7 +8846,7 @@
         <p:spPr>
           <a:xfrm xmlns:a="http://schemas.openxmlformats.org/drawingml/2006/main">
             <a:off x="8610600" y="3819525"/>
-            <a:ext cx="1943100" cy="266700"/>
+            <a:ext cx="2133600" cy="266700"/>
           </a:xfrm>
           <a:prstGeom xmlns:a="http://schemas.openxmlformats.org/drawingml/2006/main" prst="rect">
             <a:avLst/>
@@ -8885,7 +8885,7 @@
                 <a:ea typeface="Arial"/>
                 <a:cs typeface="Arial"/>
               </a:rPr>
-              <a:t>Discordant cells</a:t>
+              <a:t>Discordant RNA/protein</a:t>
             </a:r>
           </a:p>
         </p:txBody>
@@ -8895,7 +8895,7 @@
           <p:cNvPr id="21" name="">
             <a:extLst xmlns:a="http://schemas.openxmlformats.org/drawingml/2006/main">
               <a:ext uri="{FF2B5EF4-FFF2-40B4-BE49-F238E27FC236}">
-                <a16:creationId xmlns:a16="http://schemas.microsoft.com/office/drawing/2014/main" id="{12DC62A4-846E-4DAB-8D81-B101618A9A33}"/>
+                <a16:creationId xmlns:a16="http://schemas.microsoft.com/office/drawing/2014/main" id="{D18B2A40-CDAB-4A30-983F-246C057DBE43}"/>
               </a:ext>
             </a:extLst>
           </p:cNvPr>
@@ -8956,7 +8956,7 @@
           <p:cNvPr id="22" name="">
             <a:extLst xmlns:a="http://schemas.openxmlformats.org/drawingml/2006/main">
               <a:ext uri="{FF2B5EF4-FFF2-40B4-BE49-F238E27FC236}">
-                <a16:creationId xmlns:a16="http://schemas.microsoft.com/office/drawing/2014/main" id="{477D6466-80AB-4FDA-A585-A348900C0491}"/>
+                <a16:creationId xmlns:a16="http://schemas.microsoft.com/office/drawing/2014/main" id="{5518C098-C74F-4D02-B45C-735510A3158A}"/>
               </a:ext>
             </a:extLst>
           </p:cNvPr>
@@ -9017,7 +9017,7 @@
           <p:cNvPr id="23" name="">
             <a:extLst xmlns:a="http://schemas.openxmlformats.org/drawingml/2006/main">
               <a:ext uri="{FF2B5EF4-FFF2-40B4-BE49-F238E27FC236}">
-                <a16:creationId xmlns:a16="http://schemas.microsoft.com/office/drawing/2014/main" id="{6CFDE4D5-A417-4B9E-919D-7F2FBF1DCF6F}"/>
+                <a16:creationId xmlns:a16="http://schemas.microsoft.com/office/drawing/2014/main" id="{7AFFE18D-0B92-407F-83B8-02906DCE4995}"/>
               </a:ext>
             </a:extLst>
           </p:cNvPr>
@@ -9078,7 +9078,7 @@
           <p:cNvPr id="24" name="">
             <a:extLst xmlns:a="http://schemas.openxmlformats.org/drawingml/2006/main">
               <a:ext uri="{FF2B5EF4-FFF2-40B4-BE49-F238E27FC236}">
-                <a16:creationId xmlns:a16="http://schemas.microsoft.com/office/drawing/2014/main" id="{B22781A6-4D77-4FD1-9D37-D6C24D87AE18}"/>
+                <a16:creationId xmlns:a16="http://schemas.microsoft.com/office/drawing/2014/main" id="{D109A48E-49EC-44FA-87D8-BA72BA0E0733}"/>
               </a:ext>
             </a:extLst>
           </p:cNvPr>
@@ -9129,7 +9129,7 @@
                 <a:ea typeface="Arial"/>
                 <a:cs typeface="Arial"/>
               </a:rPr>
-              <a:t>one value per donor  |  paired Wilcoxon  |  bootstrap CI  |  BH correction</a:t>
+              <a:t>donor-level inference  |  target-by-replicate effects  |  paired tests</a:t>
             </a:r>
           </a:p>
         </p:txBody>
@@ -9137,7 +9137,7 @@
     </p:spTree>
     <p:extLst>
       <p:ext uri="{BB962C8B-B14F-4D97-AF65-F5344CB8AC3E}">
-        <p14:creationId xmlns:p14="http://schemas.microsoft.com/office/powerpoint/2010/main" val="1275935965"/>
+        <p14:creationId xmlns:p14="http://schemas.microsoft.com/office/powerpoint/2010/main" val="1152407887"/>
       </p:ext>
     </p:extLst>
   </p:cSld>
@@ -9165,10 +9165,10 @@
       </p:grpSpPr>
       <p:sp>
         <p:nvSpPr>
-          <p:cNvPr id="12" name="">
-            <a:extLst xmlns:a="http://schemas.openxmlformats.org/drawingml/2006/main">
-              <a:ext uri="{FF2B5EF4-FFF2-40B4-BE49-F238E27FC236}">
-                <a16:creationId xmlns:a16="http://schemas.microsoft.com/office/drawing/2014/main" id="{C8E66FF5-C44D-4025-93B0-E455AE689085}"/>
+          <p:cNvPr id="19" name="">
+            <a:extLst xmlns:a="http://schemas.openxmlformats.org/drawingml/2006/main">
+              <a:ext uri="{FF2B5EF4-FFF2-40B4-BE49-F238E27FC236}">
+                <a16:creationId xmlns:a16="http://schemas.microsoft.com/office/drawing/2014/main" id="{E02EAF73-D998-4181-A5D1-5EB5BBF5FE9C}"/>
               </a:ext>
             </a:extLst>
           </p:cNvPr>
@@ -9219,7 +9219,7 @@
                 <a:ea typeface="Arial"/>
                 <a:cs typeface="Arial"/>
               </a:rPr>
-              <a:t>RESULT 1</a:t>
+              <a:t>EXPERIMENT 2 DESIGN</a:t>
             </a:r>
           </a:p>
         </p:txBody>
@@ -9229,7 +9229,7 @@
           <p:cNvPr id="2" name="">
             <a:extLst xmlns:a="http://schemas.openxmlformats.org/drawingml/2006/main">
               <a:ext uri="{FF2B5EF4-FFF2-40B4-BE49-F238E27FC236}">
-                <a16:creationId xmlns:a16="http://schemas.microsoft.com/office/drawing/2014/main" id="{8E78BBA3-A7AB-4750-836C-4B072BD39D9B}"/>
+                <a16:creationId xmlns:a16="http://schemas.microsoft.com/office/drawing/2014/main" id="{CBEB23D1-4261-4E88-A066-526F999F791A}"/>
               </a:ext>
             </a:extLst>
           </p:cNvPr>
@@ -9280,7 +9280,7 @@
                 <a:ea typeface="Arial"/>
                 <a:cs typeface="Arial"/>
               </a:rPr>
-              <a:t>Broad stimulation labels were already solved</a:t>
+              <a:t>A second dataset tests unseen PD-L1 regulators</a:t>
             </a:r>
           </a:p>
         </p:txBody>
@@ -9290,7 +9290,7 @@
           <p:cNvPr id="3" name="">
             <a:extLst xmlns:a="http://schemas.openxmlformats.org/drawingml/2006/main">
               <a:ext uri="{FF2B5EF4-FFF2-40B4-BE49-F238E27FC236}">
-                <a16:creationId xmlns:a16="http://schemas.microsoft.com/office/drawing/2014/main" id="{4850B354-6FAF-4F29-AAD2-FA2D21E53EFF}"/>
+                <a16:creationId xmlns:a16="http://schemas.microsoft.com/office/drawing/2014/main" id="{7D4AF330-8538-4458-B555-5D13C48F7606}"/>
               </a:ext>
             </a:extLst>
           </p:cNvPr>
@@ -9320,7 +9320,7 @@
           <p:cNvPr id="4" name="">
             <a:extLst xmlns:a="http://schemas.openxmlformats.org/drawingml/2006/main">
               <a:ext uri="{FF2B5EF4-FFF2-40B4-BE49-F238E27FC236}">
-                <a16:creationId xmlns:a16="http://schemas.microsoft.com/office/drawing/2014/main" id="{1CBEB533-6F2C-43A6-B1E0-423BDEBAF102}"/>
+                <a16:creationId xmlns:a16="http://schemas.microsoft.com/office/drawing/2014/main" id="{9D8AD973-25E4-4083-B650-B2D9F21C07D3}"/>
               </a:ext>
             </a:extLst>
           </p:cNvPr>
@@ -9378,20 +9378,20 @@
       </p:sp>
       <p:pic>
         <p:nvPicPr>
-          <p:cNvPr id="16" name=""/>
+          <p:cNvPr id="23" name=""/>
           <p:cNvPicPr>
             <a:picLocks xmlns:a="http://schemas.openxmlformats.org/drawingml/2006/main" noChangeAspect="1"/>
           </p:cNvPicPr>
           <p:nvPr/>
         </p:nvPicPr>
         <p:blipFill>
-          <a:blip xmlns:r="http://schemas.openxmlformats.org/officeDocument/2006/relationships" xmlns:a="http://schemas.openxmlformats.org/drawingml/2006/main" r:embed="R51a9a8b523d3456a"/>
+          <a:blip xmlns:r="http://schemas.openxmlformats.org/officeDocument/2006/relationships" xmlns:a="http://schemas.openxmlformats.org/drawingml/2006/main" r:embed="Rf369efa529db4f8c"/>
           <a:stretch xmlns:a="http://schemas.openxmlformats.org/drawingml/2006/main"/>
         </p:blipFill>
         <p:spPr>
           <a:xfrm xmlns:a="http://schemas.openxmlformats.org/drawingml/2006/main">
-            <a:off x="533400" y="2328730"/>
-            <a:ext cx="8763000" cy="2829190"/>
+            <a:off x="533400" y="1468678"/>
+            <a:ext cx="11049000" cy="3177694"/>
           </a:xfrm>
           <a:prstGeom xmlns:a="http://schemas.openxmlformats.org/drawingml/2006/main" prst="rect">
             <a:avLst/>
@@ -9403,19 +9403,51 @@
           <p:cNvPr id="6" name="">
             <a:extLst xmlns:a="http://schemas.openxmlformats.org/drawingml/2006/main">
               <a:ext uri="{FF2B5EF4-FFF2-40B4-BE49-F238E27FC236}">
-                <a16:creationId xmlns:a16="http://schemas.microsoft.com/office/drawing/2014/main" id="{BD211007-37CD-41C2-9B34-4DB67BCD4151}"/>
-              </a:ext>
-            </a:extLst>
-          </p:cNvPr>
-          <p:cNvSpPr>
-            <a:spLocks xmlns:a="http://schemas.openxmlformats.org/drawingml/2006/main" noGrp="1"/>
-          </p:cNvSpPr>
-          <p:nvPr/>
-        </p:nvSpPr>
-        <p:spPr>
-          <a:xfrm xmlns:a="http://schemas.openxmlformats.org/drawingml/2006/main">
-            <a:off x="9239250" y="1790700"/>
-            <a:ext cx="2667000" cy="552450"/>
+                <a16:creationId xmlns:a16="http://schemas.microsoft.com/office/drawing/2014/main" id="{EA8AEC00-BDB1-4D02-9C54-AE63518B3F91}"/>
+              </a:ext>
+            </a:extLst>
+          </p:cNvPr>
+          <p:cNvSpPr>
+            <a:spLocks xmlns:a="http://schemas.openxmlformats.org/drawingml/2006/main" noGrp="1"/>
+          </p:cNvSpPr>
+          <p:nvPr/>
+        </p:nvSpPr>
+        <p:spPr>
+          <a:xfrm xmlns:a="http://schemas.openxmlformats.org/drawingml/2006/main">
+            <a:off x="685800" y="4933950"/>
+            <a:ext cx="1714500" cy="361950"/>
+          </a:xfrm>
+          <a:prstGeom xmlns:a="http://schemas.openxmlformats.org/drawingml/2006/main" prst="roundRect">
+            <a:avLst>
+              <a:gd name="adj" fmla="val 42105"/>
+            </a:avLst>
+          </a:prstGeom>
+          <a:solidFill xmlns:a="http://schemas.openxmlformats.org/drawingml/2006/main">
+            <a:srgbClr val="DDF3F2"/>
+          </a:solidFill>
+          <a:ln xmlns:a="http://schemas.openxmlformats.org/drawingml/2006/main" w="0">
+            <a:noFill/>
+          </a:ln>
+        </p:spPr>
+      </p:sp>
+      <p:sp>
+        <p:nvSpPr>
+          <p:cNvPr id="7" name="">
+            <a:extLst xmlns:a="http://schemas.openxmlformats.org/drawingml/2006/main">
+              <a:ext uri="{FF2B5EF4-FFF2-40B4-BE49-F238E27FC236}">
+                <a16:creationId xmlns:a16="http://schemas.microsoft.com/office/drawing/2014/main" id="{8A34670C-F26B-47A3-8A48-321B42AF24BF}"/>
+              </a:ext>
+            </a:extLst>
+          </p:cNvPr>
+          <p:cNvSpPr>
+            <a:spLocks xmlns:a="http://schemas.openxmlformats.org/drawingml/2006/main" noGrp="1"/>
+          </p:cNvSpPr>
+          <p:nvPr/>
+        </p:nvSpPr>
+        <p:spPr>
+          <a:xfrm xmlns:a="http://schemas.openxmlformats.org/drawingml/2006/main">
+            <a:off x="762000" y="4981575"/>
+            <a:ext cx="1562100" cy="266700"/>
           </a:xfrm>
           <a:prstGeom xmlns:a="http://schemas.openxmlformats.org/drawingml/2006/main" prst="rect">
             <a:avLst/>
@@ -9427,7 +9459,7 @@
         </p:spPr>
         <p:txBody>
           <a:bodyPr xmlns:a="http://schemas.openxmlformats.org/drawingml/2006/main" anchor="ctr">
-            <a:normAutofit fontScale="100000"/>
+            <a:normAutofit fontScale="92147"/>
           </a:bodyPr>
           <a:lstStyle xmlns:a="http://schemas.openxmlformats.org/drawingml/2006/main"/>
           <a:p xmlns:a="http://schemas.openxmlformats.org/drawingml/2006/main">
@@ -9436,7 +9468,193 @@
                 <a:spcPct val="104000"/>
               </a:lnSpc>
               <a:buNone/>
-              <a:defRPr sz="2550" b="1">
+              <a:defRPr sz="1200" b="1">
+                <a:solidFill>
+                  <a:srgbClr val="0D8A9A"/>
+                </a:solidFill>
+                <a:latin typeface="Arial"/>
+                <a:ea typeface="Arial"/>
+                <a:cs typeface="Arial"/>
+              </a:defRPr>
+            </a:pPr>
+            <a:r>
+              <a:rPr sz="1200" b="1">
+                <a:solidFill>
+                  <a:srgbClr val="0D8A9A"/>
+                </a:solidFill>
+                <a:latin typeface="Arial"/>
+                <a:ea typeface="Arial"/>
+                <a:cs typeface="Arial"/>
+              </a:rPr>
+              <a:t>20,729 cells</a:t>
+            </a:r>
+          </a:p>
+        </p:txBody>
+      </p:sp>
+      <p:sp>
+        <p:nvSpPr>
+          <p:cNvPr id="8" name="">
+            <a:extLst xmlns:a="http://schemas.openxmlformats.org/drawingml/2006/main">
+              <a:ext uri="{FF2B5EF4-FFF2-40B4-BE49-F238E27FC236}">
+                <a16:creationId xmlns:a16="http://schemas.microsoft.com/office/drawing/2014/main" id="{88685CD8-5694-4C2A-8D40-8975F0DBBC36}"/>
+              </a:ext>
+            </a:extLst>
+          </p:cNvPr>
+          <p:cNvSpPr>
+            <a:spLocks xmlns:a="http://schemas.openxmlformats.org/drawingml/2006/main" noGrp="1"/>
+          </p:cNvSpPr>
+          <p:nvPr/>
+        </p:nvSpPr>
+        <p:spPr>
+          <a:xfrm xmlns:a="http://schemas.openxmlformats.org/drawingml/2006/main">
+            <a:off x="2590800" y="4933950"/>
+            <a:ext cx="2095500" cy="361950"/>
+          </a:xfrm>
+          <a:prstGeom xmlns:a="http://schemas.openxmlformats.org/drawingml/2006/main" prst="roundRect">
+            <a:avLst>
+              <a:gd name="adj" fmla="val 42105"/>
+            </a:avLst>
+          </a:prstGeom>
+          <a:solidFill xmlns:a="http://schemas.openxmlformats.org/drawingml/2006/main">
+            <a:srgbClr val="EEE7FF"/>
+          </a:solidFill>
+          <a:ln xmlns:a="http://schemas.openxmlformats.org/drawingml/2006/main" w="0">
+            <a:noFill/>
+          </a:ln>
+        </p:spPr>
+      </p:sp>
+      <p:sp>
+        <p:nvSpPr>
+          <p:cNvPr id="9" name="">
+            <a:extLst xmlns:a="http://schemas.openxmlformats.org/drawingml/2006/main">
+              <a:ext uri="{FF2B5EF4-FFF2-40B4-BE49-F238E27FC236}">
+                <a16:creationId xmlns:a16="http://schemas.microsoft.com/office/drawing/2014/main" id="{B8FF642B-CAA3-4FA8-A9C4-3D53C7E41E16}"/>
+              </a:ext>
+            </a:extLst>
+          </p:cNvPr>
+          <p:cNvSpPr>
+            <a:spLocks xmlns:a="http://schemas.openxmlformats.org/drawingml/2006/main" noGrp="1"/>
+          </p:cNvSpPr>
+          <p:nvPr/>
+        </p:nvSpPr>
+        <p:spPr>
+          <a:xfrm xmlns:a="http://schemas.openxmlformats.org/drawingml/2006/main">
+            <a:off x="2667000" y="4981575"/>
+            <a:ext cx="1943100" cy="266700"/>
+          </a:xfrm>
+          <a:prstGeom xmlns:a="http://schemas.openxmlformats.org/drawingml/2006/main" prst="rect">
+            <a:avLst/>
+          </a:prstGeom>
+          <a:noFill xmlns:a="http://schemas.openxmlformats.org/drawingml/2006/main"/>
+          <a:ln xmlns:a="http://schemas.openxmlformats.org/drawingml/2006/main" w="0">
+            <a:noFill/>
+          </a:ln>
+        </p:spPr>
+        <p:txBody>
+          <a:bodyPr xmlns:a="http://schemas.openxmlformats.org/drawingml/2006/main" anchor="ctr">
+            <a:normAutofit fontScale="92147"/>
+          </a:bodyPr>
+          <a:lstStyle xmlns:a="http://schemas.openxmlformats.org/drawingml/2006/main"/>
+          <a:p xmlns:a="http://schemas.openxmlformats.org/drawingml/2006/main">
+            <a:pPr algn="ctr">
+              <a:lnSpc>
+                <a:spcPct val="104000"/>
+              </a:lnSpc>
+              <a:buNone/>
+              <a:defRPr sz="1200" b="1">
+                <a:solidFill>
+                  <a:srgbClr val="6C3ED9"/>
+                </a:solidFill>
+                <a:latin typeface="Arial"/>
+                <a:ea typeface="Arial"/>
+                <a:cs typeface="Arial"/>
+              </a:defRPr>
+            </a:pPr>
+            <a:r>
+              <a:rPr sz="1200" b="1">
+                <a:solidFill>
+                  <a:srgbClr val="6C3ED9"/>
+                </a:solidFill>
+                <a:latin typeface="Arial"/>
+                <a:ea typeface="Arial"/>
+                <a:cs typeface="Arial"/>
+              </a:rPr>
+              <a:t>25 CRISPR targets</a:t>
+            </a:r>
+          </a:p>
+        </p:txBody>
+      </p:sp>
+      <p:sp>
+        <p:nvSpPr>
+          <p:cNvPr id="10" name="">
+            <a:extLst xmlns:a="http://schemas.openxmlformats.org/drawingml/2006/main">
+              <a:ext uri="{FF2B5EF4-FFF2-40B4-BE49-F238E27FC236}">
+                <a16:creationId xmlns:a16="http://schemas.microsoft.com/office/drawing/2014/main" id="{7BCD78A1-913A-4B67-B179-FDDE45B3721B}"/>
+              </a:ext>
+            </a:extLst>
+          </p:cNvPr>
+          <p:cNvSpPr>
+            <a:spLocks xmlns:a="http://schemas.openxmlformats.org/drawingml/2006/main" noGrp="1"/>
+          </p:cNvSpPr>
+          <p:nvPr/>
+        </p:nvSpPr>
+        <p:spPr>
+          <a:xfrm xmlns:a="http://schemas.openxmlformats.org/drawingml/2006/main">
+            <a:off x="4876800" y="4933950"/>
+            <a:ext cx="1619250" cy="361950"/>
+          </a:xfrm>
+          <a:prstGeom xmlns:a="http://schemas.openxmlformats.org/drawingml/2006/main" prst="roundRect">
+            <a:avLst>
+              <a:gd name="adj" fmla="val 42105"/>
+            </a:avLst>
+          </a:prstGeom>
+          <a:solidFill xmlns:a="http://schemas.openxmlformats.org/drawingml/2006/main">
+            <a:srgbClr val="FFE7E5"/>
+          </a:solidFill>
+          <a:ln xmlns:a="http://schemas.openxmlformats.org/drawingml/2006/main" w="0">
+            <a:noFill/>
+          </a:ln>
+        </p:spPr>
+      </p:sp>
+      <p:sp>
+        <p:nvSpPr>
+          <p:cNvPr id="11" name="">
+            <a:extLst xmlns:a="http://schemas.openxmlformats.org/drawingml/2006/main">
+              <a:ext uri="{FF2B5EF4-FFF2-40B4-BE49-F238E27FC236}">
+                <a16:creationId xmlns:a16="http://schemas.microsoft.com/office/drawing/2014/main" id="{90F15340-18C9-4265-A6DA-84CCBD83CE37}"/>
+              </a:ext>
+            </a:extLst>
+          </p:cNvPr>
+          <p:cNvSpPr>
+            <a:spLocks xmlns:a="http://schemas.openxmlformats.org/drawingml/2006/main" noGrp="1"/>
+          </p:cNvSpPr>
+          <p:nvPr/>
+        </p:nvSpPr>
+        <p:spPr>
+          <a:xfrm xmlns:a="http://schemas.openxmlformats.org/drawingml/2006/main">
+            <a:off x="4953000" y="4981575"/>
+            <a:ext cx="1466850" cy="266700"/>
+          </a:xfrm>
+          <a:prstGeom xmlns:a="http://schemas.openxmlformats.org/drawingml/2006/main" prst="rect">
+            <a:avLst/>
+          </a:prstGeom>
+          <a:noFill xmlns:a="http://schemas.openxmlformats.org/drawingml/2006/main"/>
+          <a:ln xmlns:a="http://schemas.openxmlformats.org/drawingml/2006/main" w="0">
+            <a:noFill/>
+          </a:ln>
+        </p:spPr>
+        <p:txBody>
+          <a:bodyPr xmlns:a="http://schemas.openxmlformats.org/drawingml/2006/main" anchor="ctr">
+            <a:normAutofit fontScale="92147"/>
+          </a:bodyPr>
+          <a:lstStyle xmlns:a="http://schemas.openxmlformats.org/drawingml/2006/main"/>
+          <a:p xmlns:a="http://schemas.openxmlformats.org/drawingml/2006/main">
+            <a:pPr algn="ctr">
+              <a:lnSpc>
+                <a:spcPct val="104000"/>
+              </a:lnSpc>
+              <a:buNone/>
+              <a:defRPr sz="1200" b="1">
                 <a:solidFill>
                   <a:srgbClr val="F15B64"/>
                 </a:solidFill>
@@ -9446,7 +9664,7 @@
               </a:defRPr>
             </a:pPr>
             <a:r>
-              <a:rPr sz="2550" b="1">
+              <a:rPr sz="1200" b="1">
                 <a:solidFill>
                   <a:srgbClr val="F15B64"/>
                 </a:solidFill>
@@ -9454,29 +9672,122 @@
                 <a:ea typeface="Arial"/>
                 <a:cs typeface="Arial"/>
               </a:rPr>
-              <a:t>0.995–1.000</a:t>
-            </a:r>
-          </a:p>
-        </p:txBody>
-      </p:sp>
-      <p:sp>
-        <p:nvSpPr>
-          <p:cNvPr id="7" name="">
-            <a:extLst xmlns:a="http://schemas.openxmlformats.org/drawingml/2006/main">
-              <a:ext uri="{FF2B5EF4-FFF2-40B4-BE49-F238E27FC236}">
-                <a16:creationId xmlns:a16="http://schemas.microsoft.com/office/drawing/2014/main" id="{4DF604A8-622F-42B8-A4CF-20FE92A15701}"/>
-              </a:ext>
-            </a:extLst>
-          </p:cNvPr>
-          <p:cNvSpPr>
-            <a:spLocks xmlns:a="http://schemas.openxmlformats.org/drawingml/2006/main" noGrp="1"/>
-          </p:cNvSpPr>
-          <p:nvPr/>
-        </p:nvSpPr>
-        <p:spPr>
-          <a:xfrm xmlns:a="http://schemas.openxmlformats.org/drawingml/2006/main">
-            <a:off x="9525000" y="2457450"/>
-            <a:ext cx="2095500" cy="266700"/>
+              <a:t>3 replicates</a:t>
+            </a:r>
+          </a:p>
+        </p:txBody>
+      </p:sp>
+      <p:sp>
+        <p:nvSpPr>
+          <p:cNvPr id="12" name="">
+            <a:extLst xmlns:a="http://schemas.openxmlformats.org/drawingml/2006/main">
+              <a:ext uri="{FF2B5EF4-FFF2-40B4-BE49-F238E27FC236}">
+                <a16:creationId xmlns:a16="http://schemas.microsoft.com/office/drawing/2014/main" id="{ACA02DF1-BFC8-4C1F-8AAD-2B9F15B6F54D}"/>
+              </a:ext>
+            </a:extLst>
+          </p:cNvPr>
+          <p:cNvSpPr>
+            <a:spLocks xmlns:a="http://schemas.openxmlformats.org/drawingml/2006/main" noGrp="1"/>
+          </p:cNvSpPr>
+          <p:nvPr/>
+        </p:nvSpPr>
+        <p:spPr>
+          <a:xfrm xmlns:a="http://schemas.openxmlformats.org/drawingml/2006/main">
+            <a:off x="6686550" y="4933950"/>
+            <a:ext cx="1714500" cy="361950"/>
+          </a:xfrm>
+          <a:prstGeom xmlns:a="http://schemas.openxmlformats.org/drawingml/2006/main" prst="roundRect">
+            <a:avLst>
+              <a:gd name="adj" fmla="val 42105"/>
+            </a:avLst>
+          </a:prstGeom>
+          <a:solidFill xmlns:a="http://schemas.openxmlformats.org/drawingml/2006/main">
+            <a:srgbClr val="FFE7E5"/>
+          </a:solidFill>
+          <a:ln xmlns:a="http://schemas.openxmlformats.org/drawingml/2006/main" w="0">
+            <a:noFill/>
+          </a:ln>
+        </p:spPr>
+      </p:sp>
+      <p:sp>
+        <p:nvSpPr>
+          <p:cNvPr id="13" name="">
+            <a:extLst xmlns:a="http://schemas.openxmlformats.org/drawingml/2006/main">
+              <a:ext uri="{FF2B5EF4-FFF2-40B4-BE49-F238E27FC236}">
+                <a16:creationId xmlns:a16="http://schemas.microsoft.com/office/drawing/2014/main" id="{EFB11A45-D64D-4013-9940-51469F3AEA70}"/>
+              </a:ext>
+            </a:extLst>
+          </p:cNvPr>
+          <p:cNvSpPr>
+            <a:spLocks xmlns:a="http://schemas.openxmlformats.org/drawingml/2006/main" noGrp="1"/>
+          </p:cNvSpPr>
+          <p:nvPr/>
+        </p:nvSpPr>
+        <p:spPr>
+          <a:xfrm xmlns:a="http://schemas.openxmlformats.org/drawingml/2006/main">
+            <a:off x="6762750" y="4981575"/>
+            <a:ext cx="1562100" cy="266700"/>
+          </a:xfrm>
+          <a:prstGeom xmlns:a="http://schemas.openxmlformats.org/drawingml/2006/main" prst="rect">
+            <a:avLst/>
+          </a:prstGeom>
+          <a:noFill xmlns:a="http://schemas.openxmlformats.org/drawingml/2006/main"/>
+          <a:ln xmlns:a="http://schemas.openxmlformats.org/drawingml/2006/main" w="0">
+            <a:noFill/>
+          </a:ln>
+        </p:spPr>
+        <p:txBody>
+          <a:bodyPr xmlns:a="http://schemas.openxmlformats.org/drawingml/2006/main" anchor="ctr">
+            <a:normAutofit fontScale="92147"/>
+          </a:bodyPr>
+          <a:lstStyle xmlns:a="http://schemas.openxmlformats.org/drawingml/2006/main"/>
+          <a:p xmlns:a="http://schemas.openxmlformats.org/drawingml/2006/main">
+            <a:pPr algn="ctr">
+              <a:lnSpc>
+                <a:spcPct val="104000"/>
+              </a:lnSpc>
+              <a:buNone/>
+              <a:defRPr sz="1200" b="1">
+                <a:solidFill>
+                  <a:srgbClr val="F15B64"/>
+                </a:solidFill>
+                <a:latin typeface="Arial"/>
+                <a:ea typeface="Arial"/>
+                <a:cs typeface="Arial"/>
+              </a:defRPr>
+            </a:pPr>
+            <a:r>
+              <a:rPr sz="1200" b="1">
+                <a:solidFill>
+                  <a:srgbClr val="F15B64"/>
+                </a:solidFill>
+                <a:latin typeface="Arial"/>
+                <a:ea typeface="Arial"/>
+                <a:cs typeface="Arial"/>
+              </a:rPr>
+              <a:t>PD-L1 hidden</a:t>
+            </a:r>
+          </a:p>
+        </p:txBody>
+      </p:sp>
+      <p:sp>
+        <p:nvSpPr>
+          <p:cNvPr id="14" name="">
+            <a:extLst xmlns:a="http://schemas.openxmlformats.org/drawingml/2006/main">
+              <a:ext uri="{FF2B5EF4-FFF2-40B4-BE49-F238E27FC236}">
+                <a16:creationId xmlns:a16="http://schemas.microsoft.com/office/drawing/2014/main" id="{CD470B8B-1626-4177-8A87-614B0A33DFE3}"/>
+              </a:ext>
+            </a:extLst>
+          </p:cNvPr>
+          <p:cNvSpPr>
+            <a:spLocks xmlns:a="http://schemas.openxmlformats.org/drawingml/2006/main" noGrp="1"/>
+          </p:cNvSpPr>
+          <p:nvPr/>
+        </p:nvSpPr>
+        <p:spPr>
+          <a:xfrm xmlns:a="http://schemas.openxmlformats.org/drawingml/2006/main">
+            <a:off x="685800" y="5657850"/>
+            <a:ext cx="3143250" cy="323850"/>
           </a:xfrm>
           <a:prstGeom xmlns:a="http://schemas.openxmlformats.org/drawingml/2006/main" prst="rect">
             <a:avLst/>
@@ -9488,7 +9799,68 @@
         </p:spPr>
         <p:txBody>
           <a:bodyPr xmlns:a="http://schemas.openxmlformats.org/drawingml/2006/main" anchor="t">
-            <a:normAutofit fontScale="81909"/>
+            <a:normAutofit fontScale="81464"/>
+          </a:bodyPr>
+          <a:lstStyle xmlns:a="http://schemas.openxmlformats.org/drawingml/2006/main"/>
+          <a:p xmlns:a="http://schemas.openxmlformats.org/drawingml/2006/main">
+            <a:pPr algn="l">
+              <a:lnSpc>
+                <a:spcPct val="104000"/>
+              </a:lnSpc>
+              <a:buNone/>
+              <a:defRPr sz="1800" b="1">
+                <a:solidFill>
+                  <a:srgbClr val="17223B"/>
+                </a:solidFill>
+                <a:latin typeface="Arial"/>
+                <a:ea typeface="Arial"/>
+                <a:cs typeface="Arial"/>
+              </a:defRPr>
+            </a:pPr>
+            <a:r>
+              <a:rPr sz="1800" b="1">
+                <a:solidFill>
+                  <a:srgbClr val="17223B"/>
+                </a:solidFill>
+                <a:latin typeface="Arial"/>
+                <a:ea typeface="Arial"/>
+                <a:cs typeface="Arial"/>
+              </a:rPr>
+              <a:t>Five target-held-out folds</a:t>
+            </a:r>
+          </a:p>
+        </p:txBody>
+      </p:sp>
+      <p:sp>
+        <p:nvSpPr>
+          <p:cNvPr id="15" name="">
+            <a:extLst xmlns:a="http://schemas.openxmlformats.org/drawingml/2006/main">
+              <a:ext uri="{FF2B5EF4-FFF2-40B4-BE49-F238E27FC236}">
+                <a16:creationId xmlns:a16="http://schemas.microsoft.com/office/drawing/2014/main" id="{B05F05E7-325A-4B34-9CD4-73DF01D6524E}"/>
+              </a:ext>
+            </a:extLst>
+          </p:cNvPr>
+          <p:cNvSpPr>
+            <a:spLocks xmlns:a="http://schemas.openxmlformats.org/drawingml/2006/main" noGrp="1"/>
+          </p:cNvSpPr>
+          <p:nvPr/>
+        </p:nvSpPr>
+        <p:spPr>
+          <a:xfrm xmlns:a="http://schemas.openxmlformats.org/drawingml/2006/main">
+            <a:off x="3905250" y="5657850"/>
+            <a:ext cx="2381250" cy="323850"/>
+          </a:xfrm>
+          <a:prstGeom xmlns:a="http://schemas.openxmlformats.org/drawingml/2006/main" prst="rect">
+            <a:avLst/>
+          </a:prstGeom>
+          <a:noFill xmlns:a="http://schemas.openxmlformats.org/drawingml/2006/main"/>
+          <a:ln xmlns:a="http://schemas.openxmlformats.org/drawingml/2006/main" w="0">
+            <a:noFill/>
+          </a:ln>
+        </p:spPr>
+        <p:txBody>
+          <a:bodyPr xmlns:a="http://schemas.openxmlformats.org/drawingml/2006/main" anchor="t">
+            <a:normAutofit fontScale="93101"/>
           </a:bodyPr>
           <a:lstStyle xmlns:a="http://schemas.openxmlformats.org/drawingml/2006/main"/>
           <a:p xmlns:a="http://schemas.openxmlformats.org/drawingml/2006/main">
@@ -9497,6 +9869,128 @@
                 <a:spcPct val="104000"/>
               </a:lnSpc>
               <a:buNone/>
+              <a:defRPr sz="1575" b="1">
+                <a:solidFill>
+                  <a:srgbClr val="223A69"/>
+                </a:solidFill>
+                <a:latin typeface="Arial"/>
+                <a:ea typeface="Arial"/>
+                <a:cs typeface="Arial"/>
+              </a:defRPr>
+            </a:pPr>
+            <a:r>
+              <a:rPr sz="1575" b="1">
+                <a:solidFill>
+                  <a:srgbClr val="223A69"/>
+                </a:solidFill>
+                <a:latin typeface="Arial"/>
+                <a:ea typeface="Arial"/>
+                <a:cs typeface="Arial"/>
+              </a:rPr>
+              <a:t>Train on 20 targets</a:t>
+            </a:r>
+          </a:p>
+        </p:txBody>
+      </p:sp>
+      <p:sp>
+        <p:nvSpPr>
+          <p:cNvPr id="16" name="">
+            <a:extLst xmlns:a="http://schemas.openxmlformats.org/drawingml/2006/main">
+              <a:ext uri="{FF2B5EF4-FFF2-40B4-BE49-F238E27FC236}">
+                <a16:creationId xmlns:a16="http://schemas.microsoft.com/office/drawing/2014/main" id="{CD6D07C3-AEE1-4A8B-9190-D73E0602700A}"/>
+              </a:ext>
+            </a:extLst>
+          </p:cNvPr>
+          <p:cNvSpPr>
+            <a:spLocks xmlns:a="http://schemas.openxmlformats.org/drawingml/2006/main" noGrp="1"/>
+          </p:cNvSpPr>
+          <p:nvPr/>
+        </p:nvSpPr>
+        <p:spPr>
+          <a:xfrm xmlns:a="http://schemas.openxmlformats.org/drawingml/2006/main">
+            <a:off x="6819900" y="5657850"/>
+            <a:ext cx="2667000" cy="323850"/>
+          </a:xfrm>
+          <a:prstGeom xmlns:a="http://schemas.openxmlformats.org/drawingml/2006/main" prst="rect">
+            <a:avLst/>
+          </a:prstGeom>
+          <a:noFill xmlns:a="http://schemas.openxmlformats.org/drawingml/2006/main"/>
+          <a:ln xmlns:a="http://schemas.openxmlformats.org/drawingml/2006/main" w="0">
+            <a:noFill/>
+          </a:ln>
+        </p:spPr>
+        <p:txBody>
+          <a:bodyPr xmlns:a="http://schemas.openxmlformats.org/drawingml/2006/main" anchor="t">
+            <a:normAutofit fontScale="93101"/>
+          </a:bodyPr>
+          <a:lstStyle xmlns:a="http://schemas.openxmlformats.org/drawingml/2006/main"/>
+          <a:p xmlns:a="http://schemas.openxmlformats.org/drawingml/2006/main">
+            <a:pPr algn="ctr">
+              <a:lnSpc>
+                <a:spcPct val="104000"/>
+              </a:lnSpc>
+              <a:buNone/>
+              <a:defRPr sz="1575" b="1">
+                <a:solidFill>
+                  <a:srgbClr val="223A69"/>
+                </a:solidFill>
+                <a:latin typeface="Arial"/>
+                <a:ea typeface="Arial"/>
+                <a:cs typeface="Arial"/>
+              </a:defRPr>
+            </a:pPr>
+            <a:r>
+              <a:rPr sz="1575" b="1">
+                <a:solidFill>
+                  <a:srgbClr val="223A69"/>
+                </a:solidFill>
+                <a:latin typeface="Arial"/>
+                <a:ea typeface="Arial"/>
+                <a:cs typeface="Arial"/>
+              </a:rPr>
+              <a:t>Test 5 unseen targets</a:t>
+            </a:r>
+          </a:p>
+        </p:txBody>
+      </p:sp>
+      <p:sp>
+        <p:nvSpPr>
+          <p:cNvPr id="17" name="">
+            <a:extLst xmlns:a="http://schemas.openxmlformats.org/drawingml/2006/main">
+              <a:ext uri="{FF2B5EF4-FFF2-40B4-BE49-F238E27FC236}">
+                <a16:creationId xmlns:a16="http://schemas.microsoft.com/office/drawing/2014/main" id="{F0DCF9CB-3508-4F34-B0DD-7C725E14D0A3}"/>
+              </a:ext>
+            </a:extLst>
+          </p:cNvPr>
+          <p:cNvSpPr>
+            <a:spLocks xmlns:a="http://schemas.openxmlformats.org/drawingml/2006/main" noGrp="1"/>
+          </p:cNvSpPr>
+          <p:nvPr/>
+        </p:nvSpPr>
+        <p:spPr>
+          <a:xfrm xmlns:a="http://schemas.openxmlformats.org/drawingml/2006/main">
+            <a:off x="9353550" y="5657850"/>
+            <a:ext cx="2190750" cy="419100"/>
+          </a:xfrm>
+          <a:prstGeom xmlns:a="http://schemas.openxmlformats.org/drawingml/2006/main" prst="rect">
+            <a:avLst/>
+          </a:prstGeom>
+          <a:noFill xmlns:a="http://schemas.openxmlformats.org/drawingml/2006/main"/>
+          <a:ln xmlns:a="http://schemas.openxmlformats.org/drawingml/2006/main" w="0">
+            <a:noFill/>
+          </a:ln>
+        </p:spPr>
+        <p:txBody>
+          <a:bodyPr xmlns:a="http://schemas.openxmlformats.org/drawingml/2006/main" anchor="t">
+            <a:normAutofit fontScale="90753"/>
+          </a:bodyPr>
+          <a:lstStyle xmlns:a="http://schemas.openxmlformats.org/drawingml/2006/main"/>
+          <a:p xmlns:a="http://schemas.openxmlformats.org/drawingml/2006/main">
+            <a:pPr algn="ctr">
+              <a:lnSpc>
+                <a:spcPct val="104000"/>
+              </a:lnSpc>
+              <a:buNone/>
               <a:defRPr sz="1350" b="1">
                 <a:solidFill>
                   <a:srgbClr val="687086"/>
@@ -9515,147 +10009,29 @@
                 <a:ea typeface="Arial"/>
                 <a:cs typeface="Arial"/>
               </a:rPr>
-              <a:t>mean totalVI AUC</a:t>
-            </a:r>
-          </a:p>
-        </p:txBody>
-      </p:sp>
-      <p:sp>
-        <p:nvSpPr>
-          <p:cNvPr id="8" name="">
-            <a:extLst xmlns:a="http://schemas.openxmlformats.org/drawingml/2006/main">
-              <a:ext uri="{FF2B5EF4-FFF2-40B4-BE49-F238E27FC236}">
-                <a16:creationId xmlns:a16="http://schemas.microsoft.com/office/drawing/2014/main" id="{481F74E5-EE1F-4F30-875B-0DB163B9F1A1}"/>
-              </a:ext>
-            </a:extLst>
-          </p:cNvPr>
-          <p:cNvSpPr>
-            <a:spLocks xmlns:a="http://schemas.openxmlformats.org/drawingml/2006/main" noGrp="1"/>
-          </p:cNvSpPr>
-          <p:nvPr/>
-        </p:nvSpPr>
-        <p:spPr>
-          <a:xfrm xmlns:a="http://schemas.openxmlformats.org/drawingml/2006/main">
-            <a:off x="9696450" y="3067050"/>
-            <a:ext cx="1714500" cy="28575"/>
-          </a:xfrm>
-          <a:prstGeom xmlns:a="http://schemas.openxmlformats.org/drawingml/2006/main" prst="rect">
-            <a:avLst/>
-          </a:prstGeom>
-          <a:solidFill xmlns:a="http://schemas.openxmlformats.org/drawingml/2006/main">
-            <a:srgbClr val="F15B64"/>
-          </a:solidFill>
-          <a:ln xmlns:a="http://schemas.openxmlformats.org/drawingml/2006/main" w="0">
-            <a:noFill/>
-          </a:ln>
-        </p:spPr>
-      </p:sp>
-      <p:sp>
-        <p:nvSpPr>
-          <p:cNvPr id="9" name="">
-            <a:extLst xmlns:a="http://schemas.openxmlformats.org/drawingml/2006/main">
-              <a:ext uri="{FF2B5EF4-FFF2-40B4-BE49-F238E27FC236}">
-                <a16:creationId xmlns:a16="http://schemas.microsoft.com/office/drawing/2014/main" id="{44B78626-8586-4A16-A234-A621BECE53B9}"/>
-              </a:ext>
-            </a:extLst>
-          </p:cNvPr>
-          <p:cNvSpPr>
-            <a:spLocks xmlns:a="http://schemas.openxmlformats.org/drawingml/2006/main" noGrp="1"/>
-          </p:cNvSpPr>
-          <p:nvPr/>
-        </p:nvSpPr>
-        <p:spPr>
-          <a:xfrm xmlns:a="http://schemas.openxmlformats.org/drawingml/2006/main">
-            <a:off x="9525000" y="3390900"/>
-            <a:ext cx="2095500" cy="800100"/>
-          </a:xfrm>
-          <a:prstGeom xmlns:a="http://schemas.openxmlformats.org/drawingml/2006/main" prst="rect">
-            <a:avLst/>
-          </a:prstGeom>
-          <a:noFill xmlns:a="http://schemas.openxmlformats.org/drawingml/2006/main"/>
-          <a:ln xmlns:a="http://schemas.openxmlformats.org/drawingml/2006/main" w="0">
-            <a:noFill/>
-          </a:ln>
-        </p:spPr>
-        <p:txBody>
-          <a:bodyPr xmlns:a="http://schemas.openxmlformats.org/drawingml/2006/main" anchor="ctr">
-            <a:normAutofit fontScale="82799"/>
-          </a:bodyPr>
-          <a:lstStyle xmlns:a="http://schemas.openxmlformats.org/drawingml/2006/main"/>
-          <a:p xmlns:a="http://schemas.openxmlformats.org/drawingml/2006/main">
-            <a:pPr algn="ctr">
-              <a:lnSpc>
-                <a:spcPct val="104000"/>
-              </a:lnSpc>
-              <a:buNone/>
-              <a:defRPr sz="1800" b="1">
-                <a:solidFill>
-                  <a:srgbClr val="223A69"/>
-                </a:solidFill>
-                <a:latin typeface="Arial"/>
-                <a:ea typeface="Arial"/>
-                <a:cs typeface="Arial"/>
-              </a:defRPr>
-            </a:pPr>
-            <a:r>
-              <a:rPr sz="1800" b="1">
-                <a:solidFill>
-                  <a:srgbClr val="223A69"/>
-                </a:solidFill>
-                <a:latin typeface="Arial"/>
-                <a:ea typeface="Arial"/>
-                <a:cs typeface="Arial"/>
-              </a:rPr>
-              <a:t>RNA PCA also reached</a:t>
-            </a:r>
-          </a:p>
-          <a:p xmlns:a="http://schemas.openxmlformats.org/drawingml/2006/main">
-            <a:pPr algn="ctr">
-              <a:lnSpc>
-                <a:spcPct val="104000"/>
-              </a:lnSpc>
-              <a:buNone/>
-              <a:defRPr sz="1800" b="1">
-                <a:solidFill>
-                  <a:srgbClr val="223A69"/>
-                </a:solidFill>
-                <a:latin typeface="Arial"/>
-                <a:ea typeface="Arial"/>
-                <a:cs typeface="Arial"/>
-              </a:defRPr>
-            </a:pPr>
-            <a:r>
-              <a:rPr sz="1800" b="1">
-                <a:solidFill>
-                  <a:srgbClr val="223A69"/>
-                </a:solidFill>
-                <a:latin typeface="Arial"/>
-                <a:ea typeface="Arial"/>
-                <a:cs typeface="Arial"/>
-              </a:rPr>
-              <a:t>0.989–1.000</a:t>
-            </a:r>
-          </a:p>
-        </p:txBody>
-      </p:sp>
-      <p:sp>
-        <p:nvSpPr>
-          <p:cNvPr id="10" name="">
-            <a:extLst xmlns:a="http://schemas.openxmlformats.org/drawingml/2006/main">
-              <a:ext uri="{FF2B5EF4-FFF2-40B4-BE49-F238E27FC236}">
-                <a16:creationId xmlns:a16="http://schemas.microsoft.com/office/drawing/2014/main" id="{D17EFBDF-4972-4502-ADA4-ED8CC2BD3B10}"/>
-              </a:ext>
-            </a:extLst>
-          </p:cNvPr>
-          <p:cNvSpPr>
-            <a:spLocks xmlns:a="http://schemas.openxmlformats.org/drawingml/2006/main" noGrp="1"/>
-          </p:cNvSpPr>
-          <p:nvPr/>
-        </p:nvSpPr>
-        <p:spPr>
-          <a:xfrm xmlns:a="http://schemas.openxmlformats.org/drawingml/2006/main">
-            <a:off x="9525000" y="4686300"/>
-            <a:ext cx="2095500" cy="247650"/>
+              <a:t>75 target × replicate effects</a:t>
+            </a:r>
+          </a:p>
+        </p:txBody>
+      </p:sp>
+      <p:sp>
+        <p:nvSpPr>
+          <p:cNvPr id="18" name="">
+            <a:extLst xmlns:a="http://schemas.openxmlformats.org/drawingml/2006/main">
+              <a:ext uri="{FF2B5EF4-FFF2-40B4-BE49-F238E27FC236}">
+                <a16:creationId xmlns:a16="http://schemas.microsoft.com/office/drawing/2014/main" id="{B179ED15-B150-4222-90AB-288EDBCDE968}"/>
+              </a:ext>
+            </a:extLst>
+          </p:cNvPr>
+          <p:cNvSpPr>
+            <a:spLocks xmlns:a="http://schemas.openxmlformats.org/drawingml/2006/main" noGrp="1"/>
+          </p:cNvSpPr>
+          <p:nvPr/>
+        </p:nvSpPr>
+        <p:spPr>
+          <a:xfrm xmlns:a="http://schemas.openxmlformats.org/drawingml/2006/main">
+            <a:off x="685800" y="6381750"/>
+            <a:ext cx="5715000" cy="190500"/>
           </a:xfrm>
           <a:prstGeom xmlns:a="http://schemas.openxmlformats.org/drawingml/2006/main" prst="rect">
             <a:avLst/>
@@ -9667,95 +10043,34 @@
         </p:spPr>
         <p:txBody>
           <a:bodyPr xmlns:a="http://schemas.openxmlformats.org/drawingml/2006/main" anchor="t">
-            <a:normAutofit fontScale="82131"/>
-          </a:bodyPr>
-          <a:lstStyle xmlns:a="http://schemas.openxmlformats.org/drawingml/2006/main"/>
-          <a:p xmlns:a="http://schemas.openxmlformats.org/drawingml/2006/main">
-            <a:pPr algn="ctr">
-              <a:lnSpc>
-                <a:spcPct val="104000"/>
-              </a:lnSpc>
-              <a:buNone/>
-              <a:defRPr sz="1200" b="1">
-                <a:solidFill>
-                  <a:srgbClr val="0D8A9A"/>
-                </a:solidFill>
-                <a:latin typeface="Arial"/>
-                <a:ea typeface="Arial"/>
-                <a:cs typeface="Arial"/>
-              </a:defRPr>
-            </a:pPr>
-            <a:r>
-              <a:rPr sz="1200" b="1">
-                <a:solidFill>
-                  <a:srgbClr val="0D8A9A"/>
-                </a:solidFill>
-                <a:latin typeface="Arial"/>
-                <a:ea typeface="Arial"/>
-                <a:cs typeface="Arial"/>
-              </a:rPr>
-              <a:t>Interpretation</a:t>
-            </a:r>
-          </a:p>
-        </p:txBody>
-      </p:sp>
-      <p:sp>
-        <p:nvSpPr>
-          <p:cNvPr id="11" name="">
-            <a:extLst xmlns:a="http://schemas.openxmlformats.org/drawingml/2006/main">
-              <a:ext uri="{FF2B5EF4-FFF2-40B4-BE49-F238E27FC236}">
-                <a16:creationId xmlns:a16="http://schemas.microsoft.com/office/drawing/2014/main" id="{C95BCEEB-35AF-4595-A4B4-097AA8FE7870}"/>
-              </a:ext>
-            </a:extLst>
-          </p:cNvPr>
-          <p:cNvSpPr>
-            <a:spLocks xmlns:a="http://schemas.openxmlformats.org/drawingml/2006/main" noGrp="1"/>
-          </p:cNvSpPr>
-          <p:nvPr/>
-        </p:nvSpPr>
-        <p:spPr>
-          <a:xfrm xmlns:a="http://schemas.openxmlformats.org/drawingml/2006/main">
-            <a:off x="9429750" y="5010150"/>
-            <a:ext cx="2286000" cy="914400"/>
-          </a:xfrm>
-          <a:prstGeom xmlns:a="http://schemas.openxmlformats.org/drawingml/2006/main" prst="rect">
-            <a:avLst/>
-          </a:prstGeom>
-          <a:noFill xmlns:a="http://schemas.openxmlformats.org/drawingml/2006/main"/>
-          <a:ln xmlns:a="http://schemas.openxmlformats.org/drawingml/2006/main" w="0">
-            <a:noFill/>
-          </a:ln>
-        </p:spPr>
-        <p:txBody>
-          <a:bodyPr xmlns:a="http://schemas.openxmlformats.org/drawingml/2006/main" anchor="ctr">
-            <a:normAutofit fontScale="100000"/>
-          </a:bodyPr>
-          <a:lstStyle xmlns:a="http://schemas.openxmlformats.org/drawingml/2006/main"/>
-          <a:p xmlns:a="http://schemas.openxmlformats.org/drawingml/2006/main">
-            <a:pPr algn="ctr">
-              <a:lnSpc>
-                <a:spcPct val="104000"/>
-              </a:lnSpc>
-              <a:buNone/>
-              <a:defRPr sz="1500" b="0">
-                <a:solidFill>
-                  <a:srgbClr val="17223B"/>
-                </a:solidFill>
-                <a:latin typeface="Arial"/>
-                <a:ea typeface="Arial"/>
-                <a:cs typeface="Arial"/>
-              </a:defRPr>
-            </a:pPr>
-            <a:r>
-              <a:rPr sz="1500" b="0">
-                <a:solidFill>
-                  <a:srgbClr val="17223B"/>
-                </a:solidFill>
-                <a:latin typeface="Arial"/>
-                <a:ea typeface="Arial"/>
-                <a:cs typeface="Arial"/>
-              </a:rPr>
-              <a:t>Condition classification cannot reveal a better fusion strategy here.</a:t>
+            <a:normAutofit fontScale="69444"/>
+          </a:bodyPr>
+          <a:lstStyle xmlns:a="http://schemas.openxmlformats.org/drawingml/2006/main"/>
+          <a:p xmlns:a="http://schemas.openxmlformats.org/drawingml/2006/main">
+            <a:pPr algn="l">
+              <a:lnSpc>
+                <a:spcPct val="104000"/>
+              </a:lnSpc>
+              <a:buNone/>
+              <a:defRPr sz="900" b="0">
+                <a:solidFill>
+                  <a:srgbClr val="687086"/>
+                </a:solidFill>
+                <a:latin typeface="Arial"/>
+                <a:ea typeface="Arial"/>
+                <a:cs typeface="Arial"/>
+              </a:defRPr>
+            </a:pPr>
+            <a:r>
+              <a:rPr sz="900" b="0">
+                <a:solidFill>
+                  <a:srgbClr val="687086"/>
+                </a:solidFill>
+                <a:latin typeface="Arial"/>
+                <a:ea typeface="Arial"/>
+                <a:cs typeface="Arial"/>
+              </a:rPr>
+              <a:t>Source: Papalexi et al., Nature Genetics 2021, Fig. 1a</a:t>
             </a:r>
           </a:p>
         </p:txBody>
@@ -9763,7 +10078,7 @@
     </p:spTree>
     <p:extLst>
       <p:ext uri="{BB962C8B-B14F-4D97-AF65-F5344CB8AC3E}">
-        <p14:creationId xmlns:p14="http://schemas.microsoft.com/office/powerpoint/2010/main" val="1543635900"/>
+        <p14:creationId xmlns:p14="http://schemas.microsoft.com/office/powerpoint/2010/main" val="1017116780"/>
       </p:ext>
     </p:extLst>
   </p:cSld>
@@ -9794,7 +10109,7 @@
           <p:cNvPr id="18" name="">
             <a:extLst xmlns:a="http://schemas.openxmlformats.org/drawingml/2006/main">
               <a:ext uri="{FF2B5EF4-FFF2-40B4-BE49-F238E27FC236}">
-                <a16:creationId xmlns:a16="http://schemas.microsoft.com/office/drawing/2014/main" id="{81709296-E4DD-4F0F-B970-4DF7122107F7}"/>
+                <a16:creationId xmlns:a16="http://schemas.microsoft.com/office/drawing/2014/main" id="{9529BD03-ADBA-4AC6-AE43-4FF8E001D8EF}"/>
               </a:ext>
             </a:extLst>
           </p:cNvPr>
@@ -9855,7 +10170,7 @@
           <p:cNvPr id="2" name="">
             <a:extLst xmlns:a="http://schemas.openxmlformats.org/drawingml/2006/main">
               <a:ext uri="{FF2B5EF4-FFF2-40B4-BE49-F238E27FC236}">
-                <a16:creationId xmlns:a16="http://schemas.microsoft.com/office/drawing/2014/main" id="{0BDCE190-6BE5-4BE1-A232-7FB02A6F1C4F}"/>
+                <a16:creationId xmlns:a16="http://schemas.microsoft.com/office/drawing/2014/main" id="{234BFE4C-2601-484E-AE3F-12547210FA39}"/>
               </a:ext>
             </a:extLst>
           </p:cNvPr>
@@ -9916,7 +10231,7 @@
           <p:cNvPr id="3" name="">
             <a:extLst xmlns:a="http://schemas.openxmlformats.org/drawingml/2006/main">
               <a:ext uri="{FF2B5EF4-FFF2-40B4-BE49-F238E27FC236}">
-                <a16:creationId xmlns:a16="http://schemas.microsoft.com/office/drawing/2014/main" id="{0192E3AF-8448-4214-B473-E6B544BDE2F3}"/>
+                <a16:creationId xmlns:a16="http://schemas.microsoft.com/office/drawing/2014/main" id="{3F9EF1AD-A058-4AF9-AEB6-F5C4778BEFDF}"/>
               </a:ext>
             </a:extLst>
           </p:cNvPr>
@@ -9946,7 +10261,7 @@
           <p:cNvPr id="4" name="">
             <a:extLst xmlns:a="http://schemas.openxmlformats.org/drawingml/2006/main">
               <a:ext uri="{FF2B5EF4-FFF2-40B4-BE49-F238E27FC236}">
-                <a16:creationId xmlns:a16="http://schemas.microsoft.com/office/drawing/2014/main" id="{A01BD070-DA46-46DF-BDC8-74EC70F8DA30}"/>
+                <a16:creationId xmlns:a16="http://schemas.microsoft.com/office/drawing/2014/main" id="{A4ABBB31-3F9B-4C85-82E0-14E60074D921}"/>
               </a:ext>
             </a:extLst>
           </p:cNvPr>
@@ -10011,7 +10326,7 @@
           <p:nvPr/>
         </p:nvPicPr>
         <p:blipFill>
-          <a:blip xmlns:r="http://schemas.openxmlformats.org/officeDocument/2006/relationships" xmlns:a="http://schemas.openxmlformats.org/drawingml/2006/main" r:embed="R088c4ccd02404c71"/>
+          <a:blip xmlns:r="http://schemas.openxmlformats.org/officeDocument/2006/relationships" xmlns:a="http://schemas.openxmlformats.org/drawingml/2006/main" r:embed="R37a9fed2bbbc485f"/>
           <a:stretch xmlns:a="http://schemas.openxmlformats.org/drawingml/2006/main"/>
         </p:blipFill>
         <p:spPr>
@@ -10029,7 +10344,7 @@
           <p:cNvPr id="6" name="">
             <a:extLst xmlns:a="http://schemas.openxmlformats.org/drawingml/2006/main">
               <a:ext uri="{FF2B5EF4-FFF2-40B4-BE49-F238E27FC236}">
-                <a16:creationId xmlns:a16="http://schemas.microsoft.com/office/drawing/2014/main" id="{9E7B9674-D070-46AC-80E6-EE28CEA0D5F0}"/>
+                <a16:creationId xmlns:a16="http://schemas.microsoft.com/office/drawing/2014/main" id="{D83E7417-8351-483B-B742-57EFAC93C252}"/>
               </a:ext>
             </a:extLst>
           </p:cNvPr>
@@ -10090,7 +10405,7 @@
           <p:cNvPr id="7" name="">
             <a:extLst xmlns:a="http://schemas.openxmlformats.org/drawingml/2006/main">
               <a:ext uri="{FF2B5EF4-FFF2-40B4-BE49-F238E27FC236}">
-                <a16:creationId xmlns:a16="http://schemas.microsoft.com/office/drawing/2014/main" id="{390F44EF-F69E-4E4B-87E2-689B88845A5C}"/>
+                <a16:creationId xmlns:a16="http://schemas.microsoft.com/office/drawing/2014/main" id="{C3F645D9-0E0F-4D79-9215-A205DE94069F}"/>
               </a:ext>
             </a:extLst>
           </p:cNvPr>
@@ -10151,7 +10466,7 @@
           <p:cNvPr id="8" name="">
             <a:extLst xmlns:a="http://schemas.openxmlformats.org/drawingml/2006/main">
               <a:ext uri="{FF2B5EF4-FFF2-40B4-BE49-F238E27FC236}">
-                <a16:creationId xmlns:a16="http://schemas.microsoft.com/office/drawing/2014/main" id="{3FA5147B-F615-4A24-80F5-9D991B5167AE}"/>
+                <a16:creationId xmlns:a16="http://schemas.microsoft.com/office/drawing/2014/main" id="{8619D6BD-7EB2-4042-BE8B-4148B088AAA6}"/>
               </a:ext>
             </a:extLst>
           </p:cNvPr>
@@ -10212,7 +10527,7 @@
           <p:cNvPr id="9" name="">
             <a:extLst xmlns:a="http://schemas.openxmlformats.org/drawingml/2006/main">
               <a:ext uri="{FF2B5EF4-FFF2-40B4-BE49-F238E27FC236}">
-                <a16:creationId xmlns:a16="http://schemas.microsoft.com/office/drawing/2014/main" id="{85BECEDE-FB2E-4A0E-AFC9-8F1F34D51AD1}"/>
+                <a16:creationId xmlns:a16="http://schemas.microsoft.com/office/drawing/2014/main" id="{66F0B36B-2A6C-47CD-8E01-9B9C07DCC745}"/>
               </a:ext>
             </a:extLst>
           </p:cNvPr>
@@ -10273,7 +10588,7 @@
           <p:cNvPr id="10" name="">
             <a:extLst xmlns:a="http://schemas.openxmlformats.org/drawingml/2006/main">
               <a:ext uri="{FF2B5EF4-FFF2-40B4-BE49-F238E27FC236}">
-                <a16:creationId xmlns:a16="http://schemas.microsoft.com/office/drawing/2014/main" id="{06308672-3F86-40D9-8CB8-B6025A64C15D}"/>
+                <a16:creationId xmlns:a16="http://schemas.microsoft.com/office/drawing/2014/main" id="{44E8B303-4A6D-459F-8984-E3E5761663CE}"/>
               </a:ext>
             </a:extLst>
           </p:cNvPr>
@@ -10334,7 +10649,7 @@
           <p:cNvPr id="11" name="">
             <a:extLst xmlns:a="http://schemas.openxmlformats.org/drawingml/2006/main">
               <a:ext uri="{FF2B5EF4-FFF2-40B4-BE49-F238E27FC236}">
-                <a16:creationId xmlns:a16="http://schemas.microsoft.com/office/drawing/2014/main" id="{E12A9413-2E74-4D45-818C-DE8A325BC708}"/>
+                <a16:creationId xmlns:a16="http://schemas.microsoft.com/office/drawing/2014/main" id="{C27BC71B-F2D7-4953-ADAB-73310B577C53}"/>
               </a:ext>
             </a:extLst>
           </p:cNvPr>
@@ -10395,7 +10710,7 @@
           <p:cNvPr id="12" name="">
             <a:extLst xmlns:a="http://schemas.openxmlformats.org/drawingml/2006/main">
               <a:ext uri="{FF2B5EF4-FFF2-40B4-BE49-F238E27FC236}">
-                <a16:creationId xmlns:a16="http://schemas.microsoft.com/office/drawing/2014/main" id="{F6653246-E945-42C6-BD10-BB41ACB68613}"/>
+                <a16:creationId xmlns:a16="http://schemas.microsoft.com/office/drawing/2014/main" id="{FD1421B2-592C-4CFF-8AD3-AD5FC37E620A}"/>
               </a:ext>
             </a:extLst>
           </p:cNvPr>
@@ -10456,7 +10771,7 @@
           <p:cNvPr id="13" name="">
             <a:extLst xmlns:a="http://schemas.openxmlformats.org/drawingml/2006/main">
               <a:ext uri="{FF2B5EF4-FFF2-40B4-BE49-F238E27FC236}">
-                <a16:creationId xmlns:a16="http://schemas.microsoft.com/office/drawing/2014/main" id="{0D75D9AE-6E7A-4254-A39B-377EA7CE5E43}"/>
+                <a16:creationId xmlns:a16="http://schemas.microsoft.com/office/drawing/2014/main" id="{441EBAFE-067A-480A-9B38-0A6D20416FC8}"/>
               </a:ext>
             </a:extLst>
           </p:cNvPr>
@@ -10517,7 +10832,7 @@
           <p:cNvPr id="14" name="">
             <a:extLst xmlns:a="http://schemas.openxmlformats.org/drawingml/2006/main">
               <a:ext uri="{FF2B5EF4-FFF2-40B4-BE49-F238E27FC236}">
-                <a16:creationId xmlns:a16="http://schemas.microsoft.com/office/drawing/2014/main" id="{F437B5CC-3E14-485A-ACED-0DC2335AD389}"/>
+                <a16:creationId xmlns:a16="http://schemas.microsoft.com/office/drawing/2014/main" id="{0D6F9439-C14D-4AD2-995F-AF6E49B4E7F4}"/>
               </a:ext>
             </a:extLst>
           </p:cNvPr>
@@ -10578,7 +10893,7 @@
           <p:cNvPr id="15" name="">
             <a:extLst xmlns:a="http://schemas.openxmlformats.org/drawingml/2006/main">
               <a:ext uri="{FF2B5EF4-FFF2-40B4-BE49-F238E27FC236}">
-                <a16:creationId xmlns:a16="http://schemas.microsoft.com/office/drawing/2014/main" id="{84A83D45-9C9B-49F4-ACC9-0BC989481B20}"/>
+                <a16:creationId xmlns:a16="http://schemas.microsoft.com/office/drawing/2014/main" id="{C3F5221B-7313-412E-9738-E6461BBEC4E2}"/>
               </a:ext>
             </a:extLst>
           </p:cNvPr>
@@ -10639,7 +10954,7 @@
           <p:cNvPr id="16" name="">
             <a:extLst xmlns:a="http://schemas.openxmlformats.org/drawingml/2006/main">
               <a:ext uri="{FF2B5EF4-FFF2-40B4-BE49-F238E27FC236}">
-                <a16:creationId xmlns:a16="http://schemas.microsoft.com/office/drawing/2014/main" id="{105132D4-B479-4E45-BE62-174F19782874}"/>
+                <a16:creationId xmlns:a16="http://schemas.microsoft.com/office/drawing/2014/main" id="{18952CE2-19FC-4A80-8F3E-2A29C2DB109B}"/>
               </a:ext>
             </a:extLst>
           </p:cNvPr>
@@ -10700,7 +11015,7 @@
           <p:cNvPr id="17" name="">
             <a:extLst xmlns:a="http://schemas.openxmlformats.org/drawingml/2006/main">
               <a:ext uri="{FF2B5EF4-FFF2-40B4-BE49-F238E27FC236}">
-                <a16:creationId xmlns:a16="http://schemas.microsoft.com/office/drawing/2014/main" id="{33A1A422-1CB5-449F-B2BA-20D96B2B91C8}"/>
+                <a16:creationId xmlns:a16="http://schemas.microsoft.com/office/drawing/2014/main" id="{9028F43F-41A6-4BB1-B2D2-4994FA7785F5}"/>
               </a:ext>
             </a:extLst>
           </p:cNvPr>
@@ -10813,7 +11128,7 @@
     </p:spTree>
     <p:extLst>
       <p:ext uri="{BB962C8B-B14F-4D97-AF65-F5344CB8AC3E}">
-        <p14:creationId xmlns:p14="http://schemas.microsoft.com/office/powerpoint/2010/main" val="546324576"/>
+        <p14:creationId xmlns:p14="http://schemas.microsoft.com/office/powerpoint/2010/main" val="1693227320"/>
       </p:ext>
     </p:extLst>
   </p:cSld>
@@ -10844,7 +11159,7 @@
           <p:cNvPr id="8" name="">
             <a:extLst xmlns:a="http://schemas.openxmlformats.org/drawingml/2006/main">
               <a:ext uri="{FF2B5EF4-FFF2-40B4-BE49-F238E27FC236}">
-                <a16:creationId xmlns:a16="http://schemas.microsoft.com/office/drawing/2014/main" id="{D3E33F43-3FEF-4AED-A52E-B42E73722DD6}"/>
+                <a16:creationId xmlns:a16="http://schemas.microsoft.com/office/drawing/2014/main" id="{1D6B85C8-42E9-4AA4-998B-63ECAF572736}"/>
               </a:ext>
             </a:extLst>
           </p:cNvPr>
@@ -10905,7 +11220,7 @@
           <p:cNvPr id="2" name="">
             <a:extLst xmlns:a="http://schemas.openxmlformats.org/drawingml/2006/main">
               <a:ext uri="{FF2B5EF4-FFF2-40B4-BE49-F238E27FC236}">
-                <a16:creationId xmlns:a16="http://schemas.microsoft.com/office/drawing/2014/main" id="{5945B7DE-10A9-40BD-AF69-0FE9D1DEA8F9}"/>
+                <a16:creationId xmlns:a16="http://schemas.microsoft.com/office/drawing/2014/main" id="{C3347079-4AE6-42F5-9706-0E008BF91575}"/>
               </a:ext>
             </a:extLst>
           </p:cNvPr>
@@ -10966,7 +11281,7 @@
           <p:cNvPr id="3" name="">
             <a:extLst xmlns:a="http://schemas.openxmlformats.org/drawingml/2006/main">
               <a:ext uri="{FF2B5EF4-FFF2-40B4-BE49-F238E27FC236}">
-                <a16:creationId xmlns:a16="http://schemas.microsoft.com/office/drawing/2014/main" id="{19C0DDBB-4370-46CE-B81D-00D103F48FA7}"/>
+                <a16:creationId xmlns:a16="http://schemas.microsoft.com/office/drawing/2014/main" id="{366E2CB7-5011-45F8-AC69-52B2CAD7FECC}"/>
               </a:ext>
             </a:extLst>
           </p:cNvPr>
@@ -10996,7 +11311,7 @@
           <p:cNvPr id="4" name="">
             <a:extLst xmlns:a="http://schemas.openxmlformats.org/drawingml/2006/main">
               <a:ext uri="{FF2B5EF4-FFF2-40B4-BE49-F238E27FC236}">
-                <a16:creationId xmlns:a16="http://schemas.microsoft.com/office/drawing/2014/main" id="{326782E9-90D2-452C-B46C-9D052A674145}"/>
+                <a16:creationId xmlns:a16="http://schemas.microsoft.com/office/drawing/2014/main" id="{3C952716-E2C2-432E-A110-551C8F2B462B}"/>
               </a:ext>
             </a:extLst>
           </p:cNvPr>
@@ -11061,7 +11376,7 @@
           <p:nvPr/>
         </p:nvPicPr>
         <p:blipFill>
-          <a:blip xmlns:r="http://schemas.openxmlformats.org/officeDocument/2006/relationships" xmlns:a="http://schemas.openxmlformats.org/drawingml/2006/main" r:embed="Rf1d24e738a7e4212"/>
+          <a:blip xmlns:r="http://schemas.openxmlformats.org/officeDocument/2006/relationships" xmlns:a="http://schemas.openxmlformats.org/drawingml/2006/main" r:embed="Raf12d967216740a0"/>
           <a:stretch xmlns:a="http://schemas.openxmlformats.org/drawingml/2006/main"/>
         </p:blipFill>
         <p:spPr>
@@ -11079,7 +11394,7 @@
           <p:cNvPr id="6" name="">
             <a:extLst xmlns:a="http://schemas.openxmlformats.org/drawingml/2006/main">
               <a:ext uri="{FF2B5EF4-FFF2-40B4-BE49-F238E27FC236}">
-                <a16:creationId xmlns:a16="http://schemas.microsoft.com/office/drawing/2014/main" id="{EF0BA982-3E6D-4F07-8F6B-DAC46D66EE51}"/>
+                <a16:creationId xmlns:a16="http://schemas.microsoft.com/office/drawing/2014/main" id="{EDBCBC60-9E54-4A1C-8804-3C810713C178}"/>
               </a:ext>
             </a:extLst>
           </p:cNvPr>
@@ -11111,7 +11426,7 @@
           <p:cNvPr id="7" name="">
             <a:extLst xmlns:a="http://schemas.openxmlformats.org/drawingml/2006/main">
               <a:ext uri="{FF2B5EF4-FFF2-40B4-BE49-F238E27FC236}">
-                <a16:creationId xmlns:a16="http://schemas.microsoft.com/office/drawing/2014/main" id="{7C2AAB01-92FC-4898-B14C-80D0CA8C35CE}"/>
+                <a16:creationId xmlns:a16="http://schemas.microsoft.com/office/drawing/2014/main" id="{F42BE77F-3DA3-4869-9277-A1458921A574}"/>
               </a:ext>
             </a:extLst>
           </p:cNvPr>
@@ -11170,7 +11485,7 @@
     </p:spTree>
     <p:extLst>
       <p:ext uri="{BB962C8B-B14F-4D97-AF65-F5344CB8AC3E}">
-        <p14:creationId xmlns:p14="http://schemas.microsoft.com/office/powerpoint/2010/main" val="1637676601"/>
+        <p14:creationId xmlns:p14="http://schemas.microsoft.com/office/powerpoint/2010/main" val="524180366"/>
       </p:ext>
     </p:extLst>
   </p:cSld>
@@ -11198,10 +11513,10 @@
       </p:grpSpPr>
       <p:sp>
         <p:nvSpPr>
-          <p:cNvPr id="13" name="">
-            <a:extLst xmlns:a="http://schemas.openxmlformats.org/drawingml/2006/main">
-              <a:ext uri="{FF2B5EF4-FFF2-40B4-BE49-F238E27FC236}">
-                <a16:creationId xmlns:a16="http://schemas.microsoft.com/office/drawing/2014/main" id="{1A1844CA-0C88-462D-B117-297ED91D82F7}"/>
+          <p:cNvPr id="14" name="">
+            <a:extLst xmlns:a="http://schemas.openxmlformats.org/drawingml/2006/main">
+              <a:ext uri="{FF2B5EF4-FFF2-40B4-BE49-F238E27FC236}">
+                <a16:creationId xmlns:a16="http://schemas.microsoft.com/office/drawing/2014/main" id="{F3898A38-1A21-4FFE-B563-79C217D7C6C5}"/>
               </a:ext>
             </a:extLst>
           </p:cNvPr>
@@ -11252,7 +11567,7 @@
                 <a:ea typeface="Arial"/>
                 <a:cs typeface="Arial"/>
               </a:rPr>
-              <a:t>MECHANISTIC RESULT</a:t>
+              <a:t>EXPERIMENT 2 RESULT</a:t>
             </a:r>
           </a:p>
         </p:txBody>
@@ -11262,7 +11577,7 @@
           <p:cNvPr id="2" name="">
             <a:extLst xmlns:a="http://schemas.openxmlformats.org/drawingml/2006/main">
               <a:ext uri="{FF2B5EF4-FFF2-40B4-BE49-F238E27FC236}">
-                <a16:creationId xmlns:a16="http://schemas.microsoft.com/office/drawing/2014/main" id="{88786B1F-9795-4EE9-8812-534AD4738661}"/>
+                <a16:creationId xmlns:a16="http://schemas.microsoft.com/office/drawing/2014/main" id="{DCA2BF3F-9F76-4A0F-8C16-C8605E8D1245}"/>
               </a:ext>
             </a:extLst>
           </p:cNvPr>
@@ -11313,7 +11628,7 @@
                 <a:ea typeface="Arial"/>
                 <a:cs typeface="Arial"/>
               </a:rPr>
-              <a:t>The unsupervised gate still teaches us something</a:t>
+              <a:t>The result transfers to unseen PD-L1 perturbations</a:t>
             </a:r>
           </a:p>
         </p:txBody>
@@ -11323,7 +11638,7 @@
           <p:cNvPr id="3" name="">
             <a:extLst xmlns:a="http://schemas.openxmlformats.org/drawingml/2006/main">
               <a:ext uri="{FF2B5EF4-FFF2-40B4-BE49-F238E27FC236}">
-                <a16:creationId xmlns:a16="http://schemas.microsoft.com/office/drawing/2014/main" id="{BA961D09-E434-47AE-82B5-C7971F67B595}"/>
+                <a16:creationId xmlns:a16="http://schemas.microsoft.com/office/drawing/2014/main" id="{870C888A-9068-44C6-B8F2-3F088BAAB94A}"/>
               </a:ext>
             </a:extLst>
           </p:cNvPr>
@@ -11353,7 +11668,7 @@
           <p:cNvPr id="4" name="">
             <a:extLst xmlns:a="http://schemas.openxmlformats.org/drawingml/2006/main">
               <a:ext uri="{FF2B5EF4-FFF2-40B4-BE49-F238E27FC236}">
-                <a16:creationId xmlns:a16="http://schemas.microsoft.com/office/drawing/2014/main" id="{27D978F2-D677-4E6A-BCF5-798071540933}"/>
+                <a16:creationId xmlns:a16="http://schemas.microsoft.com/office/drawing/2014/main" id="{BF638E77-4ACC-4762-97CC-F40808BE4176}"/>
               </a:ext>
             </a:extLst>
           </p:cNvPr>
@@ -11411,20 +11726,20 @@
       </p:sp>
       <p:pic>
         <p:nvPicPr>
-          <p:cNvPr id="17" name=""/>
+          <p:cNvPr id="18" name=""/>
           <p:cNvPicPr>
             <a:picLocks xmlns:a="http://schemas.openxmlformats.org/drawingml/2006/main" noChangeAspect="1"/>
           </p:cNvPicPr>
           <p:nvPr/>
         </p:nvPicPr>
         <p:blipFill>
-          <a:blip xmlns:r="http://schemas.openxmlformats.org/officeDocument/2006/relationships" xmlns:a="http://schemas.openxmlformats.org/drawingml/2006/main" r:embed="Rc588e6ac62f24f7d"/>
+          <a:blip xmlns:r="http://schemas.openxmlformats.org/officeDocument/2006/relationships" xmlns:a="http://schemas.openxmlformats.org/drawingml/2006/main" r:embed="R8b1be33f37e243bd"/>
           <a:stretch xmlns:a="http://schemas.openxmlformats.org/drawingml/2006/main"/>
         </p:blipFill>
         <p:spPr>
           <a:xfrm xmlns:a="http://schemas.openxmlformats.org/drawingml/2006/main">
-            <a:off x="438150" y="1945817"/>
-            <a:ext cx="8001000" cy="3328317"/>
+            <a:off x="419100" y="2071279"/>
+            <a:ext cx="7981950" cy="3115492"/>
           </a:xfrm>
           <a:prstGeom xmlns:a="http://schemas.openxmlformats.org/drawingml/2006/main" prst="rect">
             <a:avLst/>
@@ -11436,19 +11751,19 @@
           <p:cNvPr id="6" name="">
             <a:extLst xmlns:a="http://schemas.openxmlformats.org/drawingml/2006/main">
               <a:ext uri="{FF2B5EF4-FFF2-40B4-BE49-F238E27FC236}">
-                <a16:creationId xmlns:a16="http://schemas.microsoft.com/office/drawing/2014/main" id="{1ACB4EF8-2710-441F-A8F1-A393499415F1}"/>
-              </a:ext>
-            </a:extLst>
-          </p:cNvPr>
-          <p:cNvSpPr>
-            <a:spLocks xmlns:a="http://schemas.openxmlformats.org/drawingml/2006/main" noGrp="1"/>
-          </p:cNvSpPr>
-          <p:nvPr/>
-        </p:nvSpPr>
-        <p:spPr>
-          <a:xfrm xmlns:a="http://schemas.openxmlformats.org/drawingml/2006/main">
-            <a:off x="8858250" y="1790700"/>
-            <a:ext cx="2190750" cy="552450"/>
+                <a16:creationId xmlns:a16="http://schemas.microsoft.com/office/drawing/2014/main" id="{58829FA3-2BB5-4B9D-9A5A-600115EF5C46}"/>
+              </a:ext>
+            </a:extLst>
+          </p:cNvPr>
+          <p:cNvSpPr>
+            <a:spLocks xmlns:a="http://schemas.openxmlformats.org/drawingml/2006/main" noGrp="1"/>
+          </p:cNvSpPr>
+          <p:nvPr/>
+        </p:nvSpPr>
+        <p:spPr>
+          <a:xfrm xmlns:a="http://schemas.openxmlformats.org/drawingml/2006/main">
+            <a:off x="8801100" y="1676400"/>
+            <a:ext cx="2381250" cy="514350"/>
           </a:xfrm>
           <a:prstGeom xmlns:a="http://schemas.openxmlformats.org/drawingml/2006/main" prst="rect">
             <a:avLst/>
@@ -11469,6 +11784,128 @@
                 <a:spcPct val="104000"/>
               </a:lnSpc>
               <a:buNone/>
+              <a:defRPr sz="2550" b="1">
+                <a:solidFill>
+                  <a:srgbClr val="F15B64"/>
+                </a:solidFill>
+                <a:latin typeface="Arial"/>
+                <a:ea typeface="Arial"/>
+                <a:cs typeface="Arial"/>
+              </a:defRPr>
+            </a:pPr>
+            <a:r>
+              <a:rPr sz="2550" b="1">
+                <a:solidFill>
+                  <a:srgbClr val="F15B64"/>
+                </a:solidFill>
+                <a:latin typeface="Arial"/>
+                <a:ea typeface="Arial"/>
+                <a:cs typeface="Arial"/>
+              </a:rPr>
+              <a:t>ρ = 0.879</a:t>
+            </a:r>
+          </a:p>
+        </p:txBody>
+      </p:sp>
+      <p:sp>
+        <p:nvSpPr>
+          <p:cNvPr id="7" name="">
+            <a:extLst xmlns:a="http://schemas.openxmlformats.org/drawingml/2006/main">
+              <a:ext uri="{FF2B5EF4-FFF2-40B4-BE49-F238E27FC236}">
+                <a16:creationId xmlns:a16="http://schemas.microsoft.com/office/drawing/2014/main" id="{16629BDB-8789-4D69-9B13-5EEEC53A1357}"/>
+              </a:ext>
+            </a:extLst>
+          </p:cNvPr>
+          <p:cNvSpPr>
+            <a:spLocks xmlns:a="http://schemas.openxmlformats.org/drawingml/2006/main" noGrp="1"/>
+          </p:cNvSpPr>
+          <p:nvPr/>
+        </p:nvSpPr>
+        <p:spPr>
+          <a:xfrm xmlns:a="http://schemas.openxmlformats.org/drawingml/2006/main">
+            <a:off x="8801100" y="2209800"/>
+            <a:ext cx="2381250" cy="285750"/>
+          </a:xfrm>
+          <a:prstGeom xmlns:a="http://schemas.openxmlformats.org/drawingml/2006/main" prst="rect">
+            <a:avLst/>
+          </a:prstGeom>
+          <a:noFill xmlns:a="http://schemas.openxmlformats.org/drawingml/2006/main"/>
+          <a:ln xmlns:a="http://schemas.openxmlformats.org/drawingml/2006/main" w="0">
+            <a:noFill/>
+          </a:ln>
+        </p:spPr>
+        <p:txBody>
+          <a:bodyPr xmlns:a="http://schemas.openxmlformats.org/drawingml/2006/main" anchor="t">
+            <a:normAutofit fontScale="90812"/>
+          </a:bodyPr>
+          <a:lstStyle xmlns:a="http://schemas.openxmlformats.org/drawingml/2006/main"/>
+          <a:p xmlns:a="http://schemas.openxmlformats.org/drawingml/2006/main">
+            <a:pPr algn="ctr">
+              <a:lnSpc>
+                <a:spcPct val="104000"/>
+              </a:lnSpc>
+              <a:buNone/>
+              <a:defRPr sz="1350" b="1">
+                <a:solidFill>
+                  <a:srgbClr val="687086"/>
+                </a:solidFill>
+                <a:latin typeface="Arial"/>
+                <a:ea typeface="Arial"/>
+                <a:cs typeface="Arial"/>
+              </a:defRPr>
+            </a:pPr>
+            <a:r>
+              <a:rPr sz="1350" b="1">
+                <a:solidFill>
+                  <a:srgbClr val="687086"/>
+                </a:solidFill>
+                <a:latin typeface="Arial"/>
+                <a:ea typeface="Arial"/>
+                <a:cs typeface="Arial"/>
+              </a:rPr>
+              <a:t>FusionVI-X effect ranking</a:t>
+            </a:r>
+          </a:p>
+        </p:txBody>
+      </p:sp>
+      <p:sp>
+        <p:nvSpPr>
+          <p:cNvPr id="8" name="">
+            <a:extLst xmlns:a="http://schemas.openxmlformats.org/drawingml/2006/main">
+              <a:ext uri="{FF2B5EF4-FFF2-40B4-BE49-F238E27FC236}">
+                <a16:creationId xmlns:a16="http://schemas.microsoft.com/office/drawing/2014/main" id="{2F142CEC-16ED-4D6E-9B45-80CF4F04A66A}"/>
+              </a:ext>
+            </a:extLst>
+          </p:cNvPr>
+          <p:cNvSpPr>
+            <a:spLocks xmlns:a="http://schemas.openxmlformats.org/drawingml/2006/main" noGrp="1"/>
+          </p:cNvSpPr>
+          <p:nvPr/>
+        </p:nvSpPr>
+        <p:spPr>
+          <a:xfrm xmlns:a="http://schemas.openxmlformats.org/drawingml/2006/main">
+            <a:off x="8801100" y="3105150"/>
+            <a:ext cx="2381250" cy="514350"/>
+          </a:xfrm>
+          <a:prstGeom xmlns:a="http://schemas.openxmlformats.org/drawingml/2006/main" prst="rect">
+            <a:avLst/>
+          </a:prstGeom>
+          <a:noFill xmlns:a="http://schemas.openxmlformats.org/drawingml/2006/main"/>
+          <a:ln xmlns:a="http://schemas.openxmlformats.org/drawingml/2006/main" w="0">
+            <a:noFill/>
+          </a:ln>
+        </p:spPr>
+        <p:txBody>
+          <a:bodyPr xmlns:a="http://schemas.openxmlformats.org/drawingml/2006/main" anchor="ctr">
+            <a:normAutofit fontScale="93623"/>
+          </a:bodyPr>
+          <a:lstStyle xmlns:a="http://schemas.openxmlformats.org/drawingml/2006/main"/>
+          <a:p xmlns:a="http://schemas.openxmlformats.org/drawingml/2006/main">
+            <a:pPr algn="ctr">
+              <a:lnSpc>
+                <a:spcPct val="104000"/>
+              </a:lnSpc>
+              <a:buNone/>
               <a:defRPr sz="2850" b="1">
                 <a:solidFill>
                   <a:srgbClr val="0D8A9A"/>
@@ -11487,41 +11924,41 @@
                 <a:ea typeface="Arial"/>
                 <a:cs typeface="Arial"/>
               </a:rPr>
-              <a:t>+0.096</a:t>
-            </a:r>
-          </a:p>
-        </p:txBody>
-      </p:sp>
-      <p:sp>
-        <p:nvSpPr>
-          <p:cNvPr id="7" name="">
-            <a:extLst xmlns:a="http://schemas.openxmlformats.org/drawingml/2006/main">
-              <a:ext uri="{FF2B5EF4-FFF2-40B4-BE49-F238E27FC236}">
-                <a16:creationId xmlns:a16="http://schemas.microsoft.com/office/drawing/2014/main" id="{1622FED7-BEAA-49C2-A41D-55C94C2C1AC3}"/>
-              </a:ext>
-            </a:extLst>
-          </p:cNvPr>
-          <p:cNvSpPr>
-            <a:spLocks xmlns:a="http://schemas.openxmlformats.org/drawingml/2006/main" noGrp="1"/>
-          </p:cNvSpPr>
-          <p:nvPr/>
-        </p:nvSpPr>
-        <p:spPr>
-          <a:xfrm xmlns:a="http://schemas.openxmlformats.org/drawingml/2006/main">
-            <a:off x="8858250" y="2381250"/>
-            <a:ext cx="2190750" cy="590550"/>
-          </a:xfrm>
-          <a:prstGeom xmlns:a="http://schemas.openxmlformats.org/drawingml/2006/main" prst="rect">
-            <a:avLst/>
-          </a:prstGeom>
-          <a:noFill xmlns:a="http://schemas.openxmlformats.org/drawingml/2006/main"/>
-          <a:ln xmlns:a="http://schemas.openxmlformats.org/drawingml/2006/main" w="0">
-            <a:noFill/>
-          </a:ln>
-        </p:spPr>
-        <p:txBody>
-          <a:bodyPr xmlns:a="http://schemas.openxmlformats.org/drawingml/2006/main" anchor="ctr">
-            <a:normAutofit fontScale="92381"/>
+              <a:t>84%</a:t>
+            </a:r>
+          </a:p>
+        </p:txBody>
+      </p:sp>
+      <p:sp>
+        <p:nvSpPr>
+          <p:cNvPr id="9" name="">
+            <a:extLst xmlns:a="http://schemas.openxmlformats.org/drawingml/2006/main">
+              <a:ext uri="{FF2B5EF4-FFF2-40B4-BE49-F238E27FC236}">
+                <a16:creationId xmlns:a16="http://schemas.microsoft.com/office/drawing/2014/main" id="{C69D21B0-F83E-47B0-B84B-1EC60EA15503}"/>
+              </a:ext>
+            </a:extLst>
+          </p:cNvPr>
+          <p:cNvSpPr>
+            <a:spLocks xmlns:a="http://schemas.openxmlformats.org/drawingml/2006/main" noGrp="1"/>
+          </p:cNvSpPr>
+          <p:nvPr/>
+        </p:nvSpPr>
+        <p:spPr>
+          <a:xfrm xmlns:a="http://schemas.openxmlformats.org/drawingml/2006/main">
+            <a:off x="8801100" y="3638550"/>
+            <a:ext cx="2381250" cy="285750"/>
+          </a:xfrm>
+          <a:prstGeom xmlns:a="http://schemas.openxmlformats.org/drawingml/2006/main" prst="rect">
+            <a:avLst/>
+          </a:prstGeom>
+          <a:noFill xmlns:a="http://schemas.openxmlformats.org/drawingml/2006/main"/>
+          <a:ln xmlns:a="http://schemas.openxmlformats.org/drawingml/2006/main" w="0">
+            <a:noFill/>
+          </a:ln>
+        </p:spPr>
+        <p:txBody>
+          <a:bodyPr xmlns:a="http://schemas.openxmlformats.org/drawingml/2006/main" anchor="t">
+            <a:normAutofit fontScale="90812"/>
           </a:bodyPr>
           <a:lstStyle xmlns:a="http://schemas.openxmlformats.org/drawingml/2006/main"/>
           <a:p xmlns:a="http://schemas.openxmlformats.org/drawingml/2006/main">
@@ -11548,183 +11985,7 @@
                 <a:ea typeface="Arial"/>
                 <a:cs typeface="Arial"/>
               </a:rPr>
-              <a:t>protein weight after</a:t>
-            </a:r>
-          </a:p>
-          <a:p xmlns:a="http://schemas.openxmlformats.org/drawingml/2006/main">
-            <a:pPr algn="ctr">
-              <a:lnSpc>
-                <a:spcPct val="104000"/>
-              </a:lnSpc>
-              <a:buNone/>
-              <a:defRPr sz="1350" b="1">
-                <a:solidFill>
-                  <a:srgbClr val="687086"/>
-                </a:solidFill>
-                <a:latin typeface="Arial"/>
-                <a:ea typeface="Arial"/>
-                <a:cs typeface="Arial"/>
-              </a:defRPr>
-            </a:pPr>
-            <a:r>
-              <a:rPr sz="1350" b="1">
-                <a:solidFill>
-                  <a:srgbClr val="687086"/>
-                </a:solidFill>
-                <a:latin typeface="Arial"/>
-                <a:ea typeface="Arial"/>
-                <a:cs typeface="Arial"/>
-              </a:rPr>
-              <a:t>anti-CD3/CD28 vs baseline</a:t>
-            </a:r>
-          </a:p>
-        </p:txBody>
-      </p:sp>
-      <p:sp>
-        <p:nvSpPr>
-          <p:cNvPr id="8" name="">
-            <a:extLst xmlns:a="http://schemas.openxmlformats.org/drawingml/2006/main">
-              <a:ext uri="{FF2B5EF4-FFF2-40B4-BE49-F238E27FC236}">
-                <a16:creationId xmlns:a16="http://schemas.microsoft.com/office/drawing/2014/main" id="{24A4D675-88E7-42F4-B764-118C9E93A926}"/>
-              </a:ext>
-            </a:extLst>
-          </p:cNvPr>
-          <p:cNvSpPr>
-            <a:spLocks xmlns:a="http://schemas.openxmlformats.org/drawingml/2006/main" noGrp="1"/>
-          </p:cNvSpPr>
-          <p:nvPr/>
-        </p:nvSpPr>
-        <p:spPr>
-          <a:xfrm xmlns:a="http://schemas.openxmlformats.org/drawingml/2006/main">
-            <a:off x="8858250" y="3524250"/>
-            <a:ext cx="2190750" cy="552450"/>
-          </a:xfrm>
-          <a:prstGeom xmlns:a="http://schemas.openxmlformats.org/drawingml/2006/main" prst="rect">
-            <a:avLst/>
-          </a:prstGeom>
-          <a:noFill xmlns:a="http://schemas.openxmlformats.org/drawingml/2006/main"/>
-          <a:ln xmlns:a="http://schemas.openxmlformats.org/drawingml/2006/main" w="0">
-            <a:noFill/>
-          </a:ln>
-        </p:spPr>
-        <p:txBody>
-          <a:bodyPr xmlns:a="http://schemas.openxmlformats.org/drawingml/2006/main" anchor="ctr">
-            <a:normAutofit fontScale="100000"/>
-          </a:bodyPr>
-          <a:lstStyle xmlns:a="http://schemas.openxmlformats.org/drawingml/2006/main"/>
-          <a:p xmlns:a="http://schemas.openxmlformats.org/drawingml/2006/main">
-            <a:pPr algn="ctr">
-              <a:lnSpc>
-                <a:spcPct val="104000"/>
-              </a:lnSpc>
-              <a:buNone/>
-              <a:defRPr sz="2850" b="1">
-                <a:solidFill>
-                  <a:srgbClr val="F15B64"/>
-                </a:solidFill>
-                <a:latin typeface="Arial"/>
-                <a:ea typeface="Arial"/>
-                <a:cs typeface="Arial"/>
-              </a:defRPr>
-            </a:pPr>
-            <a:r>
-              <a:rPr sz="2850" b="1">
-                <a:solidFill>
-                  <a:srgbClr val="F15B64"/>
-                </a:solidFill>
-                <a:latin typeface="Arial"/>
-                <a:ea typeface="Arial"/>
-                <a:cs typeface="Arial"/>
-              </a:rPr>
-              <a:t>+0.090</a:t>
-            </a:r>
-          </a:p>
-        </p:txBody>
-      </p:sp>
-      <p:sp>
-        <p:nvSpPr>
-          <p:cNvPr id="9" name="">
-            <a:extLst xmlns:a="http://schemas.openxmlformats.org/drawingml/2006/main">
-              <a:ext uri="{FF2B5EF4-FFF2-40B4-BE49-F238E27FC236}">
-                <a16:creationId xmlns:a16="http://schemas.microsoft.com/office/drawing/2014/main" id="{887148A5-6CB9-4E48-98BC-39EF1E341E0A}"/>
-              </a:ext>
-            </a:extLst>
-          </p:cNvPr>
-          <p:cNvSpPr>
-            <a:spLocks xmlns:a="http://schemas.openxmlformats.org/drawingml/2006/main" noGrp="1"/>
-          </p:cNvSpPr>
-          <p:nvPr/>
-        </p:nvSpPr>
-        <p:spPr>
-          <a:xfrm xmlns:a="http://schemas.openxmlformats.org/drawingml/2006/main">
-            <a:off x="8858250" y="4114800"/>
-            <a:ext cx="2190750" cy="590550"/>
-          </a:xfrm>
-          <a:prstGeom xmlns:a="http://schemas.openxmlformats.org/drawingml/2006/main" prst="rect">
-            <a:avLst/>
-          </a:prstGeom>
-          <a:noFill xmlns:a="http://schemas.openxmlformats.org/drawingml/2006/main"/>
-          <a:ln xmlns:a="http://schemas.openxmlformats.org/drawingml/2006/main" w="0">
-            <a:noFill/>
-          </a:ln>
-        </p:spPr>
-        <p:txBody>
-          <a:bodyPr xmlns:a="http://schemas.openxmlformats.org/drawingml/2006/main" anchor="ctr">
-            <a:normAutofit fontScale="100000"/>
-          </a:bodyPr>
-          <a:lstStyle xmlns:a="http://schemas.openxmlformats.org/drawingml/2006/main"/>
-          <a:p xmlns:a="http://schemas.openxmlformats.org/drawingml/2006/main">
-            <a:pPr algn="ctr">
-              <a:lnSpc>
-                <a:spcPct val="104000"/>
-              </a:lnSpc>
-              <a:buNone/>
-              <a:defRPr sz="1350" b="1">
-                <a:solidFill>
-                  <a:srgbClr val="687086"/>
-                </a:solidFill>
-                <a:latin typeface="Arial"/>
-                <a:ea typeface="Arial"/>
-                <a:cs typeface="Arial"/>
-              </a:defRPr>
-            </a:pPr>
-            <a:r>
-              <a:rPr sz="1350" b="1">
-                <a:solidFill>
-                  <a:srgbClr val="687086"/>
-                </a:solidFill>
-                <a:latin typeface="Arial"/>
-                <a:ea typeface="Arial"/>
-                <a:cs typeface="Arial"/>
-              </a:rPr>
-              <a:t>protein weight in</a:t>
-            </a:r>
-          </a:p>
-          <a:p xmlns:a="http://schemas.openxmlformats.org/drawingml/2006/main">
-            <a:pPr algn="ctr">
-              <a:lnSpc>
-                <a:spcPct val="104000"/>
-              </a:lnSpc>
-              <a:buNone/>
-              <a:defRPr sz="1350" b="1">
-                <a:solidFill>
-                  <a:srgbClr val="687086"/>
-                </a:solidFill>
-                <a:latin typeface="Arial"/>
-                <a:ea typeface="Arial"/>
-                <a:cs typeface="Arial"/>
-              </a:defRPr>
-            </a:pPr>
-            <a:r>
-              <a:rPr sz="1350" b="1">
-                <a:solidFill>
-                  <a:srgbClr val="687086"/>
-                </a:solidFill>
-                <a:latin typeface="Arial"/>
-                <a:ea typeface="Arial"/>
-                <a:cs typeface="Arial"/>
-              </a:rPr>
-              <a:t>CD69-discordant cells</a:t>
+              <a:t>effect direction correct</a:t>
             </a:r>
           </a:p>
         </p:txBody>
@@ -11734,23 +11995,23 @@
           <p:cNvPr id="10" name="">
             <a:extLst xmlns:a="http://schemas.openxmlformats.org/drawingml/2006/main">
               <a:ext uri="{FF2B5EF4-FFF2-40B4-BE49-F238E27FC236}">
-                <a16:creationId xmlns:a16="http://schemas.microsoft.com/office/drawing/2014/main" id="{D7D16146-3A1E-4F20-B6B9-EFE14CB9B599}"/>
-              </a:ext>
-            </a:extLst>
-          </p:cNvPr>
-          <p:cNvSpPr>
-            <a:spLocks xmlns:a="http://schemas.openxmlformats.org/drawingml/2006/main" noGrp="1"/>
-          </p:cNvSpPr>
-          <p:nvPr/>
-        </p:nvSpPr>
-        <p:spPr>
-          <a:xfrm xmlns:a="http://schemas.openxmlformats.org/drawingml/2006/main">
-            <a:off x="8667750" y="5219700"/>
-            <a:ext cx="2667000" cy="914400"/>
+                <a16:creationId xmlns:a16="http://schemas.microsoft.com/office/drawing/2014/main" id="{34CABD36-ECF5-4E44-B0C7-43D345F545A2}"/>
+              </a:ext>
+            </a:extLst>
+          </p:cNvPr>
+          <p:cNvSpPr>
+            <a:spLocks xmlns:a="http://schemas.openxmlformats.org/drawingml/2006/main" noGrp="1"/>
+          </p:cNvSpPr>
+          <p:nvPr/>
+        </p:nvSpPr>
+        <p:spPr>
+          <a:xfrm xmlns:a="http://schemas.openxmlformats.org/drawingml/2006/main">
+            <a:off x="8705850" y="4476750"/>
+            <a:ext cx="2667000" cy="1200150"/>
           </a:xfrm>
           <a:prstGeom xmlns:a="http://schemas.openxmlformats.org/drawingml/2006/main" prst="roundRect">
             <a:avLst>
-              <a:gd name="adj" fmla="val 12500"/>
+              <a:gd name="adj" fmla="val 9524"/>
             </a:avLst>
           </a:prstGeom>
           <a:solidFill xmlns:a="http://schemas.openxmlformats.org/drawingml/2006/main">
@@ -11766,19 +12027,19 @@
           <p:cNvPr id="11" name="">
             <a:extLst xmlns:a="http://schemas.openxmlformats.org/drawingml/2006/main">
               <a:ext uri="{FF2B5EF4-FFF2-40B4-BE49-F238E27FC236}">
-                <a16:creationId xmlns:a16="http://schemas.microsoft.com/office/drawing/2014/main" id="{CA9A165B-9565-49E4-8738-770F5A6DB69D}"/>
-              </a:ext>
-            </a:extLst>
-          </p:cNvPr>
-          <p:cNvSpPr>
-            <a:spLocks xmlns:a="http://schemas.openxmlformats.org/drawingml/2006/main" noGrp="1"/>
-          </p:cNvSpPr>
-          <p:nvPr/>
-        </p:nvSpPr>
-        <p:spPr>
-          <a:xfrm xmlns:a="http://schemas.openxmlformats.org/drawingml/2006/main">
-            <a:off x="8858250" y="5391150"/>
-            <a:ext cx="2286000" cy="285750"/>
+                <a16:creationId xmlns:a16="http://schemas.microsoft.com/office/drawing/2014/main" id="{241212B8-59F7-468B-B31F-75B410A4DBE8}"/>
+              </a:ext>
+            </a:extLst>
+          </p:cNvPr>
+          <p:cNvSpPr>
+            <a:spLocks xmlns:a="http://schemas.openxmlformats.org/drawingml/2006/main" noGrp="1"/>
+          </p:cNvSpPr>
+          <p:nvPr/>
+        </p:nvSpPr>
+        <p:spPr>
+          <a:xfrm xmlns:a="http://schemas.openxmlformats.org/drawingml/2006/main">
+            <a:off x="8896350" y="4629150"/>
+            <a:ext cx="2286000" cy="247650"/>
           </a:xfrm>
           <a:prstGeom xmlns:a="http://schemas.openxmlformats.org/drawingml/2006/main" prst="rect">
             <a:avLst/>
@@ -11790,7 +12051,7 @@
         </p:spPr>
         <p:txBody>
           <a:bodyPr xmlns:a="http://schemas.openxmlformats.org/drawingml/2006/main" anchor="ctr">
-            <a:normAutofit fontScale="74301"/>
+            <a:normAutofit fontScale="73006"/>
           </a:bodyPr>
           <a:lstStyle xmlns:a="http://schemas.openxmlformats.org/drawingml/2006/main"/>
           <a:p xmlns:a="http://schemas.openxmlformats.org/drawingml/2006/main">
@@ -11799,7 +12060,7 @@
                 <a:spcPct val="104000"/>
               </a:lnSpc>
               <a:buNone/>
-              <a:defRPr sz="1650" b="1">
+              <a:defRPr sz="1350" b="1">
                 <a:solidFill>
                   <a:srgbClr val="F15B64"/>
                 </a:solidFill>
@@ -11809,7 +12070,7 @@
               </a:defRPr>
             </a:pPr>
             <a:r>
-              <a:rPr sz="1650" b="1">
+              <a:rPr sz="1350" b="1">
                 <a:solidFill>
                   <a:srgbClr val="F15B64"/>
                 </a:solidFill>
@@ -11817,7 +12078,7 @@
                 <a:ea typeface="Arial"/>
                 <a:cs typeface="Arial"/>
               </a:rPr>
-              <a:t>Gate ≠ targeted readout</a:t>
+              <a:t>Useful failure</a:t>
             </a:r>
           </a:p>
         </p:txBody>
@@ -11827,19 +12088,19 @@
           <p:cNvPr id="12" name="">
             <a:extLst xmlns:a="http://schemas.openxmlformats.org/drawingml/2006/main">
               <a:ext uri="{FF2B5EF4-FFF2-40B4-BE49-F238E27FC236}">
-                <a16:creationId xmlns:a16="http://schemas.microsoft.com/office/drawing/2014/main" id="{32919308-EB66-4D82-9A43-B40654C24360}"/>
-              </a:ext>
-            </a:extLst>
-          </p:cNvPr>
-          <p:cNvSpPr>
-            <a:spLocks xmlns:a="http://schemas.openxmlformats.org/drawingml/2006/main" noGrp="1"/>
-          </p:cNvSpPr>
-          <p:nvPr/>
-        </p:nvSpPr>
-        <p:spPr>
-          <a:xfrm xmlns:a="http://schemas.openxmlformats.org/drawingml/2006/main">
-            <a:off x="8858250" y="5743575"/>
-            <a:ext cx="2286000" cy="285750"/>
+                <a16:creationId xmlns:a16="http://schemas.microsoft.com/office/drawing/2014/main" id="{881A6387-A4E6-4C1D-B374-3A58C5FCA620}"/>
+              </a:ext>
+            </a:extLst>
+          </p:cNvPr>
+          <p:cNvSpPr>
+            <a:spLocks xmlns:a="http://schemas.openxmlformats.org/drawingml/2006/main" noGrp="1"/>
+          </p:cNvSpPr>
+          <p:nvPr/>
+        </p:nvSpPr>
+        <p:spPr>
+          <a:xfrm xmlns:a="http://schemas.openxmlformats.org/drawingml/2006/main">
+            <a:off x="8896350" y="4972050"/>
+            <a:ext cx="2286000" cy="552450"/>
           </a:xfrm>
           <a:prstGeom xmlns:a="http://schemas.openxmlformats.org/drawingml/2006/main" prst="rect">
             <a:avLst/>
@@ -11851,7 +12112,7 @@
         </p:spPr>
         <p:txBody>
           <a:bodyPr xmlns:a="http://schemas.openxmlformats.org/drawingml/2006/main" anchor="ctr">
-            <a:normAutofit fontScale="63703"/>
+            <a:normAutofit fontScale="82647"/>
           </a:bodyPr>
           <a:lstStyle xmlns:a="http://schemas.openxmlformats.org/drawingml/2006/main"/>
           <a:p xmlns:a="http://schemas.openxmlformats.org/drawingml/2006/main">
@@ -11860,7 +12121,7 @@
                 <a:spcPct val="104000"/>
               </a:lnSpc>
               <a:buNone/>
-              <a:defRPr sz="1275" b="0">
+              <a:defRPr sz="1350" b="1">
                 <a:solidFill>
                   <a:srgbClr val="17223B"/>
                 </a:solidFill>
@@ -11870,7 +12131,7 @@
               </a:defRPr>
             </a:pPr>
             <a:r>
-              <a:rPr sz="1275" b="0">
+              <a:rPr sz="1350" b="1">
                 <a:solidFill>
                   <a:srgbClr val="17223B"/>
                 </a:solidFill>
@@ -11878,7 +12139,68 @@
                 <a:ea typeface="Arial"/>
                 <a:cs typeface="Arial"/>
               </a:rPr>
-              <a:t>Biological context needs endpoint supervision.</a:t>
+              <a:t>CMTM6 lowers surface PD-L1, but RNA and the model miss it.</a:t>
+            </a:r>
+          </a:p>
+        </p:txBody>
+      </p:sp>
+      <p:sp>
+        <p:nvSpPr>
+          <p:cNvPr id="13" name="">
+            <a:extLst xmlns:a="http://schemas.openxmlformats.org/drawingml/2006/main">
+              <a:ext uri="{FF2B5EF4-FFF2-40B4-BE49-F238E27FC236}">
+                <a16:creationId xmlns:a16="http://schemas.microsoft.com/office/drawing/2014/main" id="{7FAA8BE1-5EEF-490F-84C6-0CB45B7389D7}"/>
+              </a:ext>
+            </a:extLst>
+          </p:cNvPr>
+          <p:cNvSpPr>
+            <a:spLocks xmlns:a="http://schemas.openxmlformats.org/drawingml/2006/main" noGrp="1"/>
+          </p:cNvSpPr>
+          <p:nvPr/>
+        </p:nvSpPr>
+        <p:spPr>
+          <a:xfrm xmlns:a="http://schemas.openxmlformats.org/drawingml/2006/main">
+            <a:off x="685800" y="6115050"/>
+            <a:ext cx="10001250" cy="247650"/>
+          </a:xfrm>
+          <a:prstGeom xmlns:a="http://schemas.openxmlformats.org/drawingml/2006/main" prst="rect">
+            <a:avLst/>
+          </a:prstGeom>
+          <a:noFill xmlns:a="http://schemas.openxmlformats.org/drawingml/2006/main"/>
+          <a:ln xmlns:a="http://schemas.openxmlformats.org/drawingml/2006/main" w="0">
+            <a:noFill/>
+          </a:ln>
+        </p:spPr>
+        <p:txBody>
+          <a:bodyPr xmlns:a="http://schemas.openxmlformats.org/drawingml/2006/main" anchor="t">
+            <a:normAutofit fontScale="77300"/>
+          </a:bodyPr>
+          <a:lstStyle xmlns:a="http://schemas.openxmlformats.org/drawingml/2006/main"/>
+          <a:p xmlns:a="http://schemas.openxmlformats.org/drawingml/2006/main">
+            <a:pPr algn="l">
+              <a:lnSpc>
+                <a:spcPct val="104000"/>
+              </a:lnSpc>
+              <a:buNone/>
+              <a:defRPr sz="1275" b="1">
+                <a:solidFill>
+                  <a:srgbClr val="223A69"/>
+                </a:solidFill>
+                <a:latin typeface="Arial"/>
+                <a:ea typeface="Arial"/>
+                <a:cs typeface="Arial"/>
+              </a:defRPr>
+            </a:pPr>
+            <a:r>
+              <a:rPr sz="1275" b="1">
+                <a:solidFill>
+                  <a:srgbClr val="223A69"/>
+                </a:solidFill>
+                <a:latin typeface="Arial"/>
+                <a:ea typeface="Arial"/>
+                <a:cs typeface="Arial"/>
+              </a:rPr>
+              <a:t>FusionVI-X vs totalVI-X: median target error reduction 0.0042; p = 0.042</a:t>
             </a:r>
           </a:p>
         </p:txBody>
@@ -11886,7 +12208,7 @@
     </p:spTree>
     <p:extLst>
       <p:ext uri="{BB962C8B-B14F-4D97-AF65-F5344CB8AC3E}">
-        <p14:creationId xmlns:p14="http://schemas.microsoft.com/office/powerpoint/2010/main" val="990709235"/>
+        <p14:creationId xmlns:p14="http://schemas.microsoft.com/office/powerpoint/2010/main" val="652865722"/>
       </p:ext>
     </p:extLst>
   </p:cSld>

</xml_diff>